<commit_message>
Calibrate slide typography and fill card layouts with rich content
</commit_message>
<xml_diff>
--- a/JalDrishti_SIH2026_Presentation_Final.pptx
+++ b/JalDrishti_SIH2026_Presentation_Final.pptx
@@ -3216,21 +3216,21 @@
           <a:noFill/>
         </p:spPr>
         <p:txBody>
-          <a:bodyPr wrap="square">
+          <a:bodyPr wrap="square" tIns="73152" bIns="73152">
             <a:spAutoFit/>
           </a:bodyPr>
           <a:lstStyle/>
           <a:p>
             <a:pPr>
               <a:spcAft>
-                <a:spcPts val="600"/>
+                <a:spcPts val="1100"/>
               </a:spcAft>
               <a:defRPr>
                 <a:latin typeface="Calibri"/>
               </a:defRPr>
             </a:pPr>
             <a:r>
-              <a:rPr sz="1350" b="1">
+              <a:rPr sz="1550" b="1">
                 <a:solidFill>
                   <a:srgbClr val="000000"/>
                 </a:solidFill>
@@ -3239,7 +3239,7 @@
               <a:t>•  Problem Statement ID – </a:t>
             </a:r>
             <a:r>
-              <a:rPr sz="1350" b="0">
+              <a:rPr sz="1500" b="0">
                 <a:solidFill>
                   <a:srgbClr val="1F2937"/>
                 </a:solidFill>
@@ -3251,11 +3251,11 @@
           <a:p>
             <a:pPr>
               <a:spcAft>
-                <a:spcPts val="600"/>
+                <a:spcPts val="1100"/>
               </a:spcAft>
             </a:pPr>
             <a:r>
-              <a:rPr sz="1350" b="1">
+              <a:rPr sz="1550" b="1">
                 <a:solidFill>
                   <a:srgbClr val="000000"/>
                 </a:solidFill>
@@ -3264,7 +3264,7 @@
               <a:t>•  Problem Statement Title – </a:t>
             </a:r>
             <a:r>
-              <a:rPr sz="1350" b="0">
+              <a:rPr sz="1500" b="0">
                 <a:solidFill>
                   <a:srgbClr val="1F2937"/>
                 </a:solidFill>
@@ -3276,11 +3276,11 @@
           <a:p>
             <a:pPr>
               <a:spcAft>
-                <a:spcPts val="600"/>
+                <a:spcPts val="1100"/>
               </a:spcAft>
             </a:pPr>
             <a:r>
-              <a:rPr sz="1350" b="1">
+              <a:rPr sz="1550" b="1">
                 <a:solidFill>
                   <a:srgbClr val="000000"/>
                 </a:solidFill>
@@ -3289,7 +3289,7 @@
               <a:t>•  Theme – </a:t>
             </a:r>
             <a:r>
-              <a:rPr sz="1350" b="0">
+              <a:rPr sz="1500" b="0">
                 <a:solidFill>
                   <a:srgbClr val="1F2937"/>
                 </a:solidFill>
@@ -3301,11 +3301,11 @@
           <a:p>
             <a:pPr>
               <a:spcAft>
-                <a:spcPts val="600"/>
+                <a:spcPts val="1100"/>
               </a:spcAft>
             </a:pPr>
             <a:r>
-              <a:rPr sz="1350" b="1">
+              <a:rPr sz="1550" b="1">
                 <a:solidFill>
                   <a:srgbClr val="000000"/>
                 </a:solidFill>
@@ -3314,7 +3314,7 @@
               <a:t>•  PS Category – </a:t>
             </a:r>
             <a:r>
-              <a:rPr sz="1350" b="0">
+              <a:rPr sz="1500" b="0">
                 <a:solidFill>
                   <a:srgbClr val="1F2937"/>
                 </a:solidFill>
@@ -3326,11 +3326,11 @@
           <a:p>
             <a:pPr>
               <a:spcAft>
-                <a:spcPts val="600"/>
+                <a:spcPts val="1100"/>
               </a:spcAft>
             </a:pPr>
             <a:r>
-              <a:rPr sz="1350" b="1">
+              <a:rPr sz="1550" b="1">
                 <a:solidFill>
                   <a:srgbClr val="000000"/>
                 </a:solidFill>
@@ -3339,7 +3339,7 @@
               <a:t>•  Team ID – </a:t>
             </a:r>
             <a:r>
-              <a:rPr sz="1350" b="0">
+              <a:rPr sz="1500" b="0">
                 <a:solidFill>
                   <a:srgbClr val="1F2937"/>
                 </a:solidFill>
@@ -3351,11 +3351,11 @@
           <a:p>
             <a:pPr>
               <a:spcAft>
-                <a:spcPts val="600"/>
+                <a:spcPts val="1100"/>
               </a:spcAft>
             </a:pPr>
             <a:r>
-              <a:rPr sz="1350" b="1">
+              <a:rPr sz="1550" b="1">
                 <a:solidFill>
                   <a:srgbClr val="000000"/>
                 </a:solidFill>
@@ -3364,7 +3364,7 @@
               <a:t>•  Team Name – </a:t>
             </a:r>
             <a:r>
-              <a:rPr sz="1350" b="0">
+              <a:rPr sz="1500" b="0">
                 <a:solidFill>
                   <a:srgbClr val="1F2937"/>
                 </a:solidFill>
@@ -3661,7 +3661,7 @@
           <a:noFill/>
         </p:spPr>
         <p:txBody>
-          <a:bodyPr wrap="square" lIns="36576" rIns="36576" tIns="36576" bIns="36576">
+          <a:bodyPr wrap="square" lIns="36576" rIns="36576" tIns="27432" bIns="27432">
             <a:spAutoFit/>
           </a:bodyPr>
           <a:lstStyle/>
@@ -3675,7 +3675,7 @@
               </a:defRPr>
             </a:pPr>
             <a:r>
-              <a:rPr sz="1800" b="1">
+              <a:rPr sz="2200" b="1">
                 <a:solidFill>
                   <a:srgbClr val="973835"/>
                 </a:solidFill>
@@ -3703,7 +3703,7 @@
           <a:noFill/>
         </p:spPr>
         <p:txBody>
-          <a:bodyPr wrap="square" lIns="36576" rIns="36576" tIns="36576" bIns="36576">
+          <a:bodyPr wrap="square" lIns="36576" rIns="36576" tIns="27432" bIns="27432">
             <a:spAutoFit/>
           </a:bodyPr>
           <a:lstStyle/>
@@ -3717,7 +3717,7 @@
               </a:defRPr>
             </a:pPr>
             <a:r>
-              <a:rPr sz="1000" b="0">
+              <a:rPr sz="1150" b="0">
                 <a:solidFill>
                   <a:srgbClr val="4B5563"/>
                 </a:solidFill>
@@ -3766,7 +3766,7 @@
           </a:fontRef>
         </p:style>
         <p:txBody>
-          <a:bodyPr rtlCol="0" anchor="ctr" wrap="square" lIns="36576" rIns="36576" tIns="36576" bIns="36576"/>
+          <a:bodyPr rtlCol="0" anchor="ctr" wrap="square" lIns="36576" rIns="36576" tIns="27432" bIns="27432"/>
           <a:lstStyle/>
           <a:p>
             <a:pPr algn="ctr">
@@ -3778,7 +3778,7 @@
               </a:defRPr>
             </a:pPr>
             <a:r>
-              <a:rPr sz="1100" b="1">
+              <a:rPr sz="1200" b="1">
                 <a:solidFill>
                   <a:srgbClr val="FFFFFF"/>
                 </a:solidFill>
@@ -3836,7 +3836,7 @@
           <a:lstStyle/>
           <a:p>
             <a:r>
-              <a:rPr sz="850" b="1">
+              <a:rPr sz="1000" b="1">
                 <a:solidFill>
                   <a:srgbClr val="1E3A8A"/>
                 </a:solidFill>
@@ -3845,7 +3845,7 @@
               <a:t>Full-Viewport Vector GIS: </a:t>
             </a:r>
             <a:r>
-              <a:rPr sz="720" b="0">
+              <a:rPr sz="880" b="0">
                 <a:solidFill>
                   <a:srgbClr val="1F2937"/>
                 </a:solidFill>
@@ -3903,7 +3903,7 @@
           <a:lstStyle/>
           <a:p>
             <a:r>
-              <a:rPr sz="850" b="1">
+              <a:rPr sz="1000" b="1">
                 <a:solidFill>
                   <a:srgbClr val="1E3A8A"/>
                 </a:solidFill>
@@ -3912,7 +3912,7 @@
               <a:t>AI Siting Optimizer: </a:t>
             </a:r>
             <a:r>
-              <a:rPr sz="720" b="0">
+              <a:rPr sz="880" b="0">
                 <a:solidFill>
                   <a:srgbClr val="1F2937"/>
                 </a:solidFill>
@@ -3970,7 +3970,7 @@
           <a:lstStyle/>
           <a:p>
             <a:r>
-              <a:rPr sz="850" b="1">
+              <a:rPr sz="1000" b="1">
                 <a:solidFill>
                   <a:srgbClr val="1E3A8A"/>
                 </a:solidFill>
@@ -3979,7 +3979,7 @@
               <a:t>Multi-Layer Neural Forensics: </a:t>
             </a:r>
             <a:r>
-              <a:rPr sz="720" b="0">
+              <a:rPr sz="880" b="0">
                 <a:solidFill>
                   <a:srgbClr val="1F2937"/>
                 </a:solidFill>
@@ -4037,7 +4037,7 @@
           <a:lstStyle/>
           <a:p>
             <a:r>
-              <a:rPr sz="850" b="1">
+              <a:rPr sz="1000" b="1">
                 <a:solidFill>
                   <a:srgbClr val="1E3A8A"/>
                 </a:solidFill>
@@ -4046,7 +4046,7 @@
               <a:t>Live IoT Mesh &amp; Satellite: </a:t>
             </a:r>
             <a:r>
-              <a:rPr sz="720" b="0">
+              <a:rPr sz="880" b="0">
                 <a:solidFill>
                   <a:srgbClr val="1F2937"/>
                 </a:solidFill>
@@ -4106,7 +4106,7 @@
                         </a:defRPr>
                       </a:pPr>
                       <a:r>
-                        <a:rPr sz="850" b="1">
+                        <a:rPr sz="950" b="1">
                           <a:solidFill>
                             <a:srgbClr val="973835"/>
                           </a:solidFill>
@@ -4136,7 +4136,7 @@
                         </a:defRPr>
                       </a:pPr>
                       <a:r>
-                        <a:rPr sz="850" b="1">
+                        <a:rPr sz="950" b="1">
                           <a:solidFill>
                             <a:srgbClr val="973835"/>
                           </a:solidFill>
@@ -4173,13 +4173,13 @@
                         </a:defRPr>
                       </a:pPr>
                       <a:r>
-                        <a:rPr sz="720" b="0">
+                        <a:rPr sz="819" b="0">
                           <a:solidFill>
                             <a:srgbClr val="1F2937"/>
                           </a:solidFill>
                           <a:latin typeface="Arial"/>
                         </a:rPr>
-                        <a:t>Unscientific Siting: Check-dams placed by guesswork, failing to recharge water</a:t>
+                        <a:t>Unscientific Siting: Check-dams placed by manual guesswork, failing to recharge water and prone to flash-flood washouts.</a:t>
                       </a:r>
                     </a:p>
                   </a:txBody>
@@ -4203,13 +4203,13 @@
                         </a:defRPr>
                       </a:pPr>
                       <a:r>
-                        <a:rPr sz="720" b="0">
+                        <a:rPr sz="819" b="0">
                           <a:solidFill>
                             <a:srgbClr val="973835"/>
                           </a:solidFill>
                           <a:latin typeface="Arial"/>
                         </a:rPr>
-                        <a:t>AI Siting Optimizer: Algorithmic DEM slope %, catchment area &amp; runoff calculation</a:t>
+                        <a:t>AI Siting Optimizer: Algorithmic DEM slope %, drainage convergence &amp; soil permeability scoring for 100% recharge efficacy.</a:t>
                       </a:r>
                     </a:p>
                   </a:txBody>
@@ -4240,13 +4240,13 @@
                         </a:defRPr>
                       </a:pPr>
                       <a:r>
-                        <a:rPr sz="720" b="0">
+                        <a:rPr sz="819" b="0">
                           <a:solidFill>
                             <a:srgbClr val="1F2937"/>
                           </a:solidFill>
                           <a:latin typeface="Arial"/>
                         </a:rPr>
-                        <a:t>Ghost Infrastructure: Re-used &amp; synthetic photos claim completion funds</a:t>
+                        <a:t>Ghost Infrastructure: Re-used &amp; synthetic photos claim milestone completion funds without genuine construction.</a:t>
                       </a:r>
                     </a:p>
                   </a:txBody>
@@ -4270,13 +4270,13 @@
                         </a:defRPr>
                       </a:pPr>
                       <a:r>
-                        <a:rPr sz="720" b="0">
+                        <a:rPr sz="819" b="0">
                           <a:solidFill>
                             <a:srgbClr val="973835"/>
                           </a:solidFill>
                           <a:latin typeface="Arial"/>
                         </a:rPr>
-                        <a:t>Multi-Layer Neural Forensics: CMOS Bayer noise &amp; EXIF integrity audit flags fake photos</a:t>
+                        <a:t>Multi-Layer Neural Forensics: CMOS Bayer noise &amp; EXIF integrity audit flags fraudulent &amp; AI-generated photos instantly.</a:t>
                       </a:r>
                     </a:p>
                   </a:txBody>
@@ -4307,13 +4307,13 @@
                         </a:defRPr>
                       </a:pPr>
                       <a:r>
-                        <a:rPr sz="720" b="0">
+                        <a:rPr sz="819" b="0">
                           <a:solidFill>
                             <a:srgbClr val="1F2937"/>
                           </a:solidFill>
                           <a:latin typeface="Arial"/>
                         </a:rPr>
-                        <a:t>30–60 Day Paper Delays: Field reports take months to reach Zilla Parishads</a:t>
+                        <a:t>30–60 Day Paper Delays: Field inspection reports take months to reach Zilla Parishads, delaying fund clearance.</a:t>
                       </a:r>
                     </a:p>
                   </a:txBody>
@@ -4337,13 +4337,13 @@
                         </a:defRPr>
                       </a:pPr>
                       <a:r>
-                        <a:rPr sz="720" b="0">
+                        <a:rPr sz="819" b="0">
                           <a:solidFill>
                             <a:srgbClr val="973835"/>
                           </a:solidFill>
                           <a:latin typeface="Arial"/>
                         </a:rPr>
-                        <a:t>Sub-Second IoT Telemetry: Real-time 4G/LoRaWAN groundwater depth &amp; silt alerts</a:t>
+                        <a:t>Sub-Second IoT Telemetry: Real-time 4G/LoRaWAN groundwater depth &amp; ultrasonic silt sensors trigger instant alerts.</a:t>
                       </a:r>
                     </a:p>
                   </a:txBody>
@@ -4374,13 +4374,13 @@
                         </a:defRPr>
                       </a:pPr>
                       <a:r>
-                        <a:rPr sz="720" b="0">
+                        <a:rPr sz="819" b="0">
                           <a:solidFill>
                             <a:srgbClr val="1F2937"/>
                           </a:solidFill>
                           <a:latin typeface="Arial"/>
                         </a:rPr>
-                        <a:t>Unmeasured Impact: Lack of pre/post monsoon vegetation &amp; water spread tracking</a:t>
+                        <a:t>Unmeasured Impact: Lack of long-term post-monsoon vegetation growth and surface water spread tracking.</a:t>
                       </a:r>
                     </a:p>
                   </a:txBody>
@@ -4404,13 +4404,13 @@
                         </a:defRPr>
                       </a:pPr>
                       <a:r>
-                        <a:rPr sz="720" b="0">
+                        <a:rPr sz="819" b="0">
                           <a:solidFill>
                             <a:srgbClr val="973835"/>
                           </a:solidFill>
                           <a:latin typeface="Arial"/>
                         </a:rPr>
-                        <a:t>Sentinel-2 Satellite Playback: 5-season multi-spectral NDVI &amp; NDWI analytics</a:t>
+                        <a:t>Sentinel-2 Satellite Playback: 5-season multi-spectral NDVI biomass &amp; NDWI water spread analytics over time.</a:t>
                       </a:r>
                     </a:p>
                   </a:txBody>
@@ -4512,7 +4512,7 @@
           </a:fontRef>
         </p:style>
         <p:txBody>
-          <a:bodyPr rtlCol="0" anchor="ctr" wrap="square" lIns="36576" rIns="36576" tIns="36576" bIns="36576"/>
+          <a:bodyPr rtlCol="0" anchor="ctr" wrap="square" lIns="36576" rIns="36576" tIns="27432" bIns="27432"/>
           <a:lstStyle/>
           <a:p>
             <a:pPr algn="ctr">
@@ -4524,7 +4524,7 @@
               </a:defRPr>
             </a:pPr>
             <a:r>
-              <a:rPr sz="780" b="1">
+              <a:rPr sz="850" b="1">
                 <a:solidFill>
                   <a:srgbClr val="FFFFFF"/>
                 </a:solidFill>
@@ -4557,7 +4557,10 @@
           </a:bodyPr>
           <a:lstStyle/>
           <a:p>
-            <a:pPr algn="ctr">
+            <a:pPr algn="l">
+              <a:spcAft>
+                <a:spcPts val="350"/>
+              </a:spcAft>
               <a:defRPr sz="1050">
                 <a:solidFill>
                   <a:srgbClr val="212529"/>
@@ -4566,13 +4569,61 @@
               </a:defRPr>
             </a:pPr>
             <a:r>
-              <a:rPr sz="680" b="0">
+              <a:rPr sz="800" b="0">
                 <a:solidFill>
                   <a:srgbClr val="1F2937"/>
                 </a:solidFill>
                 <a:latin typeface="Arial"/>
               </a:rPr>
-              <a:t>Sub-meter vector basin delineation &amp; Strahler 1st-3rd order stream classification</a:t>
+              <a:t>• Sub-meter vector basin delineation</a:t>
+            </a:r>
+          </a:p>
+          <a:p>
+            <a:pPr algn="l">
+              <a:spcAft>
+                <a:spcPts val="350"/>
+              </a:spcAft>
+            </a:pPr>
+            <a:r>
+              <a:rPr sz="800" b="0">
+                <a:solidFill>
+                  <a:srgbClr val="1F2937"/>
+                </a:solidFill>
+                <a:latin typeface="Arial"/>
+              </a:rPr>
+              <a:t>• Strahler 1st-3rd stream hierarchy</a:t>
+            </a:r>
+          </a:p>
+          <a:p>
+            <a:pPr algn="l">
+              <a:spcAft>
+                <a:spcPts val="350"/>
+              </a:spcAft>
+            </a:pPr>
+            <a:r>
+              <a:rPr sz="800" b="0">
+                <a:solidFill>
+                  <a:srgbClr val="1F2937"/>
+                </a:solidFill>
+                <a:latin typeface="Arial"/>
+              </a:rPr>
+              <a:t>• Topographical contour flow vectors</a:t>
+            </a:r>
+          </a:p>
+          <a:p>
+            <a:pPr algn="l">
+              <a:spcAft>
+                <a:spcPts val="350"/>
+              </a:spcAft>
+            </a:pPr>
+            <a:r>
+              <a:rPr sz="800" b="0">
+                <a:solidFill>
+                  <a:srgbClr val="1F2937"/>
+                </a:solidFill>
+                <a:latin typeface="Arial"/>
+              </a:rPr>
+              <a:t>• ISRO Bhuvan &amp; DEM layer sync</a:t>
             </a:r>
           </a:p>
         </p:txBody>
@@ -4659,7 +4710,7 @@
           </a:fontRef>
         </p:style>
         <p:txBody>
-          <a:bodyPr rtlCol="0" anchor="ctr" wrap="square" lIns="36576" rIns="36576" tIns="36576" bIns="36576"/>
+          <a:bodyPr rtlCol="0" anchor="ctr" wrap="square" lIns="36576" rIns="36576" tIns="27432" bIns="27432"/>
           <a:lstStyle/>
           <a:p>
             <a:pPr algn="ctr">
@@ -4671,7 +4722,7 @@
               </a:defRPr>
             </a:pPr>
             <a:r>
-              <a:rPr sz="780" b="1">
+              <a:rPr sz="850" b="1">
                 <a:solidFill>
                   <a:srgbClr val="FFFFFF"/>
                 </a:solidFill>
@@ -4704,7 +4755,10 @@
           </a:bodyPr>
           <a:lstStyle/>
           <a:p>
-            <a:pPr algn="ctr">
+            <a:pPr algn="l">
+              <a:spcAft>
+                <a:spcPts val="350"/>
+              </a:spcAft>
               <a:defRPr sz="1050">
                 <a:solidFill>
                   <a:srgbClr val="212529"/>
@@ -4713,13 +4767,61 @@
               </a:defRPr>
             </a:pPr>
             <a:r>
-              <a:rPr sz="680" b="0">
+              <a:rPr sz="800" b="0">
                 <a:solidFill>
                   <a:srgbClr val="1F2937"/>
                 </a:solidFill>
                 <a:latin typeface="Arial"/>
               </a:rPr>
-              <a:t>Algorithmic DEM slope %, drainage convergence &amp; water yield storage calculation</a:t>
+              <a:t>• Algorithmic 3%-12% slope gradient</a:t>
+            </a:r>
+          </a:p>
+          <a:p>
+            <a:pPr algn="l">
+              <a:spcAft>
+                <a:spcPts val="350"/>
+              </a:spcAft>
+            </a:pPr>
+            <a:r>
+              <a:rPr sz="800" b="0">
+                <a:solidFill>
+                  <a:srgbClr val="1F2937"/>
+                </a:solidFill>
+                <a:latin typeface="Arial"/>
+              </a:rPr>
+              <a:t>• SCS-CN seasonal runoff yield volume</a:t>
+            </a:r>
+          </a:p>
+          <a:p>
+            <a:pPr algn="l">
+              <a:spcAft>
+                <a:spcPts val="350"/>
+              </a:spcAft>
+            </a:pPr>
+            <a:r>
+              <a:rPr sz="800" b="0">
+                <a:solidFill>
+                  <a:srgbClr val="1F2937"/>
+                </a:solidFill>
+                <a:latin typeface="Arial"/>
+              </a:rPr>
+              <a:t>• Soil permeability &amp; aquifer recharge</a:t>
+            </a:r>
+          </a:p>
+          <a:p>
+            <a:pPr algn="l">
+              <a:spcAft>
+                <a:spcPts val="350"/>
+              </a:spcAft>
+            </a:pPr>
+            <a:r>
+              <a:rPr sz="800" b="0">
+                <a:solidFill>
+                  <a:srgbClr val="1F2937"/>
+                </a:solidFill>
+                <a:latin typeface="Arial"/>
+              </a:rPr>
+              <a:t>• Instant 0-100% suitability rating</a:t>
             </a:r>
           </a:p>
         </p:txBody>
@@ -4806,7 +4908,7 @@
           </a:fontRef>
         </p:style>
         <p:txBody>
-          <a:bodyPr rtlCol="0" anchor="ctr" wrap="square" lIns="36576" rIns="36576" tIns="36576" bIns="36576"/>
+          <a:bodyPr rtlCol="0" anchor="ctr" wrap="square" lIns="36576" rIns="36576" tIns="27432" bIns="27432"/>
           <a:lstStyle/>
           <a:p>
             <a:pPr algn="ctr">
@@ -4818,7 +4920,7 @@
               </a:defRPr>
             </a:pPr>
             <a:r>
-              <a:rPr sz="780" b="1">
+              <a:rPr sz="850" b="1">
                 <a:solidFill>
                   <a:srgbClr val="FFFFFF"/>
                 </a:solidFill>
@@ -4851,7 +4953,10 @@
           </a:bodyPr>
           <a:lstStyle/>
           <a:p>
-            <a:pPr algn="ctr">
+            <a:pPr algn="l">
+              <a:spcAft>
+                <a:spcPts val="350"/>
+              </a:spcAft>
               <a:defRPr sz="1050">
                 <a:solidFill>
                   <a:srgbClr val="212529"/>
@@ -4860,13 +4965,61 @@
               </a:defRPr>
             </a:pPr>
             <a:r>
-              <a:rPr sz="680" b="0">
+              <a:rPr sz="800" b="0">
                 <a:solidFill>
                   <a:srgbClr val="1F2937"/>
                 </a:solidFill>
                 <a:latin typeface="Arial"/>
               </a:rPr>
-              <a:t>Mobile geo-tagged photo capture with client-side SHA-256 hashing &amp; EXIF verification</a:t>
+              <a:t>• Mobile geo-tagged photo capture</a:t>
+            </a:r>
+          </a:p>
+          <a:p>
+            <a:pPr algn="l">
+              <a:spcAft>
+                <a:spcPts val="350"/>
+              </a:spcAft>
+            </a:pPr>
+            <a:r>
+              <a:rPr sz="800" b="0">
+                <a:solidFill>
+                  <a:srgbClr val="1F2937"/>
+                </a:solidFill>
+                <a:latin typeface="Arial"/>
+              </a:rPr>
+              <a:t>• Client-side SHA-256 tamper hash</a:t>
+            </a:r>
+          </a:p>
+          <a:p>
+            <a:pPr algn="l">
+              <a:spcAft>
+                <a:spcPts val="350"/>
+              </a:spcAft>
+            </a:pPr>
+            <a:r>
+              <a:rPr sz="800" b="0">
+                <a:solidFill>
+                  <a:srgbClr val="1F2937"/>
+                </a:solidFill>
+                <a:latin typeface="Arial"/>
+              </a:rPr>
+              <a:t>• Hardware EXIF &amp; GPS metadata lock</a:t>
+            </a:r>
+          </a:p>
+          <a:p>
+            <a:pPr algn="l">
+              <a:spcAft>
+                <a:spcPts val="350"/>
+              </a:spcAft>
+            </a:pPr>
+            <a:r>
+              <a:rPr sz="800" b="0">
+                <a:solidFill>
+                  <a:srgbClr val="1F2937"/>
+                </a:solidFill>
+                <a:latin typeface="Arial"/>
+              </a:rPr>
+              <a:t>• Offline-first local storage sync</a:t>
             </a:r>
           </a:p>
         </p:txBody>
@@ -4953,7 +5106,7 @@
           </a:fontRef>
         </p:style>
         <p:txBody>
-          <a:bodyPr rtlCol="0" anchor="ctr" wrap="square" lIns="36576" rIns="36576" tIns="36576" bIns="36576"/>
+          <a:bodyPr rtlCol="0" anchor="ctr" wrap="square" lIns="36576" rIns="36576" tIns="27432" bIns="27432"/>
           <a:lstStyle/>
           <a:p>
             <a:pPr algn="ctr">
@@ -4965,7 +5118,7 @@
               </a:defRPr>
             </a:pPr>
             <a:r>
-              <a:rPr sz="780" b="1">
+              <a:rPr sz="850" b="1">
                 <a:solidFill>
                   <a:srgbClr val="FFFFFF"/>
                 </a:solidFill>
@@ -4998,7 +5151,10 @@
           </a:bodyPr>
           <a:lstStyle/>
           <a:p>
-            <a:pPr algn="ctr">
+            <a:pPr algn="l">
+              <a:spcAft>
+                <a:spcPts val="350"/>
+              </a:spcAft>
               <a:defRPr sz="1050">
                 <a:solidFill>
                   <a:srgbClr val="212529"/>
@@ -5007,13 +5163,61 @@
               </a:defRPr>
             </a:pPr>
             <a:r>
-              <a:rPr sz="680" b="0">
+              <a:rPr sz="800" b="0">
                 <a:solidFill>
                   <a:srgbClr val="1F2937"/>
                 </a:solidFill>
                 <a:latin typeface="Arial"/>
               </a:rPr>
-              <a:t>CMOS sensor Bayer noise vs diffusion anomaly scan to verify genuine construction</a:t>
+              <a:t>• CMOS Bayer photon noise analysis</a:t>
+            </a:r>
+          </a:p>
+          <a:p>
+            <a:pPr algn="l">
+              <a:spcAft>
+                <a:spcPts val="350"/>
+              </a:spcAft>
+            </a:pPr>
+            <a:r>
+              <a:rPr sz="800" b="0">
+                <a:solidFill>
+                  <a:srgbClr val="1F2937"/>
+                </a:solidFill>
+                <a:latin typeface="Arial"/>
+              </a:rPr>
+              <a:t>• Optical diffusion anomaly detection</a:t>
+            </a:r>
+          </a:p>
+          <a:p>
+            <a:pPr algn="l">
+              <a:spcAft>
+                <a:spcPts val="350"/>
+              </a:spcAft>
+            </a:pPr>
+            <a:r>
+              <a:rPr sz="800" b="0">
+                <a:solidFill>
+                  <a:srgbClr val="1F2937"/>
+                </a:solidFill>
+                <a:latin typeface="Arial"/>
+              </a:rPr>
+              <a:t>• Forensic PRNU sensor fingerprint</a:t>
+            </a:r>
+          </a:p>
+          <a:p>
+            <a:pPr algn="l">
+              <a:spcAft>
+                <a:spcPts val="350"/>
+              </a:spcAft>
+            </a:pPr>
+            <a:r>
+              <a:rPr sz="800" b="0">
+                <a:solidFill>
+                  <a:srgbClr val="1F2937"/>
+                </a:solidFill>
+                <a:latin typeface="Arial"/>
+              </a:rPr>
+              <a:t>• Automated duplicate photo prevention</a:t>
             </a:r>
           </a:p>
         </p:txBody>
@@ -5100,7 +5304,7 @@
           </a:fontRef>
         </p:style>
         <p:txBody>
-          <a:bodyPr rtlCol="0" anchor="ctr" wrap="square" lIns="36576" rIns="36576" tIns="36576" bIns="36576"/>
+          <a:bodyPr rtlCol="0" anchor="ctr" wrap="square" lIns="36576" rIns="36576" tIns="27432" bIns="27432"/>
           <a:lstStyle/>
           <a:p>
             <a:pPr algn="ctr">
@@ -5112,7 +5316,7 @@
               </a:defRPr>
             </a:pPr>
             <a:r>
-              <a:rPr sz="780" b="1">
+              <a:rPr sz="850" b="1">
                 <a:solidFill>
                   <a:srgbClr val="FFFFFF"/>
                 </a:solidFill>
@@ -5145,7 +5349,10 @@
           </a:bodyPr>
           <a:lstStyle/>
           <a:p>
-            <a:pPr algn="ctr">
+            <a:pPr algn="l">
+              <a:spcAft>
+                <a:spcPts val="350"/>
+              </a:spcAft>
               <a:defRPr sz="1050">
                 <a:solidFill>
                   <a:srgbClr val="212529"/>
@@ -5154,13 +5361,61 @@
               </a:defRPr>
             </a:pPr>
             <a:r>
-              <a:rPr sz="680" b="0">
+              <a:rPr sz="800" b="0">
                 <a:solidFill>
                   <a:srgbClr val="1F2937"/>
                 </a:solidFill>
                 <a:latin typeface="Arial"/>
               </a:rPr>
-              <a:t>Automated cryptographic audit certificate for fund release + continuous LoRaWAN telemetry</a:t>
+              <a:t>• Cryptographic certificate fund trigger</a:t>
+            </a:r>
+          </a:p>
+          <a:p>
+            <a:pPr algn="l">
+              <a:spcAft>
+                <a:spcPts val="350"/>
+              </a:spcAft>
+            </a:pPr>
+            <a:r>
+              <a:rPr sz="800" b="0">
+                <a:solidFill>
+                  <a:srgbClr val="1F2937"/>
+                </a:solidFill>
+                <a:latin typeface="Arial"/>
+              </a:rPr>
+              <a:t>• Continuous LoRaWAN water telemetry</a:t>
+            </a:r>
+          </a:p>
+          <a:p>
+            <a:pPr algn="l">
+              <a:spcAft>
+                <a:spcPts val="350"/>
+              </a:spcAft>
+            </a:pPr>
+            <a:r>
+              <a:rPr sz="800" b="0">
+                <a:solidFill>
+                  <a:srgbClr val="1F2937"/>
+                </a:solidFill>
+                <a:latin typeface="Arial"/>
+              </a:rPr>
+              <a:t>• Real-time ultrasonic silt level alerts</a:t>
+            </a:r>
+          </a:p>
+          <a:p>
+            <a:pPr algn="l">
+              <a:spcAft>
+                <a:spcPts val="350"/>
+              </a:spcAft>
+            </a:pPr>
+            <a:r>
+              <a:rPr sz="800" b="0">
+                <a:solidFill>
+                  <a:srgbClr val="1F2937"/>
+                </a:solidFill>
+                <a:latin typeface="Arial"/>
+              </a:rPr>
+              <a:t>• Public Gram Panchayat audit dossier</a:t>
             </a:r>
           </a:p>
         </p:txBody>
@@ -5476,7 +5731,7 @@
           </a:fontRef>
         </p:style>
         <p:txBody>
-          <a:bodyPr wrap="square" tIns="36576" rtlCol="0" anchor="ctr" lIns="36576" rIns="36576" bIns="36576"/>
+          <a:bodyPr wrap="square" tIns="27432" rtlCol="0" anchor="ctr" lIns="36576" rIns="36576" bIns="27432"/>
           <a:lstStyle/>
           <a:p>
             <a:pPr algn="ctr">
@@ -5488,7 +5743,7 @@
               </a:defRPr>
             </a:pPr>
             <a:r>
-              <a:rPr sz="750" b="1">
+              <a:rPr sz="850" b="1">
                 <a:solidFill>
                   <a:srgbClr val="973835"/>
                 </a:solidFill>
@@ -5504,13 +5759,13 @@
               </a:spcBef>
             </a:pPr>
             <a:r>
-              <a:rPr sz="650" b="0">
+              <a:rPr sz="720" b="0">
                 <a:solidFill>
                   <a:srgbClr val="4B5563"/>
                 </a:solidFill>
                 <a:latin typeface="Arial"/>
               </a:rPr>
-              <a:t>GIS Command Center &amp; Field Web App</a:t>
+              <a:t>GIS Command Cockpit &amp; Field Mobile PWA</a:t>
             </a:r>
           </a:p>
         </p:txBody>
@@ -5553,7 +5808,7 @@
           </a:fontRef>
         </p:style>
         <p:txBody>
-          <a:bodyPr wrap="square" tIns="36576" rtlCol="0" anchor="ctr" lIns="36576" rIns="36576" bIns="36576"/>
+          <a:bodyPr wrap="square" tIns="27432" rtlCol="0" anchor="ctr" lIns="36576" rIns="36576" bIns="27432"/>
           <a:lstStyle/>
           <a:p>
             <a:pPr algn="ctr">
@@ -5565,7 +5820,7 @@
               </a:defRPr>
             </a:pPr>
             <a:r>
-              <a:rPr sz="750" b="1">
+              <a:rPr sz="850" b="1">
                 <a:solidFill>
                   <a:srgbClr val="973835"/>
                 </a:solidFill>
@@ -5581,13 +5836,13 @@
               </a:spcBef>
             </a:pPr>
             <a:r>
-              <a:rPr sz="650" b="0">
+              <a:rPr sz="720" b="0">
                 <a:solidFill>
                   <a:srgbClr val="4B5563"/>
                 </a:solidFill>
                 <a:latin typeface="Arial"/>
               </a:rPr>
-              <a:t>Sub-meter Vector Tile Hydrology Engine</a:t>
+              <a:t>Sub-Meter Vector Tile Hydrology Engine</a:t>
             </a:r>
           </a:p>
         </p:txBody>
@@ -5630,7 +5885,7 @@
           </a:fontRef>
         </p:style>
         <p:txBody>
-          <a:bodyPr wrap="square" tIns="36576" rtlCol="0" anchor="ctr" lIns="36576" rIns="36576" bIns="36576"/>
+          <a:bodyPr wrap="square" tIns="27432" rtlCol="0" anchor="ctr" lIns="36576" rIns="36576" bIns="27432"/>
           <a:lstStyle/>
           <a:p>
             <a:pPr algn="ctr">
@@ -5642,7 +5897,7 @@
               </a:defRPr>
             </a:pPr>
             <a:r>
-              <a:rPr sz="750" b="1">
+              <a:rPr sz="850" b="1">
                 <a:solidFill>
                   <a:srgbClr val="973835"/>
                 </a:solidFill>
@@ -5658,13 +5913,13 @@
               </a:spcBef>
             </a:pPr>
             <a:r>
-              <a:rPr sz="650" b="0">
+              <a:rPr sz="720" b="0">
                 <a:solidFill>
                   <a:srgbClr val="4B5563"/>
                 </a:solidFill>
                 <a:latin typeface="Arial"/>
               </a:rPr>
-              <a:t>Interactive GIS Layers &amp; Telemetry Charts</a:t>
+              <a:t>Interactive GIS Layers &amp; Live Telemetry</a:t>
             </a:r>
           </a:p>
         </p:txBody>
@@ -5707,7 +5962,7 @@
           </a:fontRef>
         </p:style>
         <p:txBody>
-          <a:bodyPr wrap="square" tIns="36576" rtlCol="0" anchor="ctr" lIns="36576" rIns="36576" bIns="36576"/>
+          <a:bodyPr wrap="square" tIns="27432" rtlCol="0" anchor="ctr" lIns="36576" rIns="36576" bIns="27432"/>
           <a:lstStyle/>
           <a:p>
             <a:pPr algn="ctr">
@@ -5719,7 +5974,7 @@
               </a:defRPr>
             </a:pPr>
             <a:r>
-              <a:rPr sz="750" b="1">
+              <a:rPr sz="850" b="1">
                 <a:solidFill>
                   <a:srgbClr val="973835"/>
                 </a:solidFill>
@@ -5735,13 +5990,13 @@
               </a:spcBef>
             </a:pPr>
             <a:r>
-              <a:rPr sz="650" b="0">
+              <a:rPr sz="720" b="0">
                 <a:solidFill>
                   <a:srgbClr val="4B5563"/>
                 </a:solidFill>
                 <a:latin typeface="Arial"/>
               </a:rPr>
-              <a:t>CMOS Bayer Noise &amp; Tamper Detection</a:t>
+              <a:t>CMOS Bayer Sensor Noise &amp; Forensics Engine</a:t>
             </a:r>
           </a:p>
         </p:txBody>
@@ -5784,7 +6039,7 @@
           </a:fontRef>
         </p:style>
         <p:txBody>
-          <a:bodyPr wrap="square" tIns="36576" rtlCol="0" anchor="ctr" lIns="36576" rIns="36576" bIns="36576"/>
+          <a:bodyPr wrap="square" tIns="27432" rtlCol="0" anchor="ctr" lIns="36576" rIns="36576" bIns="27432"/>
           <a:lstStyle/>
           <a:p>
             <a:pPr algn="ctr">
@@ -5796,7 +6051,7 @@
               </a:defRPr>
             </a:pPr>
             <a:r>
-              <a:rPr sz="750" b="1">
+              <a:rPr sz="850" b="1">
                 <a:solidFill>
                   <a:srgbClr val="973835"/>
                 </a:solidFill>
@@ -5812,13 +6067,13 @@
               </a:spcBef>
             </a:pPr>
             <a:r>
-              <a:rPr sz="650" b="0">
+              <a:rPr sz="720" b="0">
                 <a:solidFill>
                   <a:srgbClr val="4B5563"/>
                 </a:solidFill>
                 <a:latin typeface="Arial"/>
               </a:rPr>
-              <a:t>Automated SCS-CN Runoff &amp; Siting Formula</a:t>
+              <a:t>Automated SCS-CN Runoff &amp; Siting Algorithm</a:t>
             </a:r>
           </a:p>
         </p:txBody>
@@ -5861,7 +6116,7 @@
           </a:fontRef>
         </p:style>
         <p:txBody>
-          <a:bodyPr wrap="square" tIns="36576" rtlCol="0" anchor="ctr" lIns="36576" rIns="36576" bIns="36576"/>
+          <a:bodyPr wrap="square" tIns="27432" rtlCol="0" anchor="ctr" lIns="36576" rIns="36576" bIns="27432"/>
           <a:lstStyle/>
           <a:p>
             <a:pPr algn="ctr">
@@ -5873,7 +6128,7 @@
               </a:defRPr>
             </a:pPr>
             <a:r>
-              <a:rPr sz="750" b="1">
+              <a:rPr sz="850" b="1">
                 <a:solidFill>
                   <a:srgbClr val="973835"/>
                 </a:solidFill>
@@ -5889,7 +6144,7 @@
               </a:spcBef>
             </a:pPr>
             <a:r>
-              <a:rPr sz="650" b="0">
+              <a:rPr sz="720" b="0">
                 <a:solidFill>
                   <a:srgbClr val="4B5563"/>
                 </a:solidFill>
@@ -5938,7 +6193,7 @@
           </a:fontRef>
         </p:style>
         <p:txBody>
-          <a:bodyPr wrap="square" tIns="36576" rtlCol="0" anchor="ctr" lIns="36576" rIns="36576" bIns="36576"/>
+          <a:bodyPr wrap="square" tIns="27432" rtlCol="0" anchor="ctr" lIns="36576" rIns="36576" bIns="27432"/>
           <a:lstStyle/>
           <a:p>
             <a:pPr algn="ctr">
@@ -5950,7 +6205,7 @@
               </a:defRPr>
             </a:pPr>
             <a:r>
-              <a:rPr sz="750" b="1">
+              <a:rPr sz="850" b="1">
                 <a:solidFill>
                   <a:srgbClr val="973835"/>
                 </a:solidFill>
@@ -5966,7 +6221,7 @@
               </a:spcBef>
             </a:pPr>
             <a:r>
-              <a:rPr sz="650" b="0">
+              <a:rPr sz="720" b="0">
                 <a:solidFill>
                   <a:srgbClr val="4B5563"/>
                 </a:solidFill>
@@ -6015,7 +6270,7 @@
           </a:fontRef>
         </p:style>
         <p:txBody>
-          <a:bodyPr wrap="square" tIns="36576" rtlCol="0" anchor="ctr" lIns="36576" rIns="36576" bIns="36576"/>
+          <a:bodyPr wrap="square" tIns="27432" rtlCol="0" anchor="ctr" lIns="36576" rIns="36576" bIns="27432"/>
           <a:lstStyle/>
           <a:p>
             <a:pPr algn="ctr">
@@ -6027,7 +6282,7 @@
               </a:defRPr>
             </a:pPr>
             <a:r>
-              <a:rPr sz="750" b="1">
+              <a:rPr sz="850" b="1">
                 <a:solidFill>
                   <a:srgbClr val="973835"/>
                 </a:solidFill>
@@ -6043,7 +6298,7 @@
               </a:spcBef>
             </a:pPr>
             <a:r>
-              <a:rPr sz="650" b="0">
+              <a:rPr sz="720" b="0">
                 <a:solidFill>
                   <a:srgbClr val="4B5563"/>
                 </a:solidFill>
@@ -6136,7 +6391,7 @@
           </a:fontRef>
         </p:style>
         <p:txBody>
-          <a:bodyPr rtlCol="0" anchor="ctr" wrap="square" lIns="36576" rIns="36576" tIns="36576" bIns="36576"/>
+          <a:bodyPr rtlCol="0" anchor="ctr" wrap="square" lIns="36576" rIns="36576" tIns="27432" bIns="27432"/>
           <a:lstStyle/>
           <a:p>
             <a:pPr algn="l">
@@ -6148,7 +6403,7 @@
               </a:defRPr>
             </a:pPr>
             <a:r>
-              <a:rPr sz="850" b="1">
+              <a:rPr sz="919" b="1">
                 <a:solidFill>
                   <a:srgbClr val="FFFFFF"/>
                 </a:solidFill>
@@ -6197,10 +6452,13 @@
           </a:fontRef>
         </p:style>
         <p:txBody>
-          <a:bodyPr wrap="square" rtlCol="0" anchor="ctr" lIns="36576" rIns="36576" tIns="36576" bIns="36576"/>
+          <a:bodyPr wrap="square" rtlCol="0" anchor="ctr" lIns="27432" rIns="27432" tIns="27432" bIns="27432"/>
           <a:lstStyle/>
           <a:p>
             <a:pPr algn="ctr">
+              <a:spcAft>
+                <a:spcPts val="200"/>
+              </a:spcAft>
               <a:defRPr sz="1100" b="1">
                 <a:solidFill>
                   <a:srgbClr val="235FAF"/>
@@ -6209,7 +6467,7 @@
               </a:defRPr>
             </a:pPr>
             <a:r>
-              <a:rPr sz="720" b="1">
+              <a:rPr sz="819" b="1">
                 <a:solidFill>
                   <a:srgbClr val="1E3A8A"/>
                 </a:solidFill>
@@ -6220,18 +6478,50 @@
           </a:p>
           <a:p>
             <a:pPr algn="ctr">
-              <a:spcBef>
-                <a:spcPts val="200"/>
-              </a:spcBef>
-            </a:pPr>
-            <a:r>
-              <a:rPr sz="620" b="0">
+              <a:spcAft>
+                <a:spcPts val="150"/>
+              </a:spcAft>
+            </a:pPr>
+            <a:r>
+              <a:rPr sz="700" b="0">
                 <a:solidFill>
                   <a:srgbClr val="1F2937"/>
                 </a:solidFill>
                 <a:latin typeface="Arial"/>
               </a:rPr>
-              <a:t>Sub-meter polygon delineation &amp; Strahler 1st-3rd order stream hierarchy classification</a:t>
+              <a:t>• Sub-meter vector basin polygon mapping</a:t>
+            </a:r>
+          </a:p>
+          <a:p>
+            <a:pPr algn="ctr">
+              <a:spcAft>
+                <a:spcPts val="150"/>
+              </a:spcAft>
+            </a:pPr>
+            <a:r>
+              <a:rPr sz="700" b="0">
+                <a:solidFill>
+                  <a:srgbClr val="1F2937"/>
+                </a:solidFill>
+                <a:latin typeface="Arial"/>
+              </a:rPr>
+              <a:t>• Strahler 1st-3rd stream hierarchy</a:t>
+            </a:r>
+          </a:p>
+          <a:p>
+            <a:pPr algn="ctr">
+              <a:spcAft>
+                <a:spcPts val="150"/>
+              </a:spcAft>
+            </a:pPr>
+            <a:r>
+              <a:rPr sz="700" b="0">
+                <a:solidFill>
+                  <a:srgbClr val="1F2937"/>
+                </a:solidFill>
+                <a:latin typeface="Arial"/>
+              </a:rPr>
+              <a:t>• Multi-source elevation data fusion</a:t>
             </a:r>
           </a:p>
         </p:txBody>
@@ -6274,10 +6564,13 @@
           </a:fontRef>
         </p:style>
         <p:txBody>
-          <a:bodyPr wrap="square" rtlCol="0" anchor="ctr" lIns="36576" rIns="36576" tIns="36576" bIns="36576"/>
+          <a:bodyPr wrap="square" rtlCol="0" anchor="ctr" lIns="27432" rIns="27432" tIns="27432" bIns="27432"/>
           <a:lstStyle/>
           <a:p>
             <a:pPr algn="ctr">
+              <a:spcAft>
+                <a:spcPts val="200"/>
+              </a:spcAft>
               <a:defRPr sz="1100" b="1">
                 <a:solidFill>
                   <a:srgbClr val="235FAF"/>
@@ -6286,7 +6579,7 @@
               </a:defRPr>
             </a:pPr>
             <a:r>
-              <a:rPr sz="720" b="1">
+              <a:rPr sz="819" b="1">
                 <a:solidFill>
                   <a:srgbClr val="1E3A8A"/>
                 </a:solidFill>
@@ -6297,18 +6590,50 @@
           </a:p>
           <a:p>
             <a:pPr algn="ctr">
-              <a:spcBef>
-                <a:spcPts val="200"/>
-              </a:spcBef>
-            </a:pPr>
-            <a:r>
-              <a:rPr sz="620" b="0">
+              <a:spcAft>
+                <a:spcPts val="150"/>
+              </a:spcAft>
+            </a:pPr>
+            <a:r>
+              <a:rPr sz="700" b="0">
                 <a:solidFill>
                   <a:srgbClr val="1F2937"/>
                 </a:solidFill>
                 <a:latin typeface="Arial"/>
               </a:rPr>
-              <a:t>Automated DEM slope contour calculation (ideal 3%-12% for masonry check-dams)</a:t>
+              <a:t>• Automated DEM contour slope calculation</a:t>
+            </a:r>
+          </a:p>
+          <a:p>
+            <a:pPr algn="ctr">
+              <a:spcAft>
+                <a:spcPts val="150"/>
+              </a:spcAft>
+            </a:pPr>
+            <a:r>
+              <a:rPr sz="700" b="0">
+                <a:solidFill>
+                  <a:srgbClr val="1F2937"/>
+                </a:solidFill>
+                <a:latin typeface="Arial"/>
+              </a:rPr>
+              <a:t>• Identifies ideal 3%-12% check-dam slope</a:t>
+            </a:r>
+          </a:p>
+          <a:p>
+            <a:pPr algn="ctr">
+              <a:spcAft>
+                <a:spcPts val="150"/>
+              </a:spcAft>
+            </a:pPr>
+            <a:r>
+              <a:rPr sz="700" b="0">
+                <a:solidFill>
+                  <a:srgbClr val="1F2937"/>
+                </a:solidFill>
+                <a:latin typeface="Arial"/>
+              </a:rPr>
+              <a:t>• Prevents foundation erosion &amp; collapse</a:t>
             </a:r>
           </a:p>
         </p:txBody>
@@ -6351,10 +6676,13 @@
           </a:fontRef>
         </p:style>
         <p:txBody>
-          <a:bodyPr wrap="square" rtlCol="0" anchor="ctr" lIns="36576" rIns="36576" tIns="36576" bIns="36576"/>
+          <a:bodyPr wrap="square" rtlCol="0" anchor="ctr" lIns="27432" rIns="27432" tIns="27432" bIns="27432"/>
           <a:lstStyle/>
           <a:p>
             <a:pPr algn="ctr">
+              <a:spcAft>
+                <a:spcPts val="200"/>
+              </a:spcAft>
               <a:defRPr sz="1100" b="1">
                 <a:solidFill>
                   <a:srgbClr val="235FAF"/>
@@ -6363,7 +6691,7 @@
               </a:defRPr>
             </a:pPr>
             <a:r>
-              <a:rPr sz="720" b="1">
+              <a:rPr sz="819" b="1">
                 <a:solidFill>
                   <a:srgbClr val="1E3A8A"/>
                 </a:solidFill>
@@ -6374,18 +6702,50 @@
           </a:p>
           <a:p>
             <a:pPr algn="ctr">
-              <a:spcBef>
-                <a:spcPts val="200"/>
-              </a:spcBef>
-            </a:pPr>
-            <a:r>
-              <a:rPr sz="620" b="0">
+              <a:spcAft>
+                <a:spcPts val="150"/>
+              </a:spcAft>
+            </a:pPr>
+            <a:r>
+              <a:rPr sz="700" b="0">
                 <a:solidFill>
                   <a:srgbClr val="1F2937"/>
                 </a:solidFill>
                 <a:latin typeface="Arial"/>
               </a:rPr>
-              <a:t>Estimates potential maximum soil water retention and seasonal runoff yield volume</a:t>
+              <a:t>• Estimates max potential soil retention</a:t>
+            </a:r>
+          </a:p>
+          <a:p>
+            <a:pPr algn="ctr">
+              <a:spcAft>
+                <a:spcPts val="150"/>
+              </a:spcAft>
+            </a:pPr>
+            <a:r>
+              <a:rPr sz="700" b="0">
+                <a:solidFill>
+                  <a:srgbClr val="1F2937"/>
+                </a:solidFill>
+                <a:latin typeface="Arial"/>
+              </a:rPr>
+              <a:t>• Computes seasonal runoff yield volume</a:t>
+            </a:r>
+          </a:p>
+          <a:p>
+            <a:pPr algn="ctr">
+              <a:spcAft>
+                <a:spcPts val="150"/>
+              </a:spcAft>
+            </a:pPr>
+            <a:r>
+              <a:rPr sz="700" b="0">
+                <a:solidFill>
+                  <a:srgbClr val="1F2937"/>
+                </a:solidFill>
+                <a:latin typeface="Arial"/>
+              </a:rPr>
+              <a:t>• Calculates peak monsoon water capacity</a:t>
             </a:r>
           </a:p>
         </p:txBody>
@@ -6428,10 +6788,13 @@
           </a:fontRef>
         </p:style>
         <p:txBody>
-          <a:bodyPr wrap="square" rtlCol="0" anchor="ctr" lIns="36576" rIns="36576" tIns="36576" bIns="36576"/>
+          <a:bodyPr wrap="square" rtlCol="0" anchor="ctr" lIns="27432" rIns="27432" tIns="27432" bIns="27432"/>
           <a:lstStyle/>
           <a:p>
             <a:pPr algn="ctr">
+              <a:spcAft>
+                <a:spcPts val="200"/>
+              </a:spcAft>
               <a:defRPr sz="1100" b="1">
                 <a:solidFill>
                   <a:srgbClr val="235FAF"/>
@@ -6440,7 +6803,7 @@
               </a:defRPr>
             </a:pPr>
             <a:r>
-              <a:rPr sz="720" b="1">
+              <a:rPr sz="819" b="1">
                 <a:solidFill>
                   <a:srgbClr val="1E3A8A"/>
                 </a:solidFill>
@@ -6451,18 +6814,50 @@
           </a:p>
           <a:p>
             <a:pPr algn="ctr">
-              <a:spcBef>
-                <a:spcPts val="200"/>
-              </a:spcBef>
-            </a:pPr>
-            <a:r>
-              <a:rPr sz="620" b="0">
+              <a:spcAft>
+                <a:spcPts val="150"/>
+              </a:spcAft>
+            </a:pPr>
+            <a:r>
+              <a:rPr sz="700" b="0">
                 <a:solidFill>
                   <a:srgbClr val="1F2937"/>
                 </a:solidFill>
                 <a:latin typeface="Arial"/>
               </a:rPr>
-              <a:t>Instant 0-100% suitability score + recommended hydraulic structure &amp; capacity</a:t>
+              <a:t>• Instant 0-100% suitability rating score</a:t>
+            </a:r>
+          </a:p>
+          <a:p>
+            <a:pPr algn="ctr">
+              <a:spcAft>
+                <a:spcPts val="150"/>
+              </a:spcAft>
+            </a:pPr>
+            <a:r>
+              <a:rPr sz="700" b="0">
+                <a:solidFill>
+                  <a:srgbClr val="1F2937"/>
+                </a:solidFill>
+                <a:latin typeface="Arial"/>
+              </a:rPr>
+              <a:t>• Optimal check-dam dimension &amp; masonry</a:t>
+            </a:r>
+          </a:p>
+          <a:p>
+            <a:pPr algn="ctr">
+              <a:spcAft>
+                <a:spcPts val="150"/>
+              </a:spcAft>
+            </a:pPr>
+            <a:r>
+              <a:rPr sz="700" b="0">
+                <a:solidFill>
+                  <a:srgbClr val="1F2937"/>
+                </a:solidFill>
+                <a:latin typeface="Arial"/>
+              </a:rPr>
+              <a:t>• Recommends water storage capacity</a:t>
             </a:r>
           </a:p>
         </p:txBody>
@@ -6549,7 +6944,7 @@
           </a:fontRef>
         </p:style>
         <p:txBody>
-          <a:bodyPr rtlCol="0" anchor="ctr" wrap="square" lIns="36576" rIns="36576" tIns="36576" bIns="36576"/>
+          <a:bodyPr rtlCol="0" anchor="ctr" wrap="square" lIns="36576" rIns="36576" tIns="27432" bIns="27432"/>
           <a:lstStyle/>
           <a:p>
             <a:pPr algn="l">
@@ -6561,7 +6956,7 @@
               </a:defRPr>
             </a:pPr>
             <a:r>
-              <a:rPr sz="850" b="1">
+              <a:rPr sz="919" b="1">
                 <a:solidFill>
                   <a:srgbClr val="FFFFFF"/>
                 </a:solidFill>
@@ -6610,10 +7005,13 @@
           </a:fontRef>
         </p:style>
         <p:txBody>
-          <a:bodyPr wrap="square" rtlCol="0" anchor="ctr" lIns="36576" rIns="36576" tIns="36576" bIns="36576"/>
+          <a:bodyPr wrap="square" rtlCol="0" anchor="ctr" lIns="27432" rIns="27432" tIns="27432" bIns="27432"/>
           <a:lstStyle/>
           <a:p>
             <a:pPr algn="ctr">
+              <a:spcAft>
+                <a:spcPts val="200"/>
+              </a:spcAft>
               <a:defRPr sz="1100" b="1">
                 <a:solidFill>
                   <a:srgbClr val="238741"/>
@@ -6622,7 +7020,7 @@
               </a:defRPr>
             </a:pPr>
             <a:r>
-              <a:rPr sz="720" b="1">
+              <a:rPr sz="819" b="1">
                 <a:solidFill>
                   <a:srgbClr val="14532D"/>
                 </a:solidFill>
@@ -6633,18 +7031,50 @@
           </a:p>
           <a:p>
             <a:pPr algn="ctr">
-              <a:spcBef>
-                <a:spcPts val="200"/>
-              </a:spcBef>
-            </a:pPr>
-            <a:r>
-              <a:rPr sz="620" b="0">
+              <a:spcAft>
+                <a:spcPts val="150"/>
+              </a:spcAft>
+            </a:pPr>
+            <a:r>
+              <a:rPr sz="700" b="0">
                 <a:solidFill>
                   <a:srgbClr val="1F2937"/>
                 </a:solidFill>
                 <a:latin typeface="Arial"/>
               </a:rPr>
-              <a:t>Evaluates high-frequency CMOS photon noise variance to distinguish real cameras from AI</a:t>
+              <a:t>• High-frequency CMOS photon noise audit</a:t>
+            </a:r>
+          </a:p>
+          <a:p>
+            <a:pPr algn="ctr">
+              <a:spcAft>
+                <a:spcPts val="150"/>
+              </a:spcAft>
+            </a:pPr>
+            <a:r>
+              <a:rPr sz="700" b="0">
+                <a:solidFill>
+                  <a:srgbClr val="1F2937"/>
+                </a:solidFill>
+                <a:latin typeface="Arial"/>
+              </a:rPr>
+              <a:t>• Extracts PRNU sensor fingerprint</a:t>
+            </a:r>
+          </a:p>
+          <a:p>
+            <a:pPr algn="ctr">
+              <a:spcAft>
+                <a:spcPts val="150"/>
+              </a:spcAft>
+            </a:pPr>
+            <a:r>
+              <a:rPr sz="700" b="0">
+                <a:solidFill>
+                  <a:srgbClr val="1F2937"/>
+                </a:solidFill>
+                <a:latin typeface="Arial"/>
+              </a:rPr>
+              <a:t>• Distinguishes real cameras from AI</a:t>
             </a:r>
           </a:p>
         </p:txBody>
@@ -6687,10 +7117,13 @@
           </a:fontRef>
         </p:style>
         <p:txBody>
-          <a:bodyPr wrap="square" rtlCol="0" anchor="ctr" lIns="36576" rIns="36576" tIns="36576" bIns="36576"/>
+          <a:bodyPr wrap="square" rtlCol="0" anchor="ctr" lIns="27432" rIns="27432" tIns="27432" bIns="27432"/>
           <a:lstStyle/>
           <a:p>
             <a:pPr algn="ctr">
+              <a:spcAft>
+                <a:spcPts val="200"/>
+              </a:spcAft>
               <a:defRPr sz="1100" b="1">
                 <a:solidFill>
                   <a:srgbClr val="238741"/>
@@ -6699,7 +7132,7 @@
               </a:defRPr>
             </a:pPr>
             <a:r>
-              <a:rPr sz="720" b="1">
+              <a:rPr sz="819" b="1">
                 <a:solidFill>
                   <a:srgbClr val="14532D"/>
                 </a:solidFill>
@@ -6710,18 +7143,50 @@
           </a:p>
           <a:p>
             <a:pPr algn="ctr">
-              <a:spcBef>
-                <a:spcPts val="200"/>
-              </a:spcBef>
-            </a:pPr>
-            <a:r>
-              <a:rPr sz="620" b="0">
+              <a:spcAft>
+                <a:spcPts val="150"/>
+              </a:spcAft>
+            </a:pPr>
+            <a:r>
+              <a:rPr sz="700" b="0">
                 <a:solidFill>
                   <a:srgbClr val="1F2937"/>
                 </a:solidFill>
                 <a:latin typeface="Arial"/>
               </a:rPr>
-              <a:t>Verifies GPS coordinates, timestamp integrity, and camera hardware lens signatures</a:t>
+              <a:t>• Validates GPS timestamp &amp; focal length</a:t>
+            </a:r>
+          </a:p>
+          <a:p>
+            <a:pPr algn="ctr">
+              <a:spcAft>
+                <a:spcPts val="150"/>
+              </a:spcAft>
+            </a:pPr>
+            <a:r>
+              <a:rPr sz="700" b="0">
+                <a:solidFill>
+                  <a:srgbClr val="1F2937"/>
+                </a:solidFill>
+                <a:latin typeface="Arial"/>
+              </a:rPr>
+              <a:t>• SHA-256 tamper-proof payload digest</a:t>
+            </a:r>
+          </a:p>
+          <a:p>
+            <a:pPr algn="ctr">
+              <a:spcAft>
+                <a:spcPts val="150"/>
+              </a:spcAft>
+            </a:pPr>
+            <a:r>
+              <a:rPr sz="700" b="0">
+                <a:solidFill>
+                  <a:srgbClr val="1F2937"/>
+                </a:solidFill>
+                <a:latin typeface="Arial"/>
+              </a:rPr>
+              <a:t>• Cross-checks hardware lens signature</a:t>
             </a:r>
           </a:p>
         </p:txBody>
@@ -6764,10 +7229,13 @@
           </a:fontRef>
         </p:style>
         <p:txBody>
-          <a:bodyPr wrap="square" rtlCol="0" anchor="ctr" lIns="36576" rIns="36576" tIns="36576" bIns="36576"/>
+          <a:bodyPr wrap="square" rtlCol="0" anchor="ctr" lIns="27432" rIns="27432" tIns="27432" bIns="27432"/>
           <a:lstStyle/>
           <a:p>
             <a:pPr algn="ctr">
+              <a:spcAft>
+                <a:spcPts val="200"/>
+              </a:spcAft>
               <a:defRPr sz="1100" b="1">
                 <a:solidFill>
                   <a:srgbClr val="238741"/>
@@ -6776,7 +7244,7 @@
               </a:defRPr>
             </a:pPr>
             <a:r>
-              <a:rPr sz="720" b="1">
+              <a:rPr sz="819" b="1">
                 <a:solidFill>
                   <a:srgbClr val="14532D"/>
                 </a:solidFill>
@@ -6787,18 +7255,50 @@
           </a:p>
           <a:p>
             <a:pPr algn="ctr">
-              <a:spcBef>
-                <a:spcPts val="200"/>
-              </a:spcBef>
-            </a:pPr>
-            <a:r>
-              <a:rPr sz="620" b="0">
+              <a:spcAft>
+                <a:spcPts val="150"/>
+              </a:spcAft>
+            </a:pPr>
+            <a:r>
+              <a:rPr sz="700" b="0">
                 <a:solidFill>
                   <a:srgbClr val="1F2937"/>
                 </a:solidFill>
                 <a:latin typeface="Arial"/>
               </a:rPr>
-              <a:t>Solar Micro-RTU probes deliver continuous groundwater depth, siltation %, and soil moisture</a:t>
+              <a:t>• Solar Micro-RTU submerged sensor probes</a:t>
+            </a:r>
+          </a:p>
+          <a:p>
+            <a:pPr algn="ctr">
+              <a:spcAft>
+                <a:spcPts val="150"/>
+              </a:spcAft>
+            </a:pPr>
+            <a:r>
+              <a:rPr sz="700" b="0">
+                <a:solidFill>
+                  <a:srgbClr val="1F2937"/>
+                </a:solidFill>
+                <a:latin typeface="Arial"/>
+              </a:rPr>
+              <a:t>• Sub-second groundwater elevation tracking</a:t>
+            </a:r>
+          </a:p>
+          <a:p>
+            <a:pPr algn="ctr">
+              <a:spcAft>
+                <a:spcPts val="150"/>
+              </a:spcAft>
+            </a:pPr>
+            <a:r>
+              <a:rPr sz="700" b="0">
+                <a:solidFill>
+                  <a:srgbClr val="1F2937"/>
+                </a:solidFill>
+                <a:latin typeface="Arial"/>
+              </a:rPr>
+              <a:t>• Ultrasonic silt level &amp; soil moisture alerts</a:t>
             </a:r>
           </a:p>
         </p:txBody>
@@ -6841,10 +7341,13 @@
           </a:fontRef>
         </p:style>
         <p:txBody>
-          <a:bodyPr wrap="square" rtlCol="0" anchor="ctr" lIns="36576" rIns="36576" tIns="36576" bIns="36576"/>
+          <a:bodyPr wrap="square" rtlCol="0" anchor="ctr" lIns="27432" rIns="27432" tIns="27432" bIns="27432"/>
           <a:lstStyle/>
           <a:p>
             <a:pPr algn="ctr">
+              <a:spcAft>
+                <a:spcPts val="200"/>
+              </a:spcAft>
               <a:defRPr sz="1100" b="1">
                 <a:solidFill>
                   <a:srgbClr val="238741"/>
@@ -6853,7 +7356,7 @@
               </a:defRPr>
             </a:pPr>
             <a:r>
-              <a:rPr sz="720" b="1">
+              <a:rPr sz="819" b="1">
                 <a:solidFill>
                   <a:srgbClr val="14532D"/>
                 </a:solidFill>
@@ -6864,18 +7367,50 @@
           </a:p>
           <a:p>
             <a:pPr algn="ctr">
-              <a:spcBef>
-                <a:spcPts val="200"/>
-              </a:spcBef>
-            </a:pPr>
-            <a:r>
-              <a:rPr sz="620" b="0">
+              <a:spcAft>
+                <a:spcPts val="150"/>
+              </a:spcAft>
+            </a:pPr>
+            <a:r>
+              <a:rPr sz="700" b="0">
                 <a:solidFill>
                   <a:srgbClr val="1F2937"/>
                 </a:solidFill>
                 <a:latin typeface="Arial"/>
               </a:rPr>
-              <a:t>Multi-spectral 5-season timeline tracking NDVI biomass gain and NDWI water spread</a:t>
+              <a:t>• Sentinel-2 MSI 10m multi-spectral imagery</a:t>
+            </a:r>
+          </a:p>
+          <a:p>
+            <a:pPr algn="ctr">
+              <a:spcAft>
+                <a:spcPts val="150"/>
+              </a:spcAft>
+            </a:pPr>
+            <a:r>
+              <a:rPr sz="700" b="0">
+                <a:solidFill>
+                  <a:srgbClr val="1F2937"/>
+                </a:solidFill>
+                <a:latin typeface="Arial"/>
+              </a:rPr>
+              <a:t>• 5-season NDVI green biomass timeline</a:t>
+            </a:r>
+          </a:p>
+          <a:p>
+            <a:pPr algn="ctr">
+              <a:spcAft>
+                <a:spcPts val="150"/>
+              </a:spcAft>
+            </a:pPr>
+            <a:r>
+              <a:rPr sz="700" b="0">
+                <a:solidFill>
+                  <a:srgbClr val="1F2937"/>
+                </a:solidFill>
+                <a:latin typeface="Arial"/>
+              </a:rPr>
+              <a:t>• NDWI surface water spread verification</a:t>
             </a:r>
           </a:p>
         </p:txBody>
@@ -6962,7 +7497,7 @@
           </a:fontRef>
         </p:style>
         <p:txBody>
-          <a:bodyPr rtlCol="0" anchor="ctr" wrap="square" lIns="36576" rIns="36576" tIns="36576" bIns="36576"/>
+          <a:bodyPr rtlCol="0" anchor="ctr" wrap="square" lIns="36576" rIns="36576" tIns="27432" bIns="27432"/>
           <a:lstStyle/>
           <a:p>
             <a:pPr algn="ctr">
@@ -6974,7 +7509,7 @@
               </a:defRPr>
             </a:pPr>
             <a:r>
-              <a:rPr sz="850" b="1">
+              <a:rPr sz="919" b="1">
                 <a:solidFill>
                   <a:srgbClr val="FFFFFF"/>
                 </a:solidFill>
@@ -7023,7 +7558,7 @@
           </a:fontRef>
         </p:style>
         <p:txBody>
-          <a:bodyPr wrap="square" tIns="36576" rtlCol="0" anchor="ctr" lIns="36576" rIns="36576" bIns="36576"/>
+          <a:bodyPr wrap="square" tIns="27432" rtlCol="0" anchor="ctr" lIns="36576" rIns="36576" bIns="27432"/>
           <a:lstStyle/>
           <a:p>
             <a:pPr algn="ctr">
@@ -7035,7 +7570,7 @@
               </a:defRPr>
             </a:pPr>
             <a:r>
-              <a:rPr sz="720" b="1">
+              <a:rPr sz="819" b="1">
                 <a:solidFill>
                   <a:srgbClr val="973835"/>
                 </a:solidFill>
@@ -7051,13 +7586,13 @@
               </a:spcBef>
             </a:pPr>
             <a:r>
-              <a:rPr sz="620" b="0">
+              <a:rPr sz="720" b="0">
                 <a:solidFill>
                   <a:srgbClr val="1F2937"/>
                 </a:solidFill>
                 <a:latin typeface="Arial"/>
               </a:rPr>
-              <a:t>Algorithmic rating based on slope, drainage convergence &amp; soil permeability.</a:t>
+              <a:t>Algorithmic rating based on slope %, drainage convergence &amp; soil permeability.</a:t>
             </a:r>
           </a:p>
         </p:txBody>
@@ -7100,7 +7635,7 @@
           </a:fontRef>
         </p:style>
         <p:txBody>
-          <a:bodyPr wrap="square" tIns="36576" rtlCol="0" anchor="ctr" lIns="36576" rIns="36576" bIns="36576"/>
+          <a:bodyPr wrap="square" tIns="27432" rtlCol="0" anchor="ctr" lIns="36576" rIns="36576" bIns="27432"/>
           <a:lstStyle/>
           <a:p>
             <a:pPr algn="ctr">
@@ -7112,7 +7647,7 @@
               </a:defRPr>
             </a:pPr>
             <a:r>
-              <a:rPr sz="720" b="1">
+              <a:rPr sz="819" b="1">
                 <a:solidFill>
                   <a:srgbClr val="973835"/>
                 </a:solidFill>
@@ -7128,13 +7663,13 @@
               </a:spcBef>
             </a:pPr>
             <a:r>
-              <a:rPr sz="620" b="0">
+              <a:rPr sz="720" b="0">
                 <a:solidFill>
                   <a:srgbClr val="1F2937"/>
                 </a:solidFill>
                 <a:latin typeface="Arial"/>
               </a:rPr>
-              <a:t>SHA-256 hashed compliance report with GPS coordinates &amp; inspection timestamps.</a:t>
+              <a:t>SHA-256 hashed compliance audit report with GPS coordinates &amp; timestamps.</a:t>
             </a:r>
           </a:p>
         </p:txBody>
@@ -7177,7 +7712,7 @@
           </a:fontRef>
         </p:style>
         <p:txBody>
-          <a:bodyPr wrap="square" tIns="36576" rtlCol="0" anchor="ctr" lIns="36576" rIns="36576" bIns="36576"/>
+          <a:bodyPr wrap="square" tIns="27432" rtlCol="0" anchor="ctr" lIns="36576" rIns="36576" bIns="27432"/>
           <a:lstStyle/>
           <a:p>
             <a:pPr algn="ctr">
@@ -7189,7 +7724,7 @@
               </a:defRPr>
             </a:pPr>
             <a:r>
-              <a:rPr sz="720" b="1">
+              <a:rPr sz="819" b="1">
                 <a:solidFill>
                   <a:srgbClr val="973835"/>
                 </a:solidFill>
@@ -7205,13 +7740,13 @@
               </a:spcBef>
             </a:pPr>
             <a:r>
-              <a:rPr sz="620" b="0">
+              <a:rPr sz="720" b="0">
                 <a:solidFill>
                   <a:srgbClr val="1F2937"/>
                 </a:solidFill>
                 <a:latin typeface="Arial"/>
               </a:rPr>
-              <a:t>5-season comparison (May drought baseline to Oct peak recharge) tracking NDVI.</a:t>
+              <a:t>Multi-season comparison (May drought baseline to Oct peak recharge) via NDVI.</a:t>
             </a:r>
           </a:p>
         </p:txBody>
@@ -7254,7 +7789,7 @@
           </a:fontRef>
         </p:style>
         <p:txBody>
-          <a:bodyPr wrap="square" tIns="36576" rtlCol="0" anchor="ctr" lIns="36576" rIns="36576" bIns="36576"/>
+          <a:bodyPr wrap="square" tIns="27432" rtlCol="0" anchor="ctr" lIns="36576" rIns="36576" bIns="27432"/>
           <a:lstStyle/>
           <a:p>
             <a:pPr algn="ctr">
@@ -7266,7 +7801,7 @@
               </a:defRPr>
             </a:pPr>
             <a:r>
-              <a:rPr sz="720" b="1">
+              <a:rPr sz="819" b="1">
                 <a:solidFill>
                   <a:srgbClr val="973835"/>
                 </a:solidFill>
@@ -7282,7 +7817,7 @@
               </a:spcBef>
             </a:pPr>
             <a:r>
-              <a:rPr sz="620" b="0">
+              <a:rPr sz="720" b="0">
                 <a:solidFill>
                   <a:srgbClr val="1F2937"/>
                 </a:solidFill>
@@ -7331,7 +7866,7 @@
           </a:fontRef>
         </p:style>
         <p:txBody>
-          <a:bodyPr wrap="square" tIns="36576" rtlCol="0" anchor="ctr" lIns="36576" rIns="36576" bIns="36576"/>
+          <a:bodyPr wrap="square" tIns="27432" rtlCol="0" anchor="ctr" lIns="36576" rIns="36576" bIns="27432"/>
           <a:lstStyle/>
           <a:p>
             <a:pPr algn="ctr">
@@ -7343,7 +7878,7 @@
               </a:defRPr>
             </a:pPr>
             <a:r>
-              <a:rPr sz="720" b="1">
+              <a:rPr sz="819" b="1">
                 <a:solidFill>
                   <a:srgbClr val="973835"/>
                 </a:solidFill>
@@ -7359,7 +7894,7 @@
               </a:spcBef>
             </a:pPr>
             <a:r>
-              <a:rPr sz="620" b="0">
+              <a:rPr sz="720" b="0">
                 <a:solidFill>
                   <a:srgbClr val="1F2937"/>
                 </a:solidFill>
@@ -7624,7 +8159,7 @@
           <a:noFill/>
         </p:spPr>
         <p:txBody>
-          <a:bodyPr wrap="square" lIns="36576" rIns="36576" tIns="36576" bIns="36576">
+          <a:bodyPr wrap="square" lIns="36576" rIns="36576" tIns="27432" bIns="27432">
             <a:spAutoFit/>
           </a:bodyPr>
           <a:lstStyle/>
@@ -7638,7 +8173,7 @@
               </a:defRPr>
             </a:pPr>
             <a:r>
-              <a:rPr sz="919" b="1">
+              <a:rPr sz="1050" b="1">
                 <a:solidFill>
                   <a:srgbClr val="14532D"/>
                 </a:solidFill>
@@ -7666,7 +8201,7 @@
           <a:noFill/>
         </p:spPr>
         <p:txBody>
-          <a:bodyPr wrap="square" lIns="36576" rIns="36576" tIns="36576" bIns="36576">
+          <a:bodyPr wrap="square" lIns="36576" rIns="36576" tIns="27432" bIns="27432">
             <a:spAutoFit/>
           </a:bodyPr>
           <a:lstStyle/>
@@ -7680,7 +8215,7 @@
               </a:defRPr>
             </a:pPr>
             <a:r>
-              <a:rPr sz="880" b="0">
+              <a:rPr sz="980" b="0">
                 <a:solidFill>
                   <a:srgbClr val="4B5563"/>
                 </a:solidFill>
@@ -7814,11 +8349,11 @@
           <a:p>
             <a:pPr>
               <a:spcAft>
-                <a:spcPts val="400"/>
+                <a:spcPts val="850"/>
               </a:spcAft>
             </a:pPr>
             <a:r>
-              <a:rPr sz="850" b="1">
+              <a:rPr sz="1000" b="1">
                 <a:solidFill>
                   <a:srgbClr val="1E3A8A"/>
                 </a:solidFill>
@@ -7827,7 +8362,7 @@
               <a:t>• Zero-Download Web SPA: </a:t>
             </a:r>
             <a:r>
-              <a:rPr sz="780" b="0">
+              <a:rPr sz="900" b="0">
                 <a:solidFill>
                   <a:srgbClr val="1F2937"/>
                 </a:solidFill>
@@ -7839,11 +8374,11 @@
           <a:p>
             <a:pPr>
               <a:spcAft>
-                <a:spcPts val="400"/>
+                <a:spcPts val="850"/>
               </a:spcAft>
             </a:pPr>
             <a:r>
-              <a:rPr sz="850" b="1">
+              <a:rPr sz="1000" b="1">
                 <a:solidFill>
                   <a:srgbClr val="1E3A8A"/>
                 </a:solidFill>
@@ -7852,7 +8387,7 @@
               <a:t>• Low-Bandwidth Edge Capability: </a:t>
             </a:r>
             <a:r>
-              <a:rPr sz="780" b="0">
+              <a:rPr sz="900" b="0">
                 <a:solidFill>
                   <a:srgbClr val="1F2937"/>
                 </a:solidFill>
@@ -7864,11 +8399,11 @@
           <a:p>
             <a:pPr>
               <a:spcAft>
-                <a:spcPts val="400"/>
+                <a:spcPts val="850"/>
               </a:spcAft>
             </a:pPr>
             <a:r>
-              <a:rPr sz="850" b="1">
+              <a:rPr sz="1000" b="1">
                 <a:solidFill>
                   <a:srgbClr val="1E3A8A"/>
                 </a:solidFill>
@@ -7877,7 +8412,7 @@
               <a:t>• Offline-Resilient Field Logging: </a:t>
             </a:r>
             <a:r>
-              <a:rPr sz="780" b="0">
+              <a:rPr sz="900" b="0">
                 <a:solidFill>
                   <a:srgbClr val="1F2937"/>
                 </a:solidFill>
@@ -7889,11 +8424,11 @@
           <a:p>
             <a:pPr>
               <a:spcAft>
-                <a:spcPts val="400"/>
+                <a:spcPts val="850"/>
               </a:spcAft>
             </a:pPr>
             <a:r>
-              <a:rPr sz="850" b="1">
+              <a:rPr sz="1000" b="1">
                 <a:solidFill>
                   <a:srgbClr val="1E3A8A"/>
                 </a:solidFill>
@@ -7902,7 +8437,7 @@
               <a:t>• Open Standards &amp; Modularity: </a:t>
             </a:r>
             <a:r>
-              <a:rPr sz="780" b="0">
+              <a:rPr sz="900" b="0">
                 <a:solidFill>
                   <a:srgbClr val="1F2937"/>
                 </a:solidFill>
@@ -8050,7 +8585,7 @@
           </a:fontRef>
         </p:style>
         <p:txBody>
-          <a:bodyPr wrap="square" tIns="36576" rtlCol="0" anchor="ctr" lIns="36576" rIns="36576" bIns="36576"/>
+          <a:bodyPr wrap="square" tIns="27432" rtlCol="0" anchor="ctr" lIns="36576" rIns="36576" bIns="27432"/>
           <a:lstStyle/>
           <a:p>
             <a:pPr algn="ctr">
@@ -8062,7 +8597,7 @@
               </a:defRPr>
             </a:pPr>
             <a:r>
-              <a:rPr sz="750" b="1">
+              <a:rPr sz="880" b="1">
                 <a:solidFill>
                   <a:srgbClr val="973835"/>
                 </a:solidFill>
@@ -8111,7 +8646,7 @@
           </a:fontRef>
         </p:style>
         <p:txBody>
-          <a:bodyPr wrap="square" tIns="36576" rtlCol="0" anchor="ctr" lIns="36576" rIns="36576" bIns="36576"/>
+          <a:bodyPr wrap="square" tIns="27432" rtlCol="0" anchor="ctr" lIns="36576" rIns="36576" bIns="27432"/>
           <a:lstStyle/>
           <a:p>
             <a:pPr algn="l">
@@ -8123,7 +8658,7 @@
               </a:defRPr>
             </a:pPr>
             <a:r>
-              <a:rPr sz="680" b="0">
+              <a:rPr sz="800" b="0">
                 <a:solidFill>
                   <a:srgbClr val="14532D"/>
                 </a:solidFill>
@@ -8172,7 +8707,7 @@
           </a:fontRef>
         </p:style>
         <p:txBody>
-          <a:bodyPr wrap="square" tIns="36576" rtlCol="0" anchor="ctr" lIns="36576" rIns="36576" bIns="36576"/>
+          <a:bodyPr wrap="square" tIns="27432" rtlCol="0" anchor="ctr" lIns="36576" rIns="36576" bIns="27432"/>
           <a:lstStyle/>
           <a:p>
             <a:pPr algn="ctr">
@@ -8184,7 +8719,7 @@
               </a:defRPr>
             </a:pPr>
             <a:r>
-              <a:rPr sz="750" b="1">
+              <a:rPr sz="880" b="1">
                 <a:solidFill>
                   <a:srgbClr val="973835"/>
                 </a:solidFill>
@@ -8233,7 +8768,7 @@
           </a:fontRef>
         </p:style>
         <p:txBody>
-          <a:bodyPr wrap="square" tIns="36576" rtlCol="0" anchor="ctr" lIns="36576" rIns="36576" bIns="36576"/>
+          <a:bodyPr wrap="square" tIns="27432" rtlCol="0" anchor="ctr" lIns="36576" rIns="36576" bIns="27432"/>
           <a:lstStyle/>
           <a:p>
             <a:pPr algn="l">
@@ -8245,7 +8780,7 @@
               </a:defRPr>
             </a:pPr>
             <a:r>
-              <a:rPr sz="680" b="0">
+              <a:rPr sz="800" b="0">
                 <a:solidFill>
                   <a:srgbClr val="14532D"/>
                 </a:solidFill>
@@ -8294,7 +8829,7 @@
           </a:fontRef>
         </p:style>
         <p:txBody>
-          <a:bodyPr wrap="square" tIns="36576" rtlCol="0" anchor="ctr" lIns="36576" rIns="36576" bIns="36576"/>
+          <a:bodyPr wrap="square" tIns="27432" rtlCol="0" anchor="ctr" lIns="36576" rIns="36576" bIns="27432"/>
           <a:lstStyle/>
           <a:p>
             <a:pPr algn="ctr">
@@ -8306,7 +8841,7 @@
               </a:defRPr>
             </a:pPr>
             <a:r>
-              <a:rPr sz="750" b="1">
+              <a:rPr sz="880" b="1">
                 <a:solidFill>
                   <a:srgbClr val="973835"/>
                 </a:solidFill>
@@ -8355,7 +8890,7 @@
           </a:fontRef>
         </p:style>
         <p:txBody>
-          <a:bodyPr wrap="square" tIns="36576" rtlCol="0" anchor="ctr" lIns="36576" rIns="36576" bIns="36576"/>
+          <a:bodyPr wrap="square" tIns="27432" rtlCol="0" anchor="ctr" lIns="36576" rIns="36576" bIns="27432"/>
           <a:lstStyle/>
           <a:p>
             <a:pPr algn="l">
@@ -8367,7 +8902,7 @@
               </a:defRPr>
             </a:pPr>
             <a:r>
-              <a:rPr sz="680" b="0">
+              <a:rPr sz="800" b="0">
                 <a:solidFill>
                   <a:srgbClr val="14532D"/>
                 </a:solidFill>
@@ -8416,7 +8951,7 @@
           </a:fontRef>
         </p:style>
         <p:txBody>
-          <a:bodyPr wrap="square" tIns="36576" rtlCol="0" anchor="ctr" lIns="36576" rIns="36576" bIns="36576"/>
+          <a:bodyPr wrap="square" tIns="27432" rtlCol="0" anchor="ctr" lIns="36576" rIns="36576" bIns="27432"/>
           <a:lstStyle/>
           <a:p>
             <a:pPr algn="ctr">
@@ -8428,7 +8963,7 @@
               </a:defRPr>
             </a:pPr>
             <a:r>
-              <a:rPr sz="750" b="1">
+              <a:rPr sz="880" b="1">
                 <a:solidFill>
                   <a:srgbClr val="973835"/>
                 </a:solidFill>
@@ -8477,7 +9012,7 @@
           </a:fontRef>
         </p:style>
         <p:txBody>
-          <a:bodyPr wrap="square" tIns="36576" rtlCol="0" anchor="ctr" lIns="36576" rIns="36576" bIns="36576"/>
+          <a:bodyPr wrap="square" tIns="27432" rtlCol="0" anchor="ctr" lIns="36576" rIns="36576" bIns="27432"/>
           <a:lstStyle/>
           <a:p>
             <a:pPr algn="l">
@@ -8489,7 +9024,7 @@
               </a:defRPr>
             </a:pPr>
             <a:r>
-              <a:rPr sz="680" b="0">
+              <a:rPr sz="800" b="0">
                 <a:solidFill>
                   <a:srgbClr val="14532D"/>
                 </a:solidFill>
@@ -8669,7 +9204,7 @@
           <a:noFill/>
         </p:spPr>
         <p:txBody>
-          <a:bodyPr wrap="square" tIns="36576" lIns="36576" rIns="36576" bIns="36576">
+          <a:bodyPr wrap="square" tIns="27432" lIns="36576" rIns="36576" bIns="27432">
             <a:spAutoFit/>
           </a:bodyPr>
           <a:lstStyle/>
@@ -8683,7 +9218,7 @@
               </a:defRPr>
             </a:pPr>
             <a:r>
-              <a:rPr sz="780" b="1">
+              <a:rPr sz="900" b="1">
                 <a:solidFill>
                   <a:srgbClr val="973835"/>
                 </a:solidFill>
@@ -8699,7 +9234,7 @@
               </a:spcBef>
             </a:pPr>
             <a:r>
-              <a:rPr sz="680" b="0">
+              <a:rPr sz="800" b="0">
                 <a:solidFill>
                   <a:srgbClr val="1F2937"/>
                 </a:solidFill>
@@ -8780,7 +9315,7 @@
           <a:noFill/>
         </p:spPr>
         <p:txBody>
-          <a:bodyPr wrap="square" tIns="36576" lIns="36576" rIns="36576" bIns="36576">
+          <a:bodyPr wrap="square" tIns="27432" lIns="36576" rIns="36576" bIns="27432">
             <a:spAutoFit/>
           </a:bodyPr>
           <a:lstStyle/>
@@ -8794,7 +9329,7 @@
               </a:defRPr>
             </a:pPr>
             <a:r>
-              <a:rPr sz="780" b="1">
+              <a:rPr sz="900" b="1">
                 <a:solidFill>
                   <a:srgbClr val="973835"/>
                 </a:solidFill>
@@ -8810,7 +9345,7 @@
               </a:spcBef>
             </a:pPr>
             <a:r>
-              <a:rPr sz="680" b="0">
+              <a:rPr sz="800" b="0">
                 <a:solidFill>
                   <a:srgbClr val="1F2937"/>
                 </a:solidFill>
@@ -8891,7 +9426,7 @@
           <a:noFill/>
         </p:spPr>
         <p:txBody>
-          <a:bodyPr wrap="square" tIns="36576" lIns="36576" rIns="36576" bIns="36576">
+          <a:bodyPr wrap="square" tIns="27432" lIns="36576" rIns="36576" bIns="27432">
             <a:spAutoFit/>
           </a:bodyPr>
           <a:lstStyle/>
@@ -8905,7 +9440,7 @@
               </a:defRPr>
             </a:pPr>
             <a:r>
-              <a:rPr sz="780" b="1">
+              <a:rPr sz="900" b="1">
                 <a:solidFill>
                   <a:srgbClr val="973835"/>
                 </a:solidFill>
@@ -8921,7 +9456,7 @@
               </a:spcBef>
             </a:pPr>
             <a:r>
-              <a:rPr sz="680" b="0">
+              <a:rPr sz="800" b="0">
                 <a:solidFill>
                   <a:srgbClr val="1F2937"/>
                 </a:solidFill>
@@ -9002,7 +9537,7 @@
           <a:noFill/>
         </p:spPr>
         <p:txBody>
-          <a:bodyPr wrap="square" tIns="36576" lIns="36576" rIns="36576" bIns="36576">
+          <a:bodyPr wrap="square" tIns="27432" lIns="36576" rIns="36576" bIns="27432">
             <a:spAutoFit/>
           </a:bodyPr>
           <a:lstStyle/>
@@ -9016,7 +9551,7 @@
               </a:defRPr>
             </a:pPr>
             <a:r>
-              <a:rPr sz="780" b="1">
+              <a:rPr sz="900" b="1">
                 <a:solidFill>
                   <a:srgbClr val="973835"/>
                 </a:solidFill>
@@ -9032,7 +9567,7 @@
               </a:spcBef>
             </a:pPr>
             <a:r>
-              <a:rPr sz="680" b="0">
+              <a:rPr sz="800" b="0">
                 <a:solidFill>
                   <a:srgbClr val="1F2937"/>
                 </a:solidFill>
@@ -9113,7 +9648,7 @@
           <a:noFill/>
         </p:spPr>
         <p:txBody>
-          <a:bodyPr wrap="square" tIns="36576" lIns="36576" rIns="36576" bIns="36576">
+          <a:bodyPr wrap="square" tIns="27432" lIns="36576" rIns="36576" bIns="27432">
             <a:spAutoFit/>
           </a:bodyPr>
           <a:lstStyle/>
@@ -9127,7 +9662,7 @@
               </a:defRPr>
             </a:pPr>
             <a:r>
-              <a:rPr sz="780" b="1">
+              <a:rPr sz="900" b="1">
                 <a:solidFill>
                   <a:srgbClr val="973835"/>
                 </a:solidFill>
@@ -9143,7 +9678,7 @@
               </a:spcBef>
             </a:pPr>
             <a:r>
-              <a:rPr sz="680" b="0">
+              <a:rPr sz="800" b="0">
                 <a:solidFill>
                   <a:srgbClr val="1F2937"/>
                 </a:solidFill>
@@ -9465,7 +10000,7 @@
           </a:fontRef>
         </p:style>
         <p:txBody>
-          <a:bodyPr wrap="square" tIns="36576" rtlCol="0" anchor="ctr" lIns="36576" rIns="36576" bIns="36576"/>
+          <a:bodyPr wrap="square" tIns="27432" rtlCol="0" anchor="ctr" lIns="36576" rIns="36576" bIns="27432"/>
           <a:lstStyle/>
           <a:p>
             <a:pPr algn="ctr">
@@ -9477,7 +10012,7 @@
               </a:defRPr>
             </a:pPr>
             <a:r>
-              <a:rPr sz="780" b="1">
+              <a:rPr sz="950" b="1">
                 <a:solidFill>
                   <a:srgbClr val="973835"/>
                 </a:solidFill>
@@ -9489,11 +10024,11 @@
           <a:p>
             <a:pPr algn="ctr">
               <a:spcBef>
-                <a:spcPts val="200"/>
+                <a:spcPts val="500"/>
               </a:spcBef>
             </a:pPr>
             <a:r>
-              <a:rPr sz="680" b="0">
+              <a:rPr sz="819" b="0">
                 <a:solidFill>
                   <a:srgbClr val="1F2937"/>
                 </a:solidFill>
@@ -9542,7 +10077,7 @@
           </a:fontRef>
         </p:style>
         <p:txBody>
-          <a:bodyPr wrap="square" tIns="36576" rtlCol="0" anchor="ctr" lIns="36576" rIns="36576" bIns="36576"/>
+          <a:bodyPr wrap="square" tIns="27432" rtlCol="0" anchor="ctr" lIns="36576" rIns="36576" bIns="27432"/>
           <a:lstStyle/>
           <a:p>
             <a:pPr algn="ctr">
@@ -9554,7 +10089,7 @@
               </a:defRPr>
             </a:pPr>
             <a:r>
-              <a:rPr sz="780" b="1">
+              <a:rPr sz="950" b="1">
                 <a:solidFill>
                   <a:srgbClr val="973835"/>
                 </a:solidFill>
@@ -9566,11 +10101,11 @@
           <a:p>
             <a:pPr algn="ctr">
               <a:spcBef>
-                <a:spcPts val="200"/>
+                <a:spcPts val="500"/>
               </a:spcBef>
             </a:pPr>
             <a:r>
-              <a:rPr sz="680" b="0">
+              <a:rPr sz="819" b="0">
                 <a:solidFill>
                   <a:srgbClr val="1F2937"/>
                 </a:solidFill>
@@ -9619,7 +10154,7 @@
           </a:fontRef>
         </p:style>
         <p:txBody>
-          <a:bodyPr wrap="square" tIns="36576" rtlCol="0" anchor="ctr" lIns="36576" rIns="36576" bIns="36576"/>
+          <a:bodyPr wrap="square" tIns="27432" rtlCol="0" anchor="ctr" lIns="36576" rIns="36576" bIns="27432"/>
           <a:lstStyle/>
           <a:p>
             <a:pPr algn="ctr">
@@ -9631,7 +10166,7 @@
               </a:defRPr>
             </a:pPr>
             <a:r>
-              <a:rPr sz="780" b="1">
+              <a:rPr sz="950" b="1">
                 <a:solidFill>
                   <a:srgbClr val="973835"/>
                 </a:solidFill>
@@ -9643,11 +10178,11 @@
           <a:p>
             <a:pPr algn="ctr">
               <a:spcBef>
-                <a:spcPts val="200"/>
+                <a:spcPts val="500"/>
               </a:spcBef>
             </a:pPr>
             <a:r>
-              <a:rPr sz="680" b="0">
+              <a:rPr sz="819" b="0">
                 <a:solidFill>
                   <a:srgbClr val="1F2937"/>
                 </a:solidFill>
@@ -9696,7 +10231,7 @@
           </a:fontRef>
         </p:style>
         <p:txBody>
-          <a:bodyPr wrap="square" tIns="36576" rtlCol="0" anchor="ctr" lIns="36576" rIns="36576" bIns="36576"/>
+          <a:bodyPr wrap="square" tIns="27432" rtlCol="0" anchor="ctr" lIns="36576" rIns="36576" bIns="27432"/>
           <a:lstStyle/>
           <a:p>
             <a:pPr algn="ctr">
@@ -9708,7 +10243,7 @@
               </a:defRPr>
             </a:pPr>
             <a:r>
-              <a:rPr sz="780" b="1">
+              <a:rPr sz="950" b="1">
                 <a:solidFill>
                   <a:srgbClr val="973835"/>
                 </a:solidFill>
@@ -9720,11 +10255,11 @@
           <a:p>
             <a:pPr algn="ctr">
               <a:spcBef>
-                <a:spcPts val="200"/>
+                <a:spcPts val="500"/>
               </a:spcBef>
             </a:pPr>
             <a:r>
-              <a:rPr sz="680" b="0">
+              <a:rPr sz="819" b="0">
                 <a:solidFill>
                   <a:srgbClr val="1F2937"/>
                 </a:solidFill>
@@ -9773,7 +10308,7 @@
           </a:fontRef>
         </p:style>
         <p:txBody>
-          <a:bodyPr wrap="square" tIns="36576" rtlCol="0" anchor="ctr" lIns="36576" rIns="36576" bIns="36576"/>
+          <a:bodyPr wrap="square" tIns="27432" rtlCol="0" anchor="ctr" lIns="36576" rIns="36576" bIns="27432"/>
           <a:lstStyle/>
           <a:p>
             <a:pPr algn="ctr">
@@ -9785,7 +10320,7 @@
               </a:defRPr>
             </a:pPr>
             <a:r>
-              <a:rPr sz="780" b="1">
+              <a:rPr sz="950" b="1">
                 <a:solidFill>
                   <a:srgbClr val="973835"/>
                 </a:solidFill>
@@ -9797,11 +10332,11 @@
           <a:p>
             <a:pPr algn="ctr">
               <a:spcBef>
-                <a:spcPts val="200"/>
+                <a:spcPts val="500"/>
               </a:spcBef>
             </a:pPr>
             <a:r>
-              <a:rPr sz="680" b="0">
+              <a:rPr sz="819" b="0">
                 <a:solidFill>
                   <a:srgbClr val="1F2937"/>
                 </a:solidFill>
@@ -9930,7 +10465,7 @@
           </a:fontRef>
         </p:style>
         <p:txBody>
-          <a:bodyPr wrap="square" tIns="36576" rtlCol="0" anchor="ctr" lIns="36576" rIns="36576" bIns="36576"/>
+          <a:bodyPr wrap="square" tIns="27432" rtlCol="0" anchor="ctr" lIns="36576" rIns="36576" bIns="27432"/>
           <a:lstStyle/>
           <a:p>
             <a:pPr algn="ctr">
@@ -9942,7 +10477,7 @@
               </a:defRPr>
             </a:pPr>
             <a:r>
-              <a:rPr sz="850" b="1">
+              <a:rPr sz="980" b="1">
                 <a:solidFill>
                   <a:srgbClr val="FFFFFF"/>
                 </a:solidFill>
@@ -9976,6 +10511,9 @@
           <a:lstStyle/>
           <a:p>
             <a:pPr algn="l">
+              <a:spcAft>
+                <a:spcPts val="450"/>
+              </a:spcAft>
               <a:defRPr sz="950">
                 <a:solidFill>
                   <a:srgbClr val="212529"/>
@@ -9984,7 +10522,7 @@
               </a:defRPr>
             </a:pPr>
             <a:r>
-              <a:rPr sz="720" b="0">
+              <a:rPr sz="900" b="0">
                 <a:solidFill>
                   <a:srgbClr val="1F2937"/>
                 </a:solidFill>
@@ -9992,8 +10530,20 @@
               </a:rPr>
               <a:t>• 250–500 small &amp; marginal farming families per micro-watershed cluster</a:t>
             </a:r>
-            <a:br/>
-            <a:r>
+          </a:p>
+          <a:p>
+            <a:pPr algn="l">
+              <a:spcAft>
+                <a:spcPts val="450"/>
+              </a:spcAft>
+            </a:pPr>
+            <a:r>
+              <a:rPr sz="900" b="0">
+                <a:solidFill>
+                  <a:srgbClr val="1F2937"/>
+                </a:solidFill>
+                <a:latin typeface="Arial"/>
+              </a:rPr>
               <a:t>• State Water Resources Depts, Zilla Parishads, CSR Foundations &amp; Gram Panchayats</a:t>
             </a:r>
           </a:p>
@@ -10081,7 +10631,7 @@
           </a:fontRef>
         </p:style>
         <p:txBody>
-          <a:bodyPr wrap="square" tIns="36576" rtlCol="0" anchor="ctr" lIns="36576" rIns="36576" bIns="36576"/>
+          <a:bodyPr wrap="square" tIns="27432" rtlCol="0" anchor="ctr" lIns="36576" rIns="36576" bIns="27432"/>
           <a:lstStyle/>
           <a:p>
             <a:pPr algn="ctr">
@@ -10093,7 +10643,7 @@
               </a:defRPr>
             </a:pPr>
             <a:r>
-              <a:rPr sz="850" b="1">
+              <a:rPr sz="980" b="1">
                 <a:solidFill>
                   <a:srgbClr val="FFFFFF"/>
                 </a:solidFill>
@@ -10127,6 +10677,9 @@
           <a:lstStyle/>
           <a:p>
             <a:pPr algn="l">
+              <a:spcAft>
+                <a:spcPts val="450"/>
+              </a:spcAft>
               <a:defRPr sz="950">
                 <a:solidFill>
                   <a:srgbClr val="212529"/>
@@ -10135,7 +10688,7 @@
               </a:defRPr>
             </a:pPr>
             <a:r>
-              <a:rPr sz="720" b="0">
+              <a:rPr sz="900" b="0">
                 <a:solidFill>
                   <a:srgbClr val="1F2937"/>
                 </a:solidFill>
@@ -10143,8 +10696,20 @@
               </a:rPr>
               <a:t>• +210% to +340% increase in water retention capacity; prevents flash-flood erosion in valleys</a:t>
             </a:r>
-            <a:br/>
-            <a:r>
+          </a:p>
+          <a:p>
+            <a:pPr algn="l">
+              <a:spcAft>
+                <a:spcPts val="450"/>
+              </a:spcAft>
+            </a:pPr>
+            <a:r>
+              <a:rPr sz="900" b="0">
+                <a:solidFill>
+                  <a:srgbClr val="1F2937"/>
+                </a:solidFill>
+                <a:latin typeface="Arial"/>
+              </a:rPr>
               <a:t>• +2.4m to +4.2m water table elevation in downstream wells, sustaining borewells through summer</a:t>
             </a:r>
           </a:p>
@@ -10232,7 +10797,7 @@
           </a:fontRef>
         </p:style>
         <p:txBody>
-          <a:bodyPr wrap="square" tIns="36576" rtlCol="0" anchor="ctr" lIns="36576" rIns="36576" bIns="36576"/>
+          <a:bodyPr wrap="square" tIns="27432" rtlCol="0" anchor="ctr" lIns="36576" rIns="36576" bIns="27432"/>
           <a:lstStyle/>
           <a:p>
             <a:pPr algn="ctr">
@@ -10244,7 +10809,7 @@
               </a:defRPr>
             </a:pPr>
             <a:r>
-              <a:rPr sz="850" b="1">
+              <a:rPr sz="980" b="1">
                 <a:solidFill>
                   <a:srgbClr val="FFFFFF"/>
                 </a:solidFill>
@@ -10278,6 +10843,9 @@
           <a:lstStyle/>
           <a:p>
             <a:pPr algn="l">
+              <a:spcAft>
+                <a:spcPts val="450"/>
+              </a:spcAft>
               <a:defRPr sz="950">
                 <a:solidFill>
                   <a:srgbClr val="212529"/>
@@ -10286,7 +10854,7 @@
               </a:defRPr>
             </a:pPr>
             <a:r>
-              <a:rPr sz="720" b="0">
+              <a:rPr sz="900" b="0">
                 <a:solidFill>
                   <a:srgbClr val="1F2937"/>
                 </a:solidFill>
@@ -10294,8 +10862,20 @@
               </a:rPr>
               <a:t>• Guarantees dual-crop (Kharif + Rabi) cycles, ending distress seasonal migration</a:t>
             </a:r>
-            <a:br/>
-            <a:r>
+          </a:p>
+          <a:p>
+            <a:pPr algn="l">
+              <a:spcAft>
+                <a:spcPts val="450"/>
+              </a:spcAft>
+            </a:pPr>
+            <a:r>
+              <a:rPr sz="900" b="0">
+                <a:solidFill>
+                  <a:srgbClr val="1F2937"/>
+                </a:solidFill>
+                <a:latin typeface="Arial"/>
+              </a:rPr>
               <a:t>• +144% farmer income growth: average annual income rises from ₹58,000 to ₹1,42,000</a:t>
             </a:r>
           </a:p>
@@ -10383,7 +10963,7 @@
           </a:fontRef>
         </p:style>
         <p:txBody>
-          <a:bodyPr wrap="square" tIns="36576" rtlCol="0" anchor="ctr" lIns="36576" rIns="36576" bIns="36576"/>
+          <a:bodyPr wrap="square" tIns="27432" rtlCol="0" anchor="ctr" lIns="36576" rIns="36576" bIns="27432"/>
           <a:lstStyle/>
           <a:p>
             <a:pPr algn="ctr">
@@ -10395,7 +10975,7 @@
               </a:defRPr>
             </a:pPr>
             <a:r>
-              <a:rPr sz="850" b="1">
+              <a:rPr sz="980" b="1">
                 <a:solidFill>
                   <a:srgbClr val="FFFFFF"/>
                 </a:solidFill>
@@ -10429,6 +11009,9 @@
           <a:lstStyle/>
           <a:p>
             <a:pPr algn="l">
+              <a:spcAft>
+                <a:spcPts val="450"/>
+              </a:spcAft>
               <a:defRPr sz="950">
                 <a:solidFill>
                   <a:srgbClr val="212529"/>
@@ -10437,7 +11020,7 @@
               </a:defRPr>
             </a:pPr>
             <a:r>
-              <a:rPr sz="720" b="0">
+              <a:rPr sz="900" b="0">
                 <a:solidFill>
                   <a:srgbClr val="1F2937"/>
                 </a:solidFill>
@@ -10445,8 +11028,20 @@
               </a:rPr>
               <a:t>• 100% elimination of ghost infrastructure fraud by linking payments to cryptographic AI certificates</a:t>
             </a:r>
-            <a:br/>
-            <a:r>
+          </a:p>
+          <a:p>
+            <a:pPr algn="l">
+              <a:spcAft>
+                <a:spcPts val="450"/>
+              </a:spcAft>
+            </a:pPr>
+            <a:r>
+              <a:rPr sz="900" b="0">
+                <a:solidFill>
+                  <a:srgbClr val="1F2937"/>
+                </a:solidFill>
+                <a:latin typeface="Arial"/>
+              </a:rPr>
               <a:t>• Slashes administrative verification expenditure by 82% (from ₹20,000 to ₹2,500/year)</a:t>
             </a:r>
           </a:p>
@@ -10534,7 +11129,7 @@
           </a:fontRef>
         </p:style>
         <p:txBody>
-          <a:bodyPr wrap="square" tIns="36576" rtlCol="0" anchor="ctr" lIns="36576" rIns="36576" bIns="36576"/>
+          <a:bodyPr wrap="square" tIns="27432" rtlCol="0" anchor="ctr" lIns="36576" rIns="36576" bIns="27432"/>
           <a:lstStyle/>
           <a:p>
             <a:pPr algn="ctr">
@@ -10546,7 +11141,7 @@
               </a:defRPr>
             </a:pPr>
             <a:r>
-              <a:rPr sz="850" b="1">
+              <a:rPr sz="980" b="1">
                 <a:solidFill>
                   <a:srgbClr val="FFFFFF"/>
                 </a:solidFill>
@@ -10580,6 +11175,9 @@
           <a:lstStyle/>
           <a:p>
             <a:pPr algn="l">
+              <a:spcAft>
+                <a:spcPts val="450"/>
+              </a:spcAft>
               <a:defRPr sz="950">
                 <a:solidFill>
                   <a:srgbClr val="212529"/>
@@ -10588,7 +11186,7 @@
               </a:defRPr>
             </a:pPr>
             <a:r>
-              <a:rPr sz="720" b="0">
+              <a:rPr sz="900" b="0">
                 <a:solidFill>
                   <a:srgbClr val="1F2937"/>
                 </a:solidFill>
@@ -10596,8 +11194,20 @@
               </a:rPr>
               <a:t>• Arrests 180+ tons of topsoil erosion per dam/season; cools micro-climate by 1.5°C–2.0°C</a:t>
             </a:r>
-            <a:br/>
-            <a:r>
+          </a:p>
+          <a:p>
+            <a:pPr algn="l">
+              <a:spcAft>
+                <a:spcPts val="450"/>
+              </a:spcAft>
+            </a:pPr>
+            <a:r>
+              <a:rPr sz="900" b="0">
+                <a:solidFill>
+                  <a:srgbClr val="1F2937"/>
+                </a:solidFill>
+                <a:latin typeface="Arial"/>
+              </a:rPr>
               <a:t>• +0.28 NDVI green cover expansion supports biodiversity and soil organic carbon replenishment</a:t>
             </a:r>
           </a:p>
@@ -10653,7 +11263,7 @@
               </a:defRPr>
             </a:pPr>
             <a:r>
-              <a:rPr sz="1000" b="1">
+              <a:rPr sz="1200" b="1">
                 <a:solidFill>
                   <a:srgbClr val="973835"/>
                 </a:solidFill>
@@ -10665,14 +11275,14 @@
           <a:p>
             <a:pPr algn="ctr">
               <a:spcBef>
-                <a:spcPts val="600"/>
+                <a:spcPts val="1200"/>
               </a:spcBef>
               <a:spcAft>
-                <a:spcPts val="800"/>
+                <a:spcPts val="1400"/>
               </a:spcAft>
             </a:pPr>
             <a:r>
-              <a:rPr sz="800" i="1">
+              <a:rPr sz="950" i="1">
                 <a:solidFill>
                   <a:srgbClr val="1E3A8A"/>
                 </a:solidFill>
@@ -10684,11 +11294,11 @@
           <a:p>
             <a:pPr algn="ctr">
               <a:spcBef>
-                <a:spcPts val="200"/>
+                <a:spcPts val="500"/>
               </a:spcBef>
             </a:pPr>
             <a:r>
-              <a:rPr sz="850" b="1">
+              <a:rPr sz="980" b="1">
                 <a:solidFill>
                   <a:srgbClr val="14532D"/>
                 </a:solidFill>
@@ -10697,7 +11307,7 @@
               <a:t>✓ +340% Water Retention  </a:t>
             </a:r>
             <a:r>
-              <a:rPr sz="720">
+              <a:rPr sz="819">
                 <a:solidFill>
                   <a:srgbClr val="4B5563"/>
                 </a:solidFill>
@@ -10709,11 +11319,11 @@
           <a:p>
             <a:pPr algn="ctr">
               <a:spcBef>
-                <a:spcPts val="200"/>
+                <a:spcPts val="500"/>
               </a:spcBef>
             </a:pPr>
             <a:r>
-              <a:rPr sz="850" b="1">
+              <a:rPr sz="980" b="1">
                 <a:solidFill>
                   <a:srgbClr val="14532D"/>
                 </a:solidFill>
@@ -10722,7 +11332,7 @@
               <a:t>✓ +3.5m Aquifer Rise  </a:t>
             </a:r>
             <a:r>
-              <a:rPr sz="720">
+              <a:rPr sz="819">
                 <a:solidFill>
                   <a:srgbClr val="4B5563"/>
                 </a:solidFill>
@@ -10734,11 +11344,11 @@
           <a:p>
             <a:pPr algn="ctr">
               <a:spcBef>
-                <a:spcPts val="200"/>
+                <a:spcPts val="500"/>
               </a:spcBef>
             </a:pPr>
             <a:r>
-              <a:rPr sz="850" b="1">
+              <a:rPr sz="980" b="1">
                 <a:solidFill>
                   <a:srgbClr val="14532D"/>
                 </a:solidFill>
@@ -10747,7 +11357,7 @@
               <a:t>✓ +144% Farmer Income  </a:t>
             </a:r>
             <a:r>
-              <a:rPr sz="720">
+              <a:rPr sz="819">
                 <a:solidFill>
                   <a:srgbClr val="4B5563"/>
                 </a:solidFill>
@@ -10759,11 +11369,11 @@
           <a:p>
             <a:pPr algn="ctr">
               <a:spcBef>
-                <a:spcPts val="200"/>
+                <a:spcPts val="500"/>
               </a:spcBef>
             </a:pPr>
             <a:r>
-              <a:rPr sz="850" b="1">
+              <a:rPr sz="980" b="1">
                 <a:solidFill>
                   <a:srgbClr val="14532D"/>
                 </a:solidFill>
@@ -10772,13 +11382,38 @@
               <a:t>✓ 82% Audit Cost Reduction  </a:t>
             </a:r>
             <a:r>
-              <a:rPr sz="720">
+              <a:rPr sz="819">
                 <a:solidFill>
                   <a:srgbClr val="4B5563"/>
                 </a:solidFill>
                 <a:latin typeface="Arial"/>
               </a:rPr>
               <a:t>(Automating manual audits)</a:t>
+            </a:r>
+          </a:p>
+          <a:p>
+            <a:pPr algn="ctr">
+              <a:spcBef>
+                <a:spcPts val="500"/>
+              </a:spcBef>
+            </a:pPr>
+            <a:r>
+              <a:rPr sz="980" b="1">
+                <a:solidFill>
+                  <a:srgbClr val="14532D"/>
+                </a:solidFill>
+                <a:latin typeface="Arial"/>
+              </a:rPr>
+              <a:t>✓ 100% Fraud Elimination  </a:t>
+            </a:r>
+            <a:r>
+              <a:rPr sz="819">
+                <a:solidFill>
+                  <a:srgbClr val="4B5563"/>
+                </a:solidFill>
+                <a:latin typeface="Arial"/>
+              </a:rPr>
+              <a:t>(Zero ghost asset fund leakage)</a:t>
             </a:r>
           </a:p>
         </p:txBody>
@@ -11047,7 +11682,7 @@
                 <a:spcPts val="0"/>
               </a:spcBef>
               <a:spcAft>
-                <a:spcPts val="200"/>
+                <a:spcPts val="250"/>
               </a:spcAft>
               <a:defRPr sz="1500" b="1">
                 <a:solidFill>
@@ -11057,7 +11692,7 @@
               </a:defRPr>
             </a:pPr>
             <a:r>
-              <a:rPr sz="1100" b="1">
+              <a:rPr sz="1200" b="1">
                 <a:solidFill>
                   <a:srgbClr val="973835"/>
                 </a:solidFill>
@@ -11069,11 +11704,11 @@
           <a:p>
             <a:pPr>
               <a:spcAft>
-                <a:spcPts val="150"/>
+                <a:spcPts val="250"/>
               </a:spcAft>
             </a:pPr>
             <a:r>
-              <a:rPr sz="950" b="1">
+              <a:rPr sz="980" b="1">
                 <a:solidFill>
                   <a:srgbClr val="000000"/>
                 </a:solidFill>
@@ -11082,7 +11717,7 @@
               <a:t>•  Central Ground Water Board (CGWB), Ministry of Jal Shakti: </a:t>
             </a:r>
             <a:r>
-              <a:rPr sz="919" b="0">
+              <a:rPr sz="950" b="0">
                 <a:solidFill>
                   <a:srgbClr val="1F2937"/>
                 </a:solidFill>
@@ -11094,11 +11729,11 @@
           <a:p>
             <a:pPr>
               <a:spcAft>
-                <a:spcPts val="150"/>
+                <a:spcPts val="250"/>
               </a:spcAft>
             </a:pPr>
             <a:r>
-              <a:rPr sz="950" b="1">
+              <a:rPr sz="980" b="1">
                 <a:solidFill>
                   <a:srgbClr val="000000"/>
                 </a:solidFill>
@@ -11107,7 +11742,7 @@
               <a:t>•  Pradhan Mantri Krishi Sinchayee Yojana (PMKSY - WDC): </a:t>
             </a:r>
             <a:r>
-              <a:rPr sz="919" b="0">
+              <a:rPr sz="950" b="0">
                 <a:solidFill>
                   <a:srgbClr val="1F2937"/>
                 </a:solidFill>
@@ -11119,11 +11754,11 @@
           <a:p>
             <a:pPr>
               <a:spcAft>
-                <a:spcPts val="150"/>
+                <a:spcPts val="250"/>
               </a:spcAft>
             </a:pPr>
             <a:r>
-              <a:rPr sz="950" b="1">
+              <a:rPr sz="980" b="1">
                 <a:solidFill>
                   <a:srgbClr val="000000"/>
                 </a:solidFill>
@@ -11132,7 +11767,7 @@
               <a:t>•  Mission Amrit Sarovar &amp; Jal Jeevan Mission: </a:t>
             </a:r>
             <a:r>
-              <a:rPr sz="919" b="0">
+              <a:rPr sz="950" b="0">
                 <a:solidFill>
                   <a:srgbClr val="1F2937"/>
                 </a:solidFill>
@@ -11144,11 +11779,11 @@
           <a:p>
             <a:pPr>
               <a:spcAft>
-                <a:spcPts val="150"/>
+                <a:spcPts val="250"/>
               </a:spcAft>
             </a:pPr>
             <a:r>
-              <a:rPr sz="950" b="1">
+              <a:rPr sz="980" b="1">
                 <a:solidFill>
                   <a:srgbClr val="000000"/>
                 </a:solidFill>
@@ -11157,7 +11792,7 @@
               <a:t>•  Food and Agriculture Organization (FAO): </a:t>
             </a:r>
             <a:r>
-              <a:rPr sz="919" b="0">
+              <a:rPr sz="950" b="0">
                 <a:solidFill>
                   <a:srgbClr val="1F2937"/>
                 </a:solidFill>
@@ -11169,14 +11804,14 @@
           <a:p>
             <a:pPr>
               <a:spcBef>
-                <a:spcPts val="400"/>
+                <a:spcPts val="600"/>
               </a:spcBef>
               <a:spcAft>
-                <a:spcPts val="200"/>
+                <a:spcPts val="250"/>
               </a:spcAft>
             </a:pPr>
             <a:r>
-              <a:rPr sz="1100" b="1">
+              <a:rPr sz="1200" b="1">
                 <a:solidFill>
                   <a:srgbClr val="973835"/>
                 </a:solidFill>
@@ -11188,11 +11823,11 @@
           <a:p>
             <a:pPr>
               <a:spcAft>
-                <a:spcPts val="150"/>
+                <a:spcPts val="250"/>
               </a:spcAft>
             </a:pPr>
             <a:r>
-              <a:rPr sz="950" b="1">
+              <a:rPr sz="980" b="1">
                 <a:solidFill>
                   <a:srgbClr val="000000"/>
                 </a:solidFill>
@@ -11201,7 +11836,7 @@
               <a:t>•  USDA-NRCS: </a:t>
             </a:r>
             <a:r>
-              <a:rPr sz="919" b="0">
+              <a:rPr sz="950" b="0">
                 <a:solidFill>
                   <a:srgbClr val="1F2937"/>
                 </a:solidFill>
@@ -11213,11 +11848,11 @@
           <a:p>
             <a:pPr>
               <a:spcAft>
-                <a:spcPts val="150"/>
+                <a:spcPts val="250"/>
               </a:spcAft>
             </a:pPr>
             <a:r>
-              <a:rPr sz="950" b="1">
+              <a:rPr sz="980" b="1">
                 <a:solidFill>
                   <a:srgbClr val="000000"/>
                 </a:solidFill>
@@ -11226,7 +11861,7 @@
               <a:t>•  Strahler, A. N. (1957): </a:t>
             </a:r>
             <a:r>
-              <a:rPr sz="919" b="0">
+              <a:rPr sz="950" b="0">
                 <a:solidFill>
                   <a:srgbClr val="1F2937"/>
                 </a:solidFill>
@@ -11238,11 +11873,11 @@
           <a:p>
             <a:pPr>
               <a:spcAft>
-                <a:spcPts val="150"/>
+                <a:spcPts val="250"/>
               </a:spcAft>
             </a:pPr>
             <a:r>
-              <a:rPr sz="950" b="1">
+              <a:rPr sz="980" b="1">
                 <a:solidFill>
                   <a:srgbClr val="000000"/>
                 </a:solidFill>
@@ -11251,7 +11886,7 @@
               <a:t>•  European Space Agency (ESA Copernicus): </a:t>
             </a:r>
             <a:r>
-              <a:rPr sz="919" b="0">
+              <a:rPr sz="950" b="0">
                 <a:solidFill>
                   <a:srgbClr val="1F2937"/>
                 </a:solidFill>
@@ -11263,11 +11898,11 @@
           <a:p>
             <a:pPr>
               <a:spcAft>
-                <a:spcPts val="150"/>
+                <a:spcPts val="250"/>
               </a:spcAft>
             </a:pPr>
             <a:r>
-              <a:rPr sz="950" b="1">
+              <a:rPr sz="980" b="1">
                 <a:solidFill>
                   <a:srgbClr val="000000"/>
                 </a:solidFill>
@@ -11276,7 +11911,7 @@
               <a:t>•  ISRO &amp; NRSC: </a:t>
             </a:r>
             <a:r>
-              <a:rPr sz="919" b="0">
+              <a:rPr sz="950" b="0">
                 <a:solidFill>
                   <a:srgbClr val="1F2937"/>
                 </a:solidFill>
@@ -11288,11 +11923,11 @@
           <a:p>
             <a:pPr>
               <a:spcAft>
-                <a:spcPts val="150"/>
+                <a:spcPts val="250"/>
               </a:spcAft>
             </a:pPr>
             <a:r>
-              <a:rPr sz="950" b="1">
+              <a:rPr sz="980" b="1">
                 <a:solidFill>
                   <a:srgbClr val="000000"/>
                 </a:solidFill>
@@ -11301,7 +11936,7 @@
               <a:t>•  OpenFreeMap Project: </a:t>
             </a:r>
             <a:r>
-              <a:rPr sz="919" b="0">
+              <a:rPr sz="950" b="0">
                 <a:solidFill>
                   <a:srgbClr val="1F2937"/>
                 </a:solidFill>
@@ -11313,14 +11948,14 @@
           <a:p>
             <a:pPr>
               <a:spcBef>
-                <a:spcPts val="400"/>
+                <a:spcPts val="600"/>
               </a:spcBef>
               <a:spcAft>
-                <a:spcPts val="200"/>
+                <a:spcPts val="250"/>
               </a:spcAft>
             </a:pPr>
             <a:r>
-              <a:rPr sz="1100" b="1">
+              <a:rPr sz="1200" b="1">
                 <a:solidFill>
                   <a:srgbClr val="973835"/>
                 </a:solidFill>
@@ -11332,11 +11967,11 @@
           <a:p>
             <a:pPr>
               <a:spcAft>
-                <a:spcPts val="150"/>
+                <a:spcPts val="250"/>
               </a:spcAft>
             </a:pPr>
             <a:r>
-              <a:rPr sz="950" b="1">
+              <a:rPr sz="980" b="1">
                 <a:solidFill>
                   <a:srgbClr val="000000"/>
                 </a:solidFill>
@@ -11345,7 +11980,7 @@
               <a:t>•  Lukas et al. (IEEE TIFS): </a:t>
             </a:r>
             <a:r>
-              <a:rPr sz="919" b="0">
+              <a:rPr sz="950" b="0">
                 <a:solidFill>
                   <a:srgbClr val="1F2937"/>
                 </a:solidFill>
@@ -11357,11 +11992,11 @@
           <a:p>
             <a:pPr>
               <a:spcAft>
-                <a:spcPts val="150"/>
+                <a:spcPts val="250"/>
               </a:spcAft>
             </a:pPr>
             <a:r>
-              <a:rPr sz="950" b="1">
+              <a:rPr sz="980" b="1">
                 <a:solidFill>
                   <a:srgbClr val="000000"/>
                 </a:solidFill>
@@ -11370,7 +12005,7 @@
               <a:t>•  Corvi et al. (IEEE CVPR): </a:t>
             </a:r>
             <a:r>
-              <a:rPr sz="919" b="0">
+              <a:rPr sz="950" b="0">
                 <a:solidFill>
                   <a:srgbClr val="1F2937"/>
                 </a:solidFill>
@@ -11382,11 +12017,11 @@
           <a:p>
             <a:pPr>
               <a:spcAft>
-                <a:spcPts val="150"/>
+                <a:spcPts val="250"/>
               </a:spcAft>
             </a:pPr>
             <a:r>
-              <a:rPr sz="950" b="1">
+              <a:rPr sz="980" b="1">
                 <a:solidFill>
                   <a:srgbClr val="000000"/>
                 </a:solidFill>
@@ -11395,7 +12030,7 @@
               <a:t>•  NIST FIPS 180-4: </a:t>
             </a:r>
             <a:r>
-              <a:rPr sz="919" b="0">
+              <a:rPr sz="950" b="0">
                 <a:solidFill>
                   <a:srgbClr val="1F2937"/>
                 </a:solidFill>
@@ -11407,11 +12042,11 @@
           <a:p>
             <a:pPr>
               <a:spcAft>
-                <a:spcPts val="150"/>
+                <a:spcPts val="250"/>
               </a:spcAft>
             </a:pPr>
             <a:r>
-              <a:rPr sz="950" b="1">
+              <a:rPr sz="980" b="1">
                 <a:solidFill>
                   <a:srgbClr val="000000"/>
                 </a:solidFill>
@@ -11420,7 +12055,7 @@
               <a:t>•  LoRa Alliance: </a:t>
             </a:r>
             <a:r>
-              <a:rPr sz="919" b="0">
+              <a:rPr sz="950" b="0">
                 <a:solidFill>
                   <a:srgbClr val="1F2937"/>
                 </a:solidFill>

</xml_diff>

<commit_message>
Add cinematic VFX YouTube video explainer for JalDrishti (SIH26031 Team Innova8)
</commit_message>
<xml_diff>
--- a/JalDrishti_SIH2026_Presentation_Final.pptx
+++ b/JalDrishti_SIH2026_Presentation_Final.pptx
@@ -3208,7 +3208,7 @@
         <p:spPr>
           <a:xfrm>
             <a:off x="411480" y="1371600"/>
-            <a:ext cx="6675120" cy="4754880"/>
+            <a:ext cx="6675120" cy="5118324"/>
           </a:xfrm>
           <a:prstGeom prst="rect">
             <a:avLst/>
@@ -3230,7 +3230,7 @@
               </a:defRPr>
             </a:pPr>
             <a:r>
-              <a:rPr sz="1550" b="1">
+              <a:rPr sz="1550" b="1" dirty="0">
                 <a:solidFill>
                   <a:srgbClr val="000000"/>
                 </a:solidFill>
@@ -3239,7 +3239,7 @@
               <a:t>•  Problem Statement ID – </a:t>
             </a:r>
             <a:r>
-              <a:rPr sz="1500" b="0">
+              <a:rPr sz="1500" b="0" dirty="0">
                 <a:solidFill>
                   <a:srgbClr val="1F2937"/>
                 </a:solidFill>
@@ -3255,7 +3255,7 @@
               </a:spcAft>
             </a:pPr>
             <a:r>
-              <a:rPr sz="1550" b="1">
+              <a:rPr sz="1550" b="1" dirty="0">
                 <a:solidFill>
                   <a:srgbClr val="000000"/>
                 </a:solidFill>
@@ -3264,13 +3264,22 @@
               <a:t>•  Problem Statement Title – </a:t>
             </a:r>
             <a:r>
-              <a:rPr sz="1500" b="0">
+              <a:rPr sz="1500" b="0" dirty="0" err="1">
                 <a:solidFill>
                   <a:srgbClr val="1F2937"/>
                 </a:solidFill>
                 <a:latin typeface="Arial"/>
               </a:rPr>
-              <a:t>JalDrishti: AI-Powered Geospatial Watershed Siting, Siltation Tracking &amp; Anti-Fraud Verification</a:t>
+              <a:t>JalDrishti</a:t>
+            </a:r>
+            <a:r>
+              <a:rPr sz="1500" b="0" dirty="0">
+                <a:solidFill>
+                  <a:srgbClr val="1F2937"/>
+                </a:solidFill>
+                <a:latin typeface="Arial"/>
+              </a:rPr>
+              <a:t>: AI-Powered Geospatial Watershed Siting, Siltation Tracking &amp; Anti-Fraud Verification</a:t>
             </a:r>
           </a:p>
           <a:p>
@@ -3280,7 +3289,7 @@
               </a:spcAft>
             </a:pPr>
             <a:r>
-              <a:rPr sz="1550" b="1">
+              <a:rPr sz="1550" b="1" dirty="0">
                 <a:solidFill>
                   <a:srgbClr val="000000"/>
                 </a:solidFill>
@@ -3289,13 +3298,31 @@
               <a:t>•  Theme – </a:t>
             </a:r>
             <a:r>
-              <a:rPr sz="1500" b="0">
+              <a:rPr sz="1500" b="0" dirty="0">
                 <a:solidFill>
                   <a:srgbClr val="1F2937"/>
                 </a:solidFill>
                 <a:latin typeface="Arial"/>
               </a:rPr>
-              <a:t>Agriculture, FoodTech &amp; Rural Development / Smart Automation</a:t>
+              <a:t>Agriculture, </a:t>
+            </a:r>
+            <a:r>
+              <a:rPr sz="1500" b="0" dirty="0" err="1">
+                <a:solidFill>
+                  <a:srgbClr val="1F2937"/>
+                </a:solidFill>
+                <a:latin typeface="Arial"/>
+              </a:rPr>
+              <a:t>FoodTech</a:t>
+            </a:r>
+            <a:r>
+              <a:rPr sz="1500" b="0" dirty="0">
+                <a:solidFill>
+                  <a:srgbClr val="1F2937"/>
+                </a:solidFill>
+                <a:latin typeface="Arial"/>
+              </a:rPr>
+              <a:t> &amp; Rural Development / Smart Automation</a:t>
             </a:r>
           </a:p>
           <a:p>
@@ -3305,7 +3332,7 @@
               </a:spcAft>
             </a:pPr>
             <a:r>
-              <a:rPr sz="1550" b="1">
+              <a:rPr sz="1550" b="1" dirty="0">
                 <a:solidFill>
                   <a:srgbClr val="000000"/>
                 </a:solidFill>
@@ -3314,7 +3341,7 @@
               <a:t>•  PS Category – </a:t>
             </a:r>
             <a:r>
-              <a:rPr sz="1500" b="0">
+              <a:rPr sz="1500" b="0" dirty="0">
                 <a:solidFill>
                   <a:srgbClr val="1F2937"/>
                 </a:solidFill>
@@ -3330,7 +3357,7 @@
               </a:spcAft>
             </a:pPr>
             <a:r>
-              <a:rPr sz="1550" b="1">
+              <a:rPr sz="1550" b="1" dirty="0">
                 <a:solidFill>
                   <a:srgbClr val="000000"/>
                 </a:solidFill>
@@ -3339,7 +3366,7 @@
               <a:t>•  Team ID – </a:t>
             </a:r>
             <a:r>
-              <a:rPr sz="1500" b="0">
+              <a:rPr sz="1500" b="0" dirty="0">
                 <a:solidFill>
                   <a:srgbClr val="1F2937"/>
                 </a:solidFill>
@@ -3355,7 +3382,7 @@
               </a:spcAft>
             </a:pPr>
             <a:r>
-              <a:rPr sz="1550" b="1">
+              <a:rPr sz="1550" b="1" dirty="0">
                 <a:solidFill>
                   <a:srgbClr val="000000"/>
                 </a:solidFill>
@@ -3364,7 +3391,7 @@
               <a:t>•  Team Name – </a:t>
             </a:r>
             <a:r>
-              <a:rPr sz="1500" b="0">
+              <a:rPr sz="1500" b="0" dirty="0">
                 <a:solidFill>
                   <a:srgbClr val="1F2937"/>
                 </a:solidFill>
@@ -3372,6 +3399,144 @@
               </a:rPr>
               <a:t>Innova8</a:t>
             </a:r>
+            <a:endParaRPr lang="en-US" sz="1500" b="0" dirty="0">
+              <a:solidFill>
+                <a:srgbClr val="1F2937"/>
+              </a:solidFill>
+              <a:latin typeface="Arial"/>
+            </a:endParaRPr>
+          </a:p>
+          <a:p>
+            <a:pPr marL="285750" indent="-285750">
+              <a:spcAft>
+                <a:spcPts val="1100"/>
+              </a:spcAft>
+              <a:buFont typeface="Arial" panose="020B0604020202020204" pitchFamily="34" charset="0"/>
+              <a:buChar char="•"/>
+            </a:pPr>
+            <a:r>
+              <a:rPr lang="en-IN" sz="1500" b="1" dirty="0">
+                <a:solidFill>
+                  <a:srgbClr val="1F2937"/>
+                </a:solidFill>
+                <a:latin typeface="Arial"/>
+              </a:rPr>
+              <a:t>Team Members </a:t>
+            </a:r>
+          </a:p>
+          <a:p>
+            <a:pPr marL="285750" indent="-285750">
+              <a:spcAft>
+                <a:spcPts val="1100"/>
+              </a:spcAft>
+              <a:buFont typeface="Arial" panose="020B0604020202020204" pitchFamily="34" charset="0"/>
+              <a:buChar char="•"/>
+            </a:pPr>
+            <a:r>
+              <a:rPr lang="en-IN" sz="1500" dirty="0">
+                <a:solidFill>
+                  <a:srgbClr val="1F2937"/>
+                </a:solidFill>
+                <a:latin typeface="Arial"/>
+              </a:rPr>
+              <a:t>Karthik Prakash – 25070126088</a:t>
+            </a:r>
+          </a:p>
+          <a:p>
+            <a:pPr marL="285750" indent="-285750">
+              <a:spcAft>
+                <a:spcPts val="1100"/>
+              </a:spcAft>
+              <a:buFont typeface="Arial" panose="020B0604020202020204" pitchFamily="34" charset="0"/>
+              <a:buChar char="•"/>
+            </a:pPr>
+            <a:r>
+              <a:rPr lang="en-IN" sz="1500" b="0" dirty="0">
+                <a:solidFill>
+                  <a:srgbClr val="1F2937"/>
+                </a:solidFill>
+                <a:latin typeface="Arial"/>
+              </a:rPr>
+              <a:t>Kushal Shah - 25070125097</a:t>
+            </a:r>
+          </a:p>
+          <a:p>
+            <a:pPr marL="285750" indent="-285750">
+              <a:spcAft>
+                <a:spcPts val="1100"/>
+              </a:spcAft>
+              <a:buFont typeface="Arial" panose="020B0604020202020204" pitchFamily="34" charset="0"/>
+              <a:buChar char="•"/>
+            </a:pPr>
+            <a:r>
+              <a:rPr lang="en-IN" sz="1500" dirty="0">
+                <a:solidFill>
+                  <a:srgbClr val="1F2937"/>
+                </a:solidFill>
+                <a:latin typeface="Arial"/>
+              </a:rPr>
+              <a:t>Mannat Tanda - 25070126107</a:t>
+            </a:r>
+          </a:p>
+          <a:p>
+            <a:pPr marL="285750" indent="-285750">
+              <a:spcAft>
+                <a:spcPts val="1100"/>
+              </a:spcAft>
+              <a:buFont typeface="Arial" panose="020B0604020202020204" pitchFamily="34" charset="0"/>
+              <a:buChar char="•"/>
+            </a:pPr>
+            <a:r>
+              <a:rPr lang="en-IN" sz="1500" b="0" dirty="0">
+                <a:solidFill>
+                  <a:srgbClr val="1F2937"/>
+                </a:solidFill>
+                <a:latin typeface="Arial"/>
+              </a:rPr>
+              <a:t>Nirvan Joneja - 25070126117</a:t>
+            </a:r>
+          </a:p>
+          <a:p>
+            <a:pPr marL="285750" indent="-285750">
+              <a:spcAft>
+                <a:spcPts val="1100"/>
+              </a:spcAft>
+              <a:buFont typeface="Arial" panose="020B0604020202020204" pitchFamily="34" charset="0"/>
+              <a:buChar char="•"/>
+            </a:pPr>
+            <a:r>
+              <a:rPr lang="en-IN" sz="1500" dirty="0">
+                <a:solidFill>
+                  <a:srgbClr val="1F2937"/>
+                </a:solidFill>
+                <a:latin typeface="Arial"/>
+              </a:rPr>
+              <a:t>Siddhant Sinha - 25070123109</a:t>
+            </a:r>
+          </a:p>
+          <a:p>
+            <a:pPr marL="285750" indent="-285750">
+              <a:spcAft>
+                <a:spcPts val="1100"/>
+              </a:spcAft>
+              <a:buFont typeface="Arial" panose="020B0604020202020204" pitchFamily="34" charset="0"/>
+              <a:buChar char="•"/>
+            </a:pPr>
+            <a:r>
+              <a:rPr lang="en-IN" sz="1500" b="0" dirty="0">
+                <a:solidFill>
+                  <a:srgbClr val="1F2937"/>
+                </a:solidFill>
+                <a:latin typeface="Arial"/>
+              </a:rPr>
+              <a:t>Alisha Mittal - 25070126214</a:t>
+            </a:r>
+            <a:endParaRPr sz="1500" b="0" dirty="0">
+              <a:solidFill>
+                <a:srgbClr val="1F2937"/>
+              </a:solidFill>
+              <a:latin typeface="Arial"/>
+            </a:endParaRPr>
           </a:p>
         </p:txBody>
       </p:sp>
@@ -3661,7 +3826,7 @@
           <a:noFill/>
         </p:spPr>
         <p:txBody>
-          <a:bodyPr wrap="square" lIns="36576" rIns="36576" tIns="27432" bIns="27432">
+          <a:bodyPr wrap="square" lIns="36576" tIns="27432" rIns="36576" bIns="27432">
             <a:spAutoFit/>
           </a:bodyPr>
           <a:lstStyle/>
@@ -3703,7 +3868,7 @@
           <a:noFill/>
         </p:spPr>
         <p:txBody>
-          <a:bodyPr wrap="square" lIns="36576" rIns="36576" tIns="27432" bIns="27432">
+          <a:bodyPr wrap="square" lIns="36576" tIns="27432" rIns="36576" bIns="27432">
             <a:spAutoFit/>
           </a:bodyPr>
           <a:lstStyle/>
@@ -3766,7 +3931,7 @@
           </a:fontRef>
         </p:style>
         <p:txBody>
-          <a:bodyPr rtlCol="0" anchor="ctr" wrap="square" lIns="36576" rIns="36576" tIns="27432" bIns="27432"/>
+          <a:bodyPr wrap="square" lIns="36576" tIns="27432" rIns="36576" bIns="27432" rtlCol="0" anchor="ctr"/>
           <a:lstStyle/>
           <a:p>
             <a:pPr algn="ctr">
@@ -3822,7 +3987,7 @@
         <p:spPr>
           <a:xfrm>
             <a:off x="914400" y="1627632"/>
-            <a:ext cx="4937760" cy="621792"/>
+            <a:ext cx="4937760" cy="406265"/>
           </a:xfrm>
           <a:prstGeom prst="rect">
             <a:avLst/>
@@ -3830,13 +3995,13 @@
           <a:noFill/>
         </p:spPr>
         <p:txBody>
-          <a:bodyPr wrap="square" tIns="18288" lIns="18288" rIns="18288" bIns="18288">
+          <a:bodyPr wrap="square" lIns="18288" tIns="18288" rIns="18288" bIns="18288">
             <a:spAutoFit/>
           </a:bodyPr>
           <a:lstStyle/>
           <a:p>
             <a:r>
-              <a:rPr sz="1000" b="1">
+              <a:rPr sz="1200" b="1" dirty="0">
                 <a:solidFill>
                   <a:srgbClr val="1E3A8A"/>
                 </a:solidFill>
@@ -3845,13 +4010,22 @@
               <a:t>Full-Viewport Vector GIS: </a:t>
             </a:r>
             <a:r>
-              <a:rPr sz="880" b="0">
+              <a:rPr sz="1200" b="0" dirty="0" err="1">
                 <a:solidFill>
                   <a:srgbClr val="1F2937"/>
                 </a:solidFill>
                 <a:latin typeface="Arial"/>
               </a:rPr>
-              <a:t>OpenFreeMap sub-meter vector tile hydrology engine mapping micro-catchments &amp; Strahler streams.</a:t>
+              <a:t>OpenFreeMap</a:t>
+            </a:r>
+            <a:r>
+              <a:rPr sz="1200" b="0" dirty="0">
+                <a:solidFill>
+                  <a:srgbClr val="1F2937"/>
+                </a:solidFill>
+                <a:latin typeface="Arial"/>
+              </a:rPr>
+              <a:t> sub-meter vector tile hydrology engine mapping micro-catchments &amp; Strahler streams.</a:t>
             </a:r>
           </a:p>
         </p:txBody>
@@ -3889,7 +4063,7 @@
         <p:spPr>
           <a:xfrm>
             <a:off x="914400" y="2267712"/>
-            <a:ext cx="4937760" cy="621792"/>
+            <a:ext cx="4937760" cy="406265"/>
           </a:xfrm>
           <a:prstGeom prst="rect">
             <a:avLst/>
@@ -3897,13 +4071,13 @@
           <a:noFill/>
         </p:spPr>
         <p:txBody>
-          <a:bodyPr wrap="square" tIns="18288" lIns="18288" rIns="18288" bIns="18288">
+          <a:bodyPr wrap="square" lIns="18288" tIns="18288" rIns="18288" bIns="18288">
             <a:spAutoFit/>
           </a:bodyPr>
           <a:lstStyle/>
           <a:p>
             <a:r>
-              <a:rPr sz="1000" b="1">
+              <a:rPr sz="1200" b="1" dirty="0">
                 <a:solidFill>
                   <a:srgbClr val="1E3A8A"/>
                 </a:solidFill>
@@ -3912,13 +4086,22 @@
               <a:t>AI Siting Optimizer: </a:t>
             </a:r>
             <a:r>
-              <a:rPr sz="880" b="0">
+              <a:rPr sz="1200" b="0" dirty="0">
                 <a:solidFill>
                   <a:srgbClr val="1F2937"/>
                 </a:solidFill>
                 <a:latin typeface="Arial"/>
               </a:rPr>
-              <a:t>Automated DEM slope %, catchment ha &amp; runoff yield modeling for 0–100% check-dam suitability.</a:t>
+              <a:t>Automated DEM slope %, catchment ha &amp; runoff yield modeling for 0–100% check-dam suitability</a:t>
+            </a:r>
+            <a:r>
+              <a:rPr sz="880" b="0" dirty="0">
+                <a:solidFill>
+                  <a:srgbClr val="1F2937"/>
+                </a:solidFill>
+                <a:latin typeface="Arial"/>
+              </a:rPr>
+              <a:t>.</a:t>
             </a:r>
           </a:p>
         </p:txBody>
@@ -3956,7 +4139,7 @@
         <p:spPr>
           <a:xfrm>
             <a:off x="914400" y="2907791"/>
-            <a:ext cx="4937760" cy="621792"/>
+            <a:ext cx="4937760" cy="406265"/>
           </a:xfrm>
           <a:prstGeom prst="rect">
             <a:avLst/>
@@ -3964,13 +4147,13 @@
           <a:noFill/>
         </p:spPr>
         <p:txBody>
-          <a:bodyPr wrap="square" tIns="18288" lIns="18288" rIns="18288" bIns="18288">
+          <a:bodyPr wrap="square" lIns="18288" tIns="18288" rIns="18288" bIns="18288">
             <a:spAutoFit/>
           </a:bodyPr>
           <a:lstStyle/>
           <a:p>
             <a:r>
-              <a:rPr sz="1000" b="1">
+              <a:rPr sz="1200" b="1" dirty="0">
                 <a:solidFill>
                   <a:srgbClr val="1E3A8A"/>
                 </a:solidFill>
@@ -3979,7 +4162,7 @@
               <a:t>Multi-Layer Neural Forensics: </a:t>
             </a:r>
             <a:r>
-              <a:rPr sz="880" b="0">
+              <a:rPr sz="1200" b="0" dirty="0">
                 <a:solidFill>
                   <a:srgbClr val="1F2937"/>
                 </a:solidFill>
@@ -4023,7 +4206,7 @@
         <p:spPr>
           <a:xfrm>
             <a:off x="914400" y="3547872"/>
-            <a:ext cx="4937760" cy="621792"/>
+            <a:ext cx="4937760" cy="406265"/>
           </a:xfrm>
           <a:prstGeom prst="rect">
             <a:avLst/>
@@ -4031,13 +4214,13 @@
           <a:noFill/>
         </p:spPr>
         <p:txBody>
-          <a:bodyPr wrap="square" tIns="18288" lIns="18288" rIns="18288" bIns="18288">
+          <a:bodyPr wrap="square" lIns="18288" tIns="18288" rIns="18288" bIns="18288">
             <a:spAutoFit/>
           </a:bodyPr>
           <a:lstStyle/>
           <a:p>
             <a:r>
-              <a:rPr sz="1000" b="1">
+              <a:rPr sz="1200" b="1" dirty="0">
                 <a:solidFill>
                   <a:srgbClr val="1E3A8A"/>
                 </a:solidFill>
@@ -4046,13 +4229,31 @@
               <a:t>Live IoT Mesh &amp; Satellite: </a:t>
             </a:r>
             <a:r>
-              <a:rPr sz="880" b="0">
+              <a:rPr sz="1200" b="0" dirty="0">
                 <a:solidFill>
                   <a:srgbClr val="1F2937"/>
                 </a:solidFill>
                 <a:latin typeface="Arial"/>
               </a:rPr>
-              <a:t>Real-time LoRaWAN/4G telemetry for groundwater &amp; silt alerts + Sentinel-2 5-season NDVI playback.</a:t>
+              <a:t>Real-time </a:t>
+            </a:r>
+            <a:r>
+              <a:rPr sz="1200" b="0" dirty="0" err="1">
+                <a:solidFill>
+                  <a:srgbClr val="1F2937"/>
+                </a:solidFill>
+                <a:latin typeface="Arial"/>
+              </a:rPr>
+              <a:t>LoRaWAN</a:t>
+            </a:r>
+            <a:r>
+              <a:rPr sz="1200" b="0" dirty="0">
+                <a:solidFill>
+                  <a:srgbClr val="1F2937"/>
+                </a:solidFill>
+                <a:latin typeface="Arial"/>
+              </a:rPr>
+              <a:t>/4G telemetry for groundwater &amp; silt alerts + Sentinel-2 5-season NDVI playback.</a:t>
             </a:r>
           </a:p>
         </p:txBody>
@@ -4063,11 +4264,17 @@
           <p:cNvGraphicFramePr>
             <a:graphicFrameLocks noGrp="1"/>
           </p:cNvGraphicFramePr>
-          <p:nvPr/>
+          <p:nvPr>
+            <p:extLst>
+              <p:ext uri="{D42A27DB-BD31-4B8C-83A1-F6EECF244321}">
+                <p14:modId xmlns:p14="http://schemas.microsoft.com/office/powerpoint/2010/main" val="1579903669"/>
+              </p:ext>
+            </p:extLst>
+          </p:nvPr>
         </p:nvGraphicFramePr>
         <p:xfrm>
           <a:off x="6126480" y="1051560"/>
-          <a:ext cx="5669280" cy="3108960"/>
+          <a:ext cx="5669280" cy="3107485"/>
         </p:xfrm>
         <a:graphic>
           <a:graphicData uri="http://schemas.openxmlformats.org/drawingml/2006/table">
@@ -4094,7 +4301,7 @@
               <a:tr h="621792">
                 <a:tc>
                   <a:txBody>
-                    <a:bodyPr wrap="square" lIns="45720" rIns="45720" tIns="27432" bIns="27432"/>
+                    <a:bodyPr/>
                     <a:lstStyle/>
                     <a:p>
                       <a:pPr>
@@ -4124,7 +4331,7 @@
                 </a:tc>
                 <a:tc>
                   <a:txBody>
-                    <a:bodyPr wrap="square" lIns="45720" rIns="45720" tIns="27432" bIns="27432"/>
+                    <a:bodyPr/>
                     <a:lstStyle/>
                     <a:p>
                       <a:pPr>
@@ -4161,7 +4368,7 @@
               <a:tr h="621792">
                 <a:tc>
                   <a:txBody>
-                    <a:bodyPr wrap="square" lIns="45720" rIns="45720" tIns="27432" bIns="27432"/>
+                    <a:bodyPr/>
                     <a:lstStyle/>
                     <a:p>
                       <a:pPr>
@@ -4173,7 +4380,7 @@
                         </a:defRPr>
                       </a:pPr>
                       <a:r>
-                        <a:rPr sz="819" b="0">
+                        <a:rPr sz="1000" b="0">
                           <a:solidFill>
                             <a:srgbClr val="1F2937"/>
                           </a:solidFill>
@@ -4191,7 +4398,7 @@
                 </a:tc>
                 <a:tc>
                   <a:txBody>
-                    <a:bodyPr wrap="square" lIns="45720" rIns="45720" tIns="27432" bIns="27432"/>
+                    <a:bodyPr/>
                     <a:lstStyle/>
                     <a:p>
                       <a:pPr>
@@ -4203,7 +4410,7 @@
                         </a:defRPr>
                       </a:pPr>
                       <a:r>
-                        <a:rPr sz="819" b="0">
+                        <a:rPr sz="1000" b="0">
                           <a:solidFill>
                             <a:srgbClr val="973835"/>
                           </a:solidFill>
@@ -4228,7 +4435,7 @@
               <a:tr h="621792">
                 <a:tc>
                   <a:txBody>
-                    <a:bodyPr wrap="square" lIns="45720" rIns="45720" tIns="27432" bIns="27432"/>
+                    <a:bodyPr/>
                     <a:lstStyle/>
                     <a:p>
                       <a:pPr>
@@ -4240,7 +4447,7 @@
                         </a:defRPr>
                       </a:pPr>
                       <a:r>
-                        <a:rPr sz="819" b="0">
+                        <a:rPr sz="1000" b="0">
                           <a:solidFill>
                             <a:srgbClr val="1F2937"/>
                           </a:solidFill>
@@ -4258,7 +4465,7 @@
                 </a:tc>
                 <a:tc>
                   <a:txBody>
-                    <a:bodyPr wrap="square" lIns="45720" rIns="45720" tIns="27432" bIns="27432"/>
+                    <a:bodyPr/>
                     <a:lstStyle/>
                     <a:p>
                       <a:pPr>
@@ -4270,7 +4477,7 @@
                         </a:defRPr>
                       </a:pPr>
                       <a:r>
-                        <a:rPr sz="819" b="0">
+                        <a:rPr sz="1000" b="0">
                           <a:solidFill>
                             <a:srgbClr val="973835"/>
                           </a:solidFill>
@@ -4295,7 +4502,7 @@
               <a:tr h="621792">
                 <a:tc>
                   <a:txBody>
-                    <a:bodyPr wrap="square" lIns="45720" rIns="45720" tIns="27432" bIns="27432"/>
+                    <a:bodyPr/>
                     <a:lstStyle/>
                     <a:p>
                       <a:pPr>
@@ -4307,7 +4514,7 @@
                         </a:defRPr>
                       </a:pPr>
                       <a:r>
-                        <a:rPr sz="819" b="0">
+                        <a:rPr sz="1000" b="0">
                           <a:solidFill>
                             <a:srgbClr val="1F2937"/>
                           </a:solidFill>
@@ -4325,7 +4532,7 @@
                 </a:tc>
                 <a:tc>
                   <a:txBody>
-                    <a:bodyPr wrap="square" lIns="45720" rIns="45720" tIns="27432" bIns="27432"/>
+                    <a:bodyPr/>
                     <a:lstStyle/>
                     <a:p>
                       <a:pPr>
@@ -4337,7 +4544,7 @@
                         </a:defRPr>
                       </a:pPr>
                       <a:r>
-                        <a:rPr sz="819" b="0">
+                        <a:rPr sz="1000" b="0">
                           <a:solidFill>
                             <a:srgbClr val="973835"/>
                           </a:solidFill>
@@ -4359,10 +4566,10 @@
                   </a:ext>
                 </a:extLst>
               </a:tr>
-              <a:tr h="621792">
+              <a:tr h="620317">
                 <a:tc>
                   <a:txBody>
-                    <a:bodyPr wrap="square" lIns="45720" rIns="45720" tIns="27432" bIns="27432"/>
+                    <a:bodyPr/>
                     <a:lstStyle/>
                     <a:p>
                       <a:pPr>
@@ -4374,7 +4581,7 @@
                         </a:defRPr>
                       </a:pPr>
                       <a:r>
-                        <a:rPr sz="819" b="0">
+                        <a:rPr sz="1000" b="0" dirty="0">
                           <a:solidFill>
                             <a:srgbClr val="1F2937"/>
                           </a:solidFill>
@@ -4392,7 +4599,7 @@
                 </a:tc>
                 <a:tc>
                   <a:txBody>
-                    <a:bodyPr wrap="square" lIns="45720" rIns="45720" tIns="27432" bIns="27432"/>
+                    <a:bodyPr/>
                     <a:lstStyle/>
                     <a:p>
                       <a:pPr>
@@ -4404,7 +4611,7 @@
                         </a:defRPr>
                       </a:pPr>
                       <a:r>
-                        <a:rPr sz="819" b="0">
+                        <a:rPr sz="1000" b="0" dirty="0">
                           <a:solidFill>
                             <a:srgbClr val="973835"/>
                           </a:solidFill>
@@ -4512,7 +4719,7 @@
           </a:fontRef>
         </p:style>
         <p:txBody>
-          <a:bodyPr rtlCol="0" anchor="ctr" wrap="square" lIns="36576" rIns="36576" tIns="27432" bIns="27432"/>
+          <a:bodyPr wrap="square" lIns="36576" tIns="27432" rIns="36576" bIns="27432" rtlCol="0" anchor="ctr"/>
           <a:lstStyle/>
           <a:p>
             <a:pPr algn="ctr">
@@ -4544,7 +4751,7 @@
         <p:spPr>
           <a:xfrm>
             <a:off x="457200" y="4846320"/>
-            <a:ext cx="2011680" cy="1280160"/>
+            <a:ext cx="2011680" cy="1151084"/>
           </a:xfrm>
           <a:prstGeom prst="rect">
             <a:avLst/>
@@ -4552,7 +4759,7 @@
           <a:noFill/>
         </p:spPr>
         <p:txBody>
-          <a:bodyPr wrap="square" lIns="36576" rIns="36576" tIns="36576" bIns="36576">
+          <a:bodyPr wrap="square" lIns="36576" tIns="36576" rIns="36576" bIns="36576">
             <a:spAutoFit/>
           </a:bodyPr>
           <a:lstStyle/>
@@ -4569,13 +4776,22 @@
               </a:defRPr>
             </a:pPr>
             <a:r>
-              <a:rPr sz="800" b="0">
+              <a:rPr sz="800" b="0" dirty="0">
                 <a:solidFill>
                   <a:srgbClr val="1F2937"/>
                 </a:solidFill>
                 <a:latin typeface="Arial"/>
               </a:rPr>
-              <a:t>• Sub-meter vector basin delineation</a:t>
+              <a:t>• </a:t>
+            </a:r>
+            <a:r>
+              <a:rPr sz="1000" b="0" dirty="0">
+                <a:solidFill>
+                  <a:srgbClr val="1F2937"/>
+                </a:solidFill>
+                <a:latin typeface="Arial"/>
+              </a:rPr>
+              <a:t>Sub-meter vector basin delineation</a:t>
             </a:r>
           </a:p>
           <a:p>
@@ -4585,7 +4801,7 @@
               </a:spcAft>
             </a:pPr>
             <a:r>
-              <a:rPr sz="800" b="0">
+              <a:rPr sz="1000" b="0" dirty="0">
                 <a:solidFill>
                   <a:srgbClr val="1F2937"/>
                 </a:solidFill>
@@ -4601,7 +4817,7 @@
               </a:spcAft>
             </a:pPr>
             <a:r>
-              <a:rPr sz="800" b="0">
+              <a:rPr sz="1000" b="0" dirty="0">
                 <a:solidFill>
                   <a:srgbClr val="1F2937"/>
                 </a:solidFill>
@@ -4617,7 +4833,7 @@
               </a:spcAft>
             </a:pPr>
             <a:r>
-              <a:rPr sz="800" b="0">
+              <a:rPr sz="1000" b="0" dirty="0">
                 <a:solidFill>
                   <a:srgbClr val="1F2937"/>
                 </a:solidFill>
@@ -4710,7 +4926,7 @@
           </a:fontRef>
         </p:style>
         <p:txBody>
-          <a:bodyPr rtlCol="0" anchor="ctr" wrap="square" lIns="36576" rIns="36576" tIns="27432" bIns="27432"/>
+          <a:bodyPr wrap="square" lIns="36576" tIns="27432" rIns="36576" bIns="27432" rtlCol="0" anchor="ctr"/>
           <a:lstStyle/>
           <a:p>
             <a:pPr algn="ctr">
@@ -4742,7 +4958,7 @@
         <p:spPr>
           <a:xfrm>
             <a:off x="2761488" y="4846320"/>
-            <a:ext cx="2011680" cy="1280160"/>
+            <a:ext cx="2011680" cy="1304973"/>
           </a:xfrm>
           <a:prstGeom prst="rect">
             <a:avLst/>
@@ -4750,7 +4966,7 @@
           <a:noFill/>
         </p:spPr>
         <p:txBody>
-          <a:bodyPr wrap="square" lIns="36576" rIns="36576" tIns="36576" bIns="36576">
+          <a:bodyPr wrap="square" lIns="36576" tIns="36576" rIns="36576" bIns="36576">
             <a:spAutoFit/>
           </a:bodyPr>
           <a:lstStyle/>
@@ -4767,13 +4983,22 @@
               </a:defRPr>
             </a:pPr>
             <a:r>
-              <a:rPr sz="800" b="0">
+              <a:rPr sz="800" b="0" dirty="0">
                 <a:solidFill>
                   <a:srgbClr val="1F2937"/>
                 </a:solidFill>
                 <a:latin typeface="Arial"/>
               </a:rPr>
-              <a:t>• Algorithmic 3%-12% slope gradient</a:t>
+              <a:t>• Al</a:t>
+            </a:r>
+            <a:r>
+              <a:rPr sz="1000" b="0" dirty="0">
+                <a:solidFill>
+                  <a:srgbClr val="1F2937"/>
+                </a:solidFill>
+                <a:latin typeface="Arial"/>
+              </a:rPr>
+              <a:t>gorithmic 3%-12% slope gradient</a:t>
             </a:r>
           </a:p>
           <a:p>
@@ -4783,7 +5008,7 @@
               </a:spcAft>
             </a:pPr>
             <a:r>
-              <a:rPr sz="800" b="0">
+              <a:rPr sz="1000" b="0" dirty="0">
                 <a:solidFill>
                   <a:srgbClr val="1F2937"/>
                 </a:solidFill>
@@ -4799,7 +5024,7 @@
               </a:spcAft>
             </a:pPr>
             <a:r>
-              <a:rPr sz="800" b="0">
+              <a:rPr sz="1000" b="0" dirty="0">
                 <a:solidFill>
                   <a:srgbClr val="1F2937"/>
                 </a:solidFill>
@@ -4815,7 +5040,7 @@
               </a:spcAft>
             </a:pPr>
             <a:r>
-              <a:rPr sz="800" b="0">
+              <a:rPr sz="1000" b="0" dirty="0">
                 <a:solidFill>
                   <a:srgbClr val="1F2937"/>
                 </a:solidFill>
@@ -4908,7 +5133,7 @@
           </a:fontRef>
         </p:style>
         <p:txBody>
-          <a:bodyPr rtlCol="0" anchor="ctr" wrap="square" lIns="36576" rIns="36576" tIns="27432" bIns="27432"/>
+          <a:bodyPr wrap="square" lIns="36576" tIns="27432" rIns="36576" bIns="27432" rtlCol="0" anchor="ctr"/>
           <a:lstStyle/>
           <a:p>
             <a:pPr algn="ctr">
@@ -4940,7 +5165,7 @@
         <p:spPr>
           <a:xfrm>
             <a:off x="5065776" y="4846320"/>
-            <a:ext cx="2011680" cy="1280160"/>
+            <a:ext cx="2011680" cy="1151084"/>
           </a:xfrm>
           <a:prstGeom prst="rect">
             <a:avLst/>
@@ -4948,7 +5173,7 @@
           <a:noFill/>
         </p:spPr>
         <p:txBody>
-          <a:bodyPr wrap="square" lIns="36576" rIns="36576" tIns="36576" bIns="36576">
+          <a:bodyPr wrap="square" lIns="36576" tIns="36576" rIns="36576" bIns="36576">
             <a:spAutoFit/>
           </a:bodyPr>
           <a:lstStyle/>
@@ -4965,13 +5190,22 @@
               </a:defRPr>
             </a:pPr>
             <a:r>
-              <a:rPr sz="800" b="0">
+              <a:rPr sz="800" b="0" dirty="0">
                 <a:solidFill>
                   <a:srgbClr val="1F2937"/>
                 </a:solidFill>
                 <a:latin typeface="Arial"/>
               </a:rPr>
-              <a:t>• Mobile geo-tagged photo capture</a:t>
+              <a:t>• </a:t>
+            </a:r>
+            <a:r>
+              <a:rPr sz="1000" b="0" dirty="0">
+                <a:solidFill>
+                  <a:srgbClr val="1F2937"/>
+                </a:solidFill>
+                <a:latin typeface="Arial"/>
+              </a:rPr>
+              <a:t>Mobile geo-tagged photo capture</a:t>
             </a:r>
           </a:p>
           <a:p>
@@ -4981,7 +5215,7 @@
               </a:spcAft>
             </a:pPr>
             <a:r>
-              <a:rPr sz="800" b="0">
+              <a:rPr sz="1000" b="0" dirty="0">
                 <a:solidFill>
                   <a:srgbClr val="1F2937"/>
                 </a:solidFill>
@@ -4997,7 +5231,7 @@
               </a:spcAft>
             </a:pPr>
             <a:r>
-              <a:rPr sz="800" b="0">
+              <a:rPr sz="1000" b="0" dirty="0">
                 <a:solidFill>
                   <a:srgbClr val="1F2937"/>
                 </a:solidFill>
@@ -5013,7 +5247,7 @@
               </a:spcAft>
             </a:pPr>
             <a:r>
-              <a:rPr sz="800" b="0">
+              <a:rPr sz="1000" b="0" dirty="0">
                 <a:solidFill>
                   <a:srgbClr val="1F2937"/>
                 </a:solidFill>
@@ -5106,7 +5340,7 @@
           </a:fontRef>
         </p:style>
         <p:txBody>
-          <a:bodyPr rtlCol="0" anchor="ctr" wrap="square" lIns="36576" rIns="36576" tIns="27432" bIns="27432"/>
+          <a:bodyPr wrap="square" lIns="36576" tIns="27432" rIns="36576" bIns="27432" rtlCol="0" anchor="ctr"/>
           <a:lstStyle/>
           <a:p>
             <a:pPr algn="ctr">
@@ -5138,7 +5372,7 @@
         <p:spPr>
           <a:xfrm>
             <a:off x="7370064" y="4846320"/>
-            <a:ext cx="2011680" cy="1280160"/>
+            <a:ext cx="2011680" cy="1458861"/>
           </a:xfrm>
           <a:prstGeom prst="rect">
             <a:avLst/>
@@ -5146,7 +5380,7 @@
           <a:noFill/>
         </p:spPr>
         <p:txBody>
-          <a:bodyPr wrap="square" lIns="36576" rIns="36576" tIns="36576" bIns="36576">
+          <a:bodyPr wrap="square" lIns="36576" tIns="36576" rIns="36576" bIns="36576">
             <a:spAutoFit/>
           </a:bodyPr>
           <a:lstStyle/>
@@ -5163,13 +5397,22 @@
               </a:defRPr>
             </a:pPr>
             <a:r>
-              <a:rPr sz="800" b="0">
+              <a:rPr sz="800" b="0" dirty="0">
                 <a:solidFill>
                   <a:srgbClr val="1F2937"/>
                 </a:solidFill>
                 <a:latin typeface="Arial"/>
               </a:rPr>
-              <a:t>• CMOS Bayer photon noise analysis</a:t>
+              <a:t>• </a:t>
+            </a:r>
+            <a:r>
+              <a:rPr sz="1000" b="0" dirty="0">
+                <a:solidFill>
+                  <a:srgbClr val="1F2937"/>
+                </a:solidFill>
+                <a:latin typeface="Arial"/>
+              </a:rPr>
+              <a:t>CMOS Bayer photon noise analysis</a:t>
             </a:r>
           </a:p>
           <a:p>
@@ -5179,7 +5422,7 @@
               </a:spcAft>
             </a:pPr>
             <a:r>
-              <a:rPr sz="800" b="0">
+              <a:rPr sz="1000" b="0" dirty="0">
                 <a:solidFill>
                   <a:srgbClr val="1F2937"/>
                 </a:solidFill>
@@ -5195,7 +5438,7 @@
               </a:spcAft>
             </a:pPr>
             <a:r>
-              <a:rPr sz="800" b="0">
+              <a:rPr sz="1000" b="0" dirty="0">
                 <a:solidFill>
                   <a:srgbClr val="1F2937"/>
                 </a:solidFill>
@@ -5211,7 +5454,7 @@
               </a:spcAft>
             </a:pPr>
             <a:r>
-              <a:rPr sz="800" b="0">
+              <a:rPr sz="1000" b="0" dirty="0">
                 <a:solidFill>
                   <a:srgbClr val="1F2937"/>
                 </a:solidFill>
@@ -5304,7 +5547,7 @@
           </a:fontRef>
         </p:style>
         <p:txBody>
-          <a:bodyPr rtlCol="0" anchor="ctr" wrap="square" lIns="36576" rIns="36576" tIns="27432" bIns="27432"/>
+          <a:bodyPr wrap="square" lIns="36576" tIns="27432" rIns="36576" bIns="27432" rtlCol="0" anchor="ctr"/>
           <a:lstStyle/>
           <a:p>
             <a:pPr algn="ctr">
@@ -5336,7 +5579,7 @@
         <p:spPr>
           <a:xfrm>
             <a:off x="9674352" y="4846320"/>
-            <a:ext cx="2011680" cy="1280160"/>
+            <a:ext cx="2011680" cy="1458861"/>
           </a:xfrm>
           <a:prstGeom prst="rect">
             <a:avLst/>
@@ -5344,7 +5587,7 @@
           <a:noFill/>
         </p:spPr>
         <p:txBody>
-          <a:bodyPr wrap="square" lIns="36576" rIns="36576" tIns="36576" bIns="36576">
+          <a:bodyPr wrap="square" lIns="36576" tIns="36576" rIns="36576" bIns="36576">
             <a:spAutoFit/>
           </a:bodyPr>
           <a:lstStyle/>
@@ -5361,7 +5604,7 @@
               </a:defRPr>
             </a:pPr>
             <a:r>
-              <a:rPr sz="800" b="0">
+              <a:rPr sz="1000" b="0" dirty="0">
                 <a:solidFill>
                   <a:srgbClr val="1F2937"/>
                 </a:solidFill>
@@ -5377,13 +5620,31 @@
               </a:spcAft>
             </a:pPr>
             <a:r>
-              <a:rPr sz="800" b="0">
+              <a:rPr sz="1000" b="0" dirty="0">
                 <a:solidFill>
                   <a:srgbClr val="1F2937"/>
                 </a:solidFill>
                 <a:latin typeface="Arial"/>
               </a:rPr>
-              <a:t>• Continuous LoRaWAN water telemetry</a:t>
+              <a:t>• Continuous </a:t>
+            </a:r>
+            <a:r>
+              <a:rPr sz="1000" b="0" dirty="0" err="1">
+                <a:solidFill>
+                  <a:srgbClr val="1F2937"/>
+                </a:solidFill>
+                <a:latin typeface="Arial"/>
+              </a:rPr>
+              <a:t>LoRaWAN</a:t>
+            </a:r>
+            <a:r>
+              <a:rPr sz="1000" b="0" dirty="0">
+                <a:solidFill>
+                  <a:srgbClr val="1F2937"/>
+                </a:solidFill>
+                <a:latin typeface="Arial"/>
+              </a:rPr>
+              <a:t> water telemetry</a:t>
             </a:r>
           </a:p>
           <a:p>
@@ -5393,7 +5654,7 @@
               </a:spcAft>
             </a:pPr>
             <a:r>
-              <a:rPr sz="800" b="0">
+              <a:rPr sz="1000" b="0" dirty="0">
                 <a:solidFill>
                   <a:srgbClr val="1F2937"/>
                 </a:solidFill>
@@ -5409,7 +5670,7 @@
               </a:spcAft>
             </a:pPr>
             <a:r>
-              <a:rPr sz="800" b="0">
+              <a:rPr sz="1000" b="0" dirty="0">
                 <a:solidFill>
                   <a:srgbClr val="1F2937"/>
                 </a:solidFill>
@@ -5731,7 +5992,7 @@
           </a:fontRef>
         </p:style>
         <p:txBody>
-          <a:bodyPr wrap="square" tIns="27432" rtlCol="0" anchor="ctr" lIns="36576" rIns="36576" bIns="27432"/>
+          <a:bodyPr wrap="square" lIns="36576" tIns="27432" rIns="36576" bIns="27432" rtlCol="0" anchor="ctr"/>
           <a:lstStyle/>
           <a:p>
             <a:pPr algn="ctr">
@@ -5808,7 +6069,7 @@
           </a:fontRef>
         </p:style>
         <p:txBody>
-          <a:bodyPr wrap="square" tIns="27432" rtlCol="0" anchor="ctr" lIns="36576" rIns="36576" bIns="27432"/>
+          <a:bodyPr wrap="square" lIns="36576" tIns="27432" rIns="36576" bIns="27432" rtlCol="0" anchor="ctr"/>
           <a:lstStyle/>
           <a:p>
             <a:pPr algn="ctr">
@@ -5885,7 +6146,7 @@
           </a:fontRef>
         </p:style>
         <p:txBody>
-          <a:bodyPr wrap="square" tIns="27432" rtlCol="0" anchor="ctr" lIns="36576" rIns="36576" bIns="27432"/>
+          <a:bodyPr wrap="square" lIns="36576" tIns="27432" rIns="36576" bIns="27432" rtlCol="0" anchor="ctr"/>
           <a:lstStyle/>
           <a:p>
             <a:pPr algn="ctr">
@@ -5962,7 +6223,7 @@
           </a:fontRef>
         </p:style>
         <p:txBody>
-          <a:bodyPr wrap="square" tIns="27432" rtlCol="0" anchor="ctr" lIns="36576" rIns="36576" bIns="27432"/>
+          <a:bodyPr wrap="square" lIns="36576" tIns="27432" rIns="36576" bIns="27432" rtlCol="0" anchor="ctr"/>
           <a:lstStyle/>
           <a:p>
             <a:pPr algn="ctr">
@@ -6039,7 +6300,7 @@
           </a:fontRef>
         </p:style>
         <p:txBody>
-          <a:bodyPr wrap="square" tIns="27432" rtlCol="0" anchor="ctr" lIns="36576" rIns="36576" bIns="27432"/>
+          <a:bodyPr wrap="square" lIns="36576" tIns="27432" rIns="36576" bIns="27432" rtlCol="0" anchor="ctr"/>
           <a:lstStyle/>
           <a:p>
             <a:pPr algn="ctr">
@@ -6116,7 +6377,7 @@
           </a:fontRef>
         </p:style>
         <p:txBody>
-          <a:bodyPr wrap="square" tIns="27432" rtlCol="0" anchor="ctr" lIns="36576" rIns="36576" bIns="27432"/>
+          <a:bodyPr wrap="square" lIns="36576" tIns="27432" rIns="36576" bIns="27432" rtlCol="0" anchor="ctr"/>
           <a:lstStyle/>
           <a:p>
             <a:pPr algn="ctr">
@@ -6193,7 +6454,7 @@
           </a:fontRef>
         </p:style>
         <p:txBody>
-          <a:bodyPr wrap="square" tIns="27432" rtlCol="0" anchor="ctr" lIns="36576" rIns="36576" bIns="27432"/>
+          <a:bodyPr wrap="square" lIns="36576" tIns="27432" rIns="36576" bIns="27432" rtlCol="0" anchor="ctr"/>
           <a:lstStyle/>
           <a:p>
             <a:pPr algn="ctr">
@@ -6240,7 +6501,7 @@
         </p:nvSpPr>
         <p:spPr>
           <a:xfrm>
-            <a:off x="365760" y="5623560"/>
+            <a:off x="356616" y="5623560"/>
             <a:ext cx="2468880" cy="530352"/>
           </a:xfrm>
           <a:prstGeom prst="roundRect">
@@ -6270,7 +6531,7 @@
           </a:fontRef>
         </p:style>
         <p:txBody>
-          <a:bodyPr wrap="square" tIns="27432" rtlCol="0" anchor="ctr" lIns="36576" rIns="36576" bIns="27432"/>
+          <a:bodyPr wrap="square" lIns="36576" tIns="27432" rIns="36576" bIns="27432" rtlCol="0" anchor="ctr"/>
           <a:lstStyle/>
           <a:p>
             <a:pPr algn="ctr">
@@ -6282,7 +6543,7 @@
               </a:defRPr>
             </a:pPr>
             <a:r>
-              <a:rPr sz="850" b="1">
+              <a:rPr sz="850" b="1" dirty="0">
                 <a:solidFill>
                   <a:srgbClr val="973835"/>
                 </a:solidFill>
@@ -6298,7 +6559,7 @@
               </a:spcBef>
             </a:pPr>
             <a:r>
-              <a:rPr sz="720" b="0">
+              <a:rPr sz="720" b="0" dirty="0">
                 <a:solidFill>
                   <a:srgbClr val="4B5563"/>
                 </a:solidFill>
@@ -6391,7 +6652,7 @@
           </a:fontRef>
         </p:style>
         <p:txBody>
-          <a:bodyPr rtlCol="0" anchor="ctr" wrap="square" lIns="36576" rIns="36576" tIns="27432" bIns="27432"/>
+          <a:bodyPr wrap="square" lIns="36576" tIns="27432" rIns="36576" bIns="27432" rtlCol="0" anchor="ctr"/>
           <a:lstStyle/>
           <a:p>
             <a:pPr algn="l">
@@ -6452,7 +6713,7 @@
           </a:fontRef>
         </p:style>
         <p:txBody>
-          <a:bodyPr wrap="square" rtlCol="0" anchor="ctr" lIns="27432" rIns="27432" tIns="27432" bIns="27432"/>
+          <a:bodyPr wrap="square" lIns="27432" tIns="27432" rIns="27432" bIns="27432" rtlCol="0" anchor="ctr"/>
           <a:lstStyle/>
           <a:p>
             <a:pPr algn="ctr">
@@ -6467,7 +6728,7 @@
               </a:defRPr>
             </a:pPr>
             <a:r>
-              <a:rPr sz="819" b="1">
+              <a:rPr sz="1000" b="1" dirty="0">
                 <a:solidFill>
                   <a:srgbClr val="1E3A8A"/>
                 </a:solidFill>
@@ -6483,7 +6744,7 @@
               </a:spcAft>
             </a:pPr>
             <a:r>
-              <a:rPr sz="700" b="0">
+              <a:rPr sz="1000" b="0" dirty="0">
                 <a:solidFill>
                   <a:srgbClr val="1F2937"/>
                 </a:solidFill>
@@ -6499,7 +6760,7 @@
               </a:spcAft>
             </a:pPr>
             <a:r>
-              <a:rPr sz="700" b="0">
+              <a:rPr sz="1000" b="0" dirty="0">
                 <a:solidFill>
                   <a:srgbClr val="1F2937"/>
                 </a:solidFill>
@@ -6515,7 +6776,7 @@
               </a:spcAft>
             </a:pPr>
             <a:r>
-              <a:rPr sz="700" b="0">
+              <a:rPr sz="1000" b="0" dirty="0">
                 <a:solidFill>
                   <a:srgbClr val="1F2937"/>
                 </a:solidFill>
@@ -6564,7 +6825,7 @@
           </a:fontRef>
         </p:style>
         <p:txBody>
-          <a:bodyPr wrap="square" rtlCol="0" anchor="ctr" lIns="27432" rIns="27432" tIns="27432" bIns="27432"/>
+          <a:bodyPr wrap="square" lIns="27432" tIns="27432" rIns="27432" bIns="27432" rtlCol="0" anchor="ctr"/>
           <a:lstStyle/>
           <a:p>
             <a:pPr algn="ctr">
@@ -6579,7 +6840,7 @@
               </a:defRPr>
             </a:pPr>
             <a:r>
-              <a:rPr sz="819" b="1">
+              <a:rPr sz="1000" b="1" dirty="0">
                 <a:solidFill>
                   <a:srgbClr val="1E3A8A"/>
                 </a:solidFill>
@@ -6595,7 +6856,7 @@
               </a:spcAft>
             </a:pPr>
             <a:r>
-              <a:rPr sz="700" b="0">
+              <a:rPr sz="1000" b="0" dirty="0">
                 <a:solidFill>
                   <a:srgbClr val="1F2937"/>
                 </a:solidFill>
@@ -6611,7 +6872,7 @@
               </a:spcAft>
             </a:pPr>
             <a:r>
-              <a:rPr sz="700" b="0">
+              <a:rPr sz="1000" b="0" dirty="0">
                 <a:solidFill>
                   <a:srgbClr val="1F2937"/>
                 </a:solidFill>
@@ -6627,7 +6888,7 @@
               </a:spcAft>
             </a:pPr>
             <a:r>
-              <a:rPr sz="700" b="0">
+              <a:rPr sz="1000" b="0" dirty="0">
                 <a:solidFill>
                   <a:srgbClr val="1F2937"/>
                 </a:solidFill>
@@ -6676,7 +6937,7 @@
           </a:fontRef>
         </p:style>
         <p:txBody>
-          <a:bodyPr wrap="square" rtlCol="0" anchor="ctr" lIns="27432" rIns="27432" tIns="27432" bIns="27432"/>
+          <a:bodyPr wrap="square" lIns="27432" tIns="27432" rIns="27432" bIns="27432" rtlCol="0" anchor="ctr"/>
           <a:lstStyle/>
           <a:p>
             <a:pPr algn="ctr">
@@ -6691,7 +6952,7 @@
               </a:defRPr>
             </a:pPr>
             <a:r>
-              <a:rPr sz="819" b="1">
+              <a:rPr sz="1000" b="1" dirty="0">
                 <a:solidFill>
                   <a:srgbClr val="1E3A8A"/>
                 </a:solidFill>
@@ -6707,7 +6968,7 @@
               </a:spcAft>
             </a:pPr>
             <a:r>
-              <a:rPr sz="700" b="0">
+              <a:rPr sz="1000" b="0" dirty="0">
                 <a:solidFill>
                   <a:srgbClr val="1F2937"/>
                 </a:solidFill>
@@ -6723,7 +6984,7 @@
               </a:spcAft>
             </a:pPr>
             <a:r>
-              <a:rPr sz="700" b="0">
+              <a:rPr sz="1000" b="0" dirty="0">
                 <a:solidFill>
                   <a:srgbClr val="1F2937"/>
                 </a:solidFill>
@@ -6739,7 +7000,7 @@
               </a:spcAft>
             </a:pPr>
             <a:r>
-              <a:rPr sz="700" b="0">
+              <a:rPr sz="1000" b="0" dirty="0">
                 <a:solidFill>
                   <a:srgbClr val="1F2937"/>
                 </a:solidFill>
@@ -6788,7 +7049,7 @@
           </a:fontRef>
         </p:style>
         <p:txBody>
-          <a:bodyPr wrap="square" rtlCol="0" anchor="ctr" lIns="27432" rIns="27432" tIns="27432" bIns="27432"/>
+          <a:bodyPr wrap="square" lIns="27432" tIns="27432" rIns="27432" bIns="27432" rtlCol="0" anchor="ctr"/>
           <a:lstStyle/>
           <a:p>
             <a:pPr algn="ctr">
@@ -6803,7 +7064,7 @@
               </a:defRPr>
             </a:pPr>
             <a:r>
-              <a:rPr sz="819" b="1">
+              <a:rPr sz="1000" b="1" dirty="0">
                 <a:solidFill>
                   <a:srgbClr val="1E3A8A"/>
                 </a:solidFill>
@@ -6819,7 +7080,7 @@
               </a:spcAft>
             </a:pPr>
             <a:r>
-              <a:rPr sz="700" b="0">
+              <a:rPr sz="1000" b="0" dirty="0">
                 <a:solidFill>
                   <a:srgbClr val="1F2937"/>
                 </a:solidFill>
@@ -6835,7 +7096,7 @@
               </a:spcAft>
             </a:pPr>
             <a:r>
-              <a:rPr sz="700" b="0">
+              <a:rPr sz="1000" b="0" dirty="0">
                 <a:solidFill>
                   <a:srgbClr val="1F2937"/>
                 </a:solidFill>
@@ -6851,7 +7112,7 @@
               </a:spcAft>
             </a:pPr>
             <a:r>
-              <a:rPr sz="700" b="0">
+              <a:rPr sz="1000" b="0" dirty="0">
                 <a:solidFill>
                   <a:srgbClr val="1F2937"/>
                 </a:solidFill>
@@ -6944,7 +7205,7 @@
           </a:fontRef>
         </p:style>
         <p:txBody>
-          <a:bodyPr rtlCol="0" anchor="ctr" wrap="square" lIns="36576" rIns="36576" tIns="27432" bIns="27432"/>
+          <a:bodyPr wrap="square" lIns="36576" tIns="27432" rIns="36576" bIns="27432" rtlCol="0" anchor="ctr"/>
           <a:lstStyle/>
           <a:p>
             <a:pPr algn="l">
@@ -7005,7 +7266,7 @@
           </a:fontRef>
         </p:style>
         <p:txBody>
-          <a:bodyPr wrap="square" rtlCol="0" anchor="ctr" lIns="27432" rIns="27432" tIns="27432" bIns="27432"/>
+          <a:bodyPr wrap="square" lIns="27432" tIns="27432" rIns="27432" bIns="27432" rtlCol="0" anchor="ctr"/>
           <a:lstStyle/>
           <a:p>
             <a:pPr algn="ctr">
@@ -7020,7 +7281,7 @@
               </a:defRPr>
             </a:pPr>
             <a:r>
-              <a:rPr sz="819" b="1">
+              <a:rPr sz="1000" b="1" dirty="0">
                 <a:solidFill>
                   <a:srgbClr val="14532D"/>
                 </a:solidFill>
@@ -7036,7 +7297,7 @@
               </a:spcAft>
             </a:pPr>
             <a:r>
-              <a:rPr sz="700" b="0">
+              <a:rPr sz="1000" b="0" dirty="0">
                 <a:solidFill>
                   <a:srgbClr val="1F2937"/>
                 </a:solidFill>
@@ -7052,7 +7313,7 @@
               </a:spcAft>
             </a:pPr>
             <a:r>
-              <a:rPr sz="700" b="0">
+              <a:rPr sz="1000" b="0" dirty="0">
                 <a:solidFill>
                   <a:srgbClr val="1F2937"/>
                 </a:solidFill>
@@ -7068,7 +7329,7 @@
               </a:spcAft>
             </a:pPr>
             <a:r>
-              <a:rPr sz="700" b="0">
+              <a:rPr sz="1000" b="0" dirty="0">
                 <a:solidFill>
                   <a:srgbClr val="1F2937"/>
                 </a:solidFill>
@@ -7117,7 +7378,7 @@
           </a:fontRef>
         </p:style>
         <p:txBody>
-          <a:bodyPr wrap="square" rtlCol="0" anchor="ctr" lIns="27432" rIns="27432" tIns="27432" bIns="27432"/>
+          <a:bodyPr wrap="square" lIns="27432" tIns="27432" rIns="27432" bIns="27432" rtlCol="0" anchor="ctr"/>
           <a:lstStyle/>
           <a:p>
             <a:pPr algn="ctr">
@@ -7132,7 +7393,7 @@
               </a:defRPr>
             </a:pPr>
             <a:r>
-              <a:rPr sz="819" b="1">
+              <a:rPr sz="1000" b="1" dirty="0">
                 <a:solidFill>
                   <a:srgbClr val="14532D"/>
                 </a:solidFill>
@@ -7148,7 +7409,7 @@
               </a:spcAft>
             </a:pPr>
             <a:r>
-              <a:rPr sz="700" b="0">
+              <a:rPr sz="1000" b="0" dirty="0">
                 <a:solidFill>
                   <a:srgbClr val="1F2937"/>
                 </a:solidFill>
@@ -7164,7 +7425,7 @@
               </a:spcAft>
             </a:pPr>
             <a:r>
-              <a:rPr sz="700" b="0">
+              <a:rPr sz="1000" b="0" dirty="0">
                 <a:solidFill>
                   <a:srgbClr val="1F2937"/>
                 </a:solidFill>
@@ -7180,7 +7441,7 @@
               </a:spcAft>
             </a:pPr>
             <a:r>
-              <a:rPr sz="700" b="0">
+              <a:rPr sz="1000" b="0" dirty="0">
                 <a:solidFill>
                   <a:srgbClr val="1F2937"/>
                 </a:solidFill>
@@ -7229,7 +7490,7 @@
           </a:fontRef>
         </p:style>
         <p:txBody>
-          <a:bodyPr wrap="square" rtlCol="0" anchor="ctr" lIns="27432" rIns="27432" tIns="27432" bIns="27432"/>
+          <a:bodyPr wrap="square" lIns="27432" tIns="27432" rIns="27432" bIns="27432" rtlCol="0" anchor="ctr"/>
           <a:lstStyle/>
           <a:p>
             <a:pPr algn="ctr">
@@ -7244,13 +7505,22 @@
               </a:defRPr>
             </a:pPr>
             <a:r>
-              <a:rPr sz="819" b="1">
+              <a:rPr sz="1000" b="1" dirty="0" err="1">
                 <a:solidFill>
                   <a:srgbClr val="14532D"/>
                 </a:solidFill>
                 <a:latin typeface="Arial"/>
               </a:rPr>
-              <a:t>LoRaWAN Sensor Mesh</a:t>
+              <a:t>LoRaWAN</a:t>
+            </a:r>
+            <a:r>
+              <a:rPr sz="1000" b="1" dirty="0">
+                <a:solidFill>
+                  <a:srgbClr val="14532D"/>
+                </a:solidFill>
+                <a:latin typeface="Arial"/>
+              </a:rPr>
+              <a:t> Sensor Mesh</a:t>
             </a:r>
           </a:p>
           <a:p>
@@ -7260,7 +7530,7 @@
               </a:spcAft>
             </a:pPr>
             <a:r>
-              <a:rPr sz="700" b="0">
+              <a:rPr sz="1000" b="0" dirty="0">
                 <a:solidFill>
                   <a:srgbClr val="1F2937"/>
                 </a:solidFill>
@@ -7276,7 +7546,7 @@
               </a:spcAft>
             </a:pPr>
             <a:r>
-              <a:rPr sz="700" b="0">
+              <a:rPr sz="1000" b="0" dirty="0">
                 <a:solidFill>
                   <a:srgbClr val="1F2937"/>
                 </a:solidFill>
@@ -7292,7 +7562,7 @@
               </a:spcAft>
             </a:pPr>
             <a:r>
-              <a:rPr sz="700" b="0">
+              <a:rPr sz="1000" b="0" dirty="0">
                 <a:solidFill>
                   <a:srgbClr val="1F2937"/>
                 </a:solidFill>
@@ -7341,7 +7611,7 @@
           </a:fontRef>
         </p:style>
         <p:txBody>
-          <a:bodyPr wrap="square" rtlCol="0" anchor="ctr" lIns="27432" rIns="27432" tIns="27432" bIns="27432"/>
+          <a:bodyPr wrap="square" lIns="27432" tIns="27432" rIns="27432" bIns="27432" rtlCol="0" anchor="ctr"/>
           <a:lstStyle/>
           <a:p>
             <a:pPr algn="ctr">
@@ -7356,7 +7626,7 @@
               </a:defRPr>
             </a:pPr>
             <a:r>
-              <a:rPr sz="819" b="1">
+              <a:rPr sz="1000" b="1" dirty="0">
                 <a:solidFill>
                   <a:srgbClr val="14532D"/>
                 </a:solidFill>
@@ -7372,7 +7642,7 @@
               </a:spcAft>
             </a:pPr>
             <a:r>
-              <a:rPr sz="700" b="0">
+              <a:rPr sz="1000" b="0" dirty="0">
                 <a:solidFill>
                   <a:srgbClr val="1F2937"/>
                 </a:solidFill>
@@ -7388,7 +7658,7 @@
               </a:spcAft>
             </a:pPr>
             <a:r>
-              <a:rPr sz="700" b="0">
+              <a:rPr sz="1000" b="0" dirty="0">
                 <a:solidFill>
                   <a:srgbClr val="1F2937"/>
                 </a:solidFill>
@@ -7404,7 +7674,7 @@
               </a:spcAft>
             </a:pPr>
             <a:r>
-              <a:rPr sz="700" b="0">
+              <a:rPr sz="1000" b="0" dirty="0">
                 <a:solidFill>
                   <a:srgbClr val="1F2937"/>
                 </a:solidFill>
@@ -7497,7 +7767,7 @@
           </a:fontRef>
         </p:style>
         <p:txBody>
-          <a:bodyPr rtlCol="0" anchor="ctr" wrap="square" lIns="36576" rIns="36576" tIns="27432" bIns="27432"/>
+          <a:bodyPr wrap="square" lIns="36576" tIns="27432" rIns="36576" bIns="27432" rtlCol="0" anchor="ctr"/>
           <a:lstStyle/>
           <a:p>
             <a:pPr algn="ctr">
@@ -7558,7 +7828,7 @@
           </a:fontRef>
         </p:style>
         <p:txBody>
-          <a:bodyPr wrap="square" tIns="27432" rtlCol="0" anchor="ctr" lIns="36576" rIns="36576" bIns="27432"/>
+          <a:bodyPr wrap="square" lIns="36576" tIns="27432" rIns="36576" bIns="27432" rtlCol="0" anchor="ctr"/>
           <a:lstStyle/>
           <a:p>
             <a:pPr algn="ctr">
@@ -7570,7 +7840,7 @@
               </a:defRPr>
             </a:pPr>
             <a:r>
-              <a:rPr sz="819" b="1">
+              <a:rPr sz="1000" b="1" dirty="0">
                 <a:solidFill>
                   <a:srgbClr val="973835"/>
                 </a:solidFill>
@@ -7586,7 +7856,7 @@
               </a:spcBef>
             </a:pPr>
             <a:r>
-              <a:rPr sz="720" b="0">
+              <a:rPr sz="1000" b="0" dirty="0">
                 <a:solidFill>
                   <a:srgbClr val="1F2937"/>
                 </a:solidFill>
@@ -7635,7 +7905,7 @@
           </a:fontRef>
         </p:style>
         <p:txBody>
-          <a:bodyPr wrap="square" tIns="27432" rtlCol="0" anchor="ctr" lIns="36576" rIns="36576" bIns="27432"/>
+          <a:bodyPr wrap="square" lIns="36576" tIns="27432" rIns="36576" bIns="27432" rtlCol="0" anchor="ctr"/>
           <a:lstStyle/>
           <a:p>
             <a:pPr algn="ctr">
@@ -7647,7 +7917,7 @@
               </a:defRPr>
             </a:pPr>
             <a:r>
-              <a:rPr sz="819" b="1">
+              <a:rPr sz="1000" b="1" dirty="0">
                 <a:solidFill>
                   <a:srgbClr val="973835"/>
                 </a:solidFill>
@@ -7663,7 +7933,7 @@
               </a:spcBef>
             </a:pPr>
             <a:r>
-              <a:rPr sz="720" b="0">
+              <a:rPr sz="1000" b="0" dirty="0">
                 <a:solidFill>
                   <a:srgbClr val="1F2937"/>
                 </a:solidFill>
@@ -7712,7 +7982,7 @@
           </a:fontRef>
         </p:style>
         <p:txBody>
-          <a:bodyPr wrap="square" tIns="27432" rtlCol="0" anchor="ctr" lIns="36576" rIns="36576" bIns="27432"/>
+          <a:bodyPr wrap="square" lIns="36576" tIns="27432" rIns="36576" bIns="27432" rtlCol="0" anchor="ctr"/>
           <a:lstStyle/>
           <a:p>
             <a:pPr algn="ctr">
@@ -7724,7 +7994,7 @@
               </a:defRPr>
             </a:pPr>
             <a:r>
-              <a:rPr sz="819" b="1">
+              <a:rPr sz="1000" b="1" dirty="0">
                 <a:solidFill>
                   <a:srgbClr val="973835"/>
                 </a:solidFill>
@@ -7740,7 +8010,7 @@
               </a:spcBef>
             </a:pPr>
             <a:r>
-              <a:rPr sz="720" b="0">
+              <a:rPr sz="1000" b="0" dirty="0">
                 <a:solidFill>
                   <a:srgbClr val="1F2937"/>
                 </a:solidFill>
@@ -7759,8 +8029,8 @@
         </p:nvSpPr>
         <p:spPr>
           <a:xfrm>
-            <a:off x="9555480" y="4251960"/>
-            <a:ext cx="2194560" cy="749808"/>
+            <a:off x="9555480" y="4214470"/>
+            <a:ext cx="2194560" cy="824789"/>
           </a:xfrm>
           <a:prstGeom prst="roundRect">
             <a:avLst/>
@@ -7789,7 +8059,7 @@
           </a:fontRef>
         </p:style>
         <p:txBody>
-          <a:bodyPr wrap="square" tIns="27432" rtlCol="0" anchor="ctr" lIns="36576" rIns="36576" bIns="27432"/>
+          <a:bodyPr wrap="square" lIns="36576" tIns="27432" rIns="36576" bIns="27432" rtlCol="0" anchor="ctr"/>
           <a:lstStyle/>
           <a:p>
             <a:pPr algn="ctr">
@@ -7801,7 +8071,7 @@
               </a:defRPr>
             </a:pPr>
             <a:r>
-              <a:rPr sz="819" b="1">
+              <a:rPr sz="1000" b="1" dirty="0">
                 <a:solidFill>
                   <a:srgbClr val="973835"/>
                 </a:solidFill>
@@ -7817,7 +8087,7 @@
               </a:spcBef>
             </a:pPr>
             <a:r>
-              <a:rPr sz="720" b="0">
+              <a:rPr sz="1000" b="0" dirty="0">
                 <a:solidFill>
                   <a:srgbClr val="1F2937"/>
                 </a:solidFill>
@@ -7866,7 +8136,7 @@
           </a:fontRef>
         </p:style>
         <p:txBody>
-          <a:bodyPr wrap="square" tIns="27432" rtlCol="0" anchor="ctr" lIns="36576" rIns="36576" bIns="27432"/>
+          <a:bodyPr wrap="square" lIns="36576" tIns="27432" rIns="36576" bIns="27432" rtlCol="0" anchor="ctr"/>
           <a:lstStyle/>
           <a:p>
             <a:pPr algn="ctr">
@@ -7878,7 +8148,7 @@
               </a:defRPr>
             </a:pPr>
             <a:r>
-              <a:rPr sz="819" b="1">
+              <a:rPr sz="1000" b="1" dirty="0">
                 <a:solidFill>
                   <a:srgbClr val="973835"/>
                 </a:solidFill>
@@ -7894,7 +8164,7 @@
               </a:spcBef>
             </a:pPr>
             <a:r>
-              <a:rPr sz="720" b="0">
+              <a:rPr sz="1000" b="0" dirty="0">
                 <a:solidFill>
                   <a:srgbClr val="1F2937"/>
                 </a:solidFill>
@@ -8159,7 +8429,7 @@
           <a:noFill/>
         </p:spPr>
         <p:txBody>
-          <a:bodyPr wrap="square" lIns="36576" rIns="36576" tIns="27432" bIns="27432">
+          <a:bodyPr wrap="square" lIns="36576" tIns="27432" rIns="36576" bIns="27432">
             <a:spAutoFit/>
           </a:bodyPr>
           <a:lstStyle/>
@@ -8201,7 +8471,7 @@
           <a:noFill/>
         </p:spPr>
         <p:txBody>
-          <a:bodyPr wrap="square" lIns="36576" rIns="36576" tIns="27432" bIns="27432">
+          <a:bodyPr wrap="square" lIns="36576" tIns="27432" rIns="36576" bIns="27432">
             <a:spAutoFit/>
           </a:bodyPr>
           <a:lstStyle/>
@@ -8215,7 +8485,7 @@
               </a:defRPr>
             </a:pPr>
             <a:r>
-              <a:rPr sz="980" b="0">
+              <a:rPr sz="980" b="0" dirty="0">
                 <a:solidFill>
                   <a:srgbClr val="4B5563"/>
                 </a:solidFill>
@@ -8334,7 +8604,7 @@
         <p:spPr>
           <a:xfrm>
             <a:off x="502920" y="2176272"/>
-            <a:ext cx="3108960" cy="3931920"/>
+            <a:ext cx="3108960" cy="3393237"/>
           </a:xfrm>
           <a:prstGeom prst="rect">
             <a:avLst/>
@@ -8353,16 +8623,25 @@
               </a:spcAft>
             </a:pPr>
             <a:r>
-              <a:rPr sz="1000" b="1">
+              <a:rPr sz="1000" b="1" dirty="0">
                 <a:solidFill>
                   <a:srgbClr val="1E3A8A"/>
                 </a:solidFill>
                 <a:latin typeface="Arial"/>
               </a:rPr>
-              <a:t>• Zero-Download Web SPA: </a:t>
-            </a:r>
-            <a:r>
-              <a:rPr sz="900" b="0">
+              <a:t>•</a:t>
+            </a:r>
+            <a:r>
+              <a:rPr sz="1200" b="1" dirty="0">
+                <a:solidFill>
+                  <a:srgbClr val="1E3A8A"/>
+                </a:solidFill>
+                <a:latin typeface="Arial"/>
+              </a:rPr>
+              <a:t> Zero-Download Web SPA: </a:t>
+            </a:r>
+            <a:r>
+              <a:rPr sz="1200" b="0" dirty="0">
                 <a:solidFill>
                   <a:srgbClr val="1F2937"/>
                 </a:solidFill>
@@ -8378,7 +8657,7 @@
               </a:spcAft>
             </a:pPr>
             <a:r>
-              <a:rPr sz="1000" b="1">
+              <a:rPr sz="1200" b="1" dirty="0">
                 <a:solidFill>
                   <a:srgbClr val="1E3A8A"/>
                 </a:solidFill>
@@ -8387,7 +8666,7 @@
               <a:t>• Low-Bandwidth Edge Capability: </a:t>
             </a:r>
             <a:r>
-              <a:rPr sz="900" b="0">
+              <a:rPr sz="1200" b="0" dirty="0">
                 <a:solidFill>
                   <a:srgbClr val="1F2937"/>
                 </a:solidFill>
@@ -8403,7 +8682,7 @@
               </a:spcAft>
             </a:pPr>
             <a:r>
-              <a:rPr sz="1000" b="1">
+              <a:rPr sz="1200" b="1" dirty="0">
                 <a:solidFill>
                   <a:srgbClr val="1E3A8A"/>
                 </a:solidFill>
@@ -8412,13 +8691,31 @@
               <a:t>• Offline-Resilient Field Logging: </a:t>
             </a:r>
             <a:r>
-              <a:rPr sz="900" b="0">
+              <a:rPr sz="1200" b="0" dirty="0">
                 <a:solidFill>
                   <a:srgbClr val="1F2937"/>
                 </a:solidFill>
                 <a:latin typeface="Arial"/>
               </a:rPr>
-              <a:t>Field evidence photos and GPS coordinates store in IndexedDB local cache, syncing automatically when online.</a:t>
+              <a:t>Field evidence photos and GPS coordinates store in </a:t>
+            </a:r>
+            <a:r>
+              <a:rPr sz="1200" b="0" dirty="0" err="1">
+                <a:solidFill>
+                  <a:srgbClr val="1F2937"/>
+                </a:solidFill>
+                <a:latin typeface="Arial"/>
+              </a:rPr>
+              <a:t>IndexedDB</a:t>
+            </a:r>
+            <a:r>
+              <a:rPr sz="1200" b="0" dirty="0">
+                <a:solidFill>
+                  <a:srgbClr val="1F2937"/>
+                </a:solidFill>
+                <a:latin typeface="Arial"/>
+              </a:rPr>
+              <a:t> local cache, syncing automatically when online.</a:t>
             </a:r>
           </a:p>
           <a:p>
@@ -8428,7 +8725,7 @@
               </a:spcAft>
             </a:pPr>
             <a:r>
-              <a:rPr sz="1000" b="1">
+              <a:rPr sz="1200" b="1" dirty="0">
                 <a:solidFill>
                   <a:srgbClr val="1E3A8A"/>
                 </a:solidFill>
@@ -8437,13 +8734,22 @@
               <a:t>• Open Standards &amp; Modularity: </a:t>
             </a:r>
             <a:r>
-              <a:rPr sz="900" b="0">
+              <a:rPr sz="1200" b="0" dirty="0" err="1">
                 <a:solidFill>
                   <a:srgbClr val="1F2937"/>
                 </a:solidFill>
                 <a:latin typeface="Arial"/>
               </a:rPr>
-              <a:t>GeoJSON and WMS/WFS compatible with ISRO Bhuvan, CGWB, and National Watershed repositories.</a:t>
+              <a:t>GeoJSON</a:t>
+            </a:r>
+            <a:r>
+              <a:rPr sz="1200" b="0" dirty="0">
+                <a:solidFill>
+                  <a:srgbClr val="1F2937"/>
+                </a:solidFill>
+                <a:latin typeface="Arial"/>
+              </a:rPr>
+              <a:t> and WMS/WFS compatible with ISRO Bhuvan, CGWB, and National Watershed repositories.</a:t>
             </a:r>
           </a:p>
         </p:txBody>
@@ -8585,7 +8891,7 @@
           </a:fontRef>
         </p:style>
         <p:txBody>
-          <a:bodyPr wrap="square" tIns="27432" rtlCol="0" anchor="ctr" lIns="36576" rIns="36576" bIns="27432"/>
+          <a:bodyPr wrap="square" lIns="36576" tIns="27432" rIns="36576" bIns="27432" rtlCol="0" anchor="ctr"/>
           <a:lstStyle/>
           <a:p>
             <a:pPr algn="ctr">
@@ -8646,7 +8952,7 @@
           </a:fontRef>
         </p:style>
         <p:txBody>
-          <a:bodyPr wrap="square" tIns="27432" rtlCol="0" anchor="ctr" lIns="36576" rIns="36576" bIns="27432"/>
+          <a:bodyPr wrap="square" lIns="36576" tIns="27432" rIns="36576" bIns="27432" rtlCol="0" anchor="ctr"/>
           <a:lstStyle/>
           <a:p>
             <a:pPr algn="l">
@@ -8707,7 +9013,7 @@
           </a:fontRef>
         </p:style>
         <p:txBody>
-          <a:bodyPr wrap="square" tIns="27432" rtlCol="0" anchor="ctr" lIns="36576" rIns="36576" bIns="27432"/>
+          <a:bodyPr wrap="square" lIns="36576" tIns="27432" rIns="36576" bIns="27432" rtlCol="0" anchor="ctr"/>
           <a:lstStyle/>
           <a:p>
             <a:pPr algn="ctr">
@@ -8768,7 +9074,7 @@
           </a:fontRef>
         </p:style>
         <p:txBody>
-          <a:bodyPr wrap="square" tIns="27432" rtlCol="0" anchor="ctr" lIns="36576" rIns="36576" bIns="27432"/>
+          <a:bodyPr wrap="square" lIns="36576" tIns="27432" rIns="36576" bIns="27432" rtlCol="0" anchor="ctr"/>
           <a:lstStyle/>
           <a:p>
             <a:pPr algn="l">
@@ -8829,7 +9135,7 @@
           </a:fontRef>
         </p:style>
         <p:txBody>
-          <a:bodyPr wrap="square" tIns="27432" rtlCol="0" anchor="ctr" lIns="36576" rIns="36576" bIns="27432"/>
+          <a:bodyPr wrap="square" lIns="36576" tIns="27432" rIns="36576" bIns="27432" rtlCol="0" anchor="ctr"/>
           <a:lstStyle/>
           <a:p>
             <a:pPr algn="ctr">
@@ -8890,7 +9196,7 @@
           </a:fontRef>
         </p:style>
         <p:txBody>
-          <a:bodyPr wrap="square" tIns="27432" rtlCol="0" anchor="ctr" lIns="36576" rIns="36576" bIns="27432"/>
+          <a:bodyPr wrap="square" lIns="36576" tIns="27432" rIns="36576" bIns="27432" rtlCol="0" anchor="ctr"/>
           <a:lstStyle/>
           <a:p>
             <a:pPr algn="l">
@@ -8951,7 +9257,7 @@
           </a:fontRef>
         </p:style>
         <p:txBody>
-          <a:bodyPr wrap="square" tIns="27432" rtlCol="0" anchor="ctr" lIns="36576" rIns="36576" bIns="27432"/>
+          <a:bodyPr wrap="square" lIns="36576" tIns="27432" rIns="36576" bIns="27432" rtlCol="0" anchor="ctr"/>
           <a:lstStyle/>
           <a:p>
             <a:pPr algn="ctr">
@@ -9012,7 +9318,7 @@
           </a:fontRef>
         </p:style>
         <p:txBody>
-          <a:bodyPr wrap="square" tIns="27432" rtlCol="0" anchor="ctr" lIns="36576" rIns="36576" bIns="27432"/>
+          <a:bodyPr wrap="square" lIns="36576" tIns="27432" rIns="36576" bIns="27432" rtlCol="0" anchor="ctr"/>
           <a:lstStyle/>
           <a:p>
             <a:pPr algn="l">
@@ -9196,7 +9502,7 @@
         <p:spPr>
           <a:xfrm>
             <a:off x="9006840" y="2203704"/>
-            <a:ext cx="2651760" cy="731520"/>
+            <a:ext cx="2651760" cy="696601"/>
           </a:xfrm>
           <a:prstGeom prst="rect">
             <a:avLst/>
@@ -9204,7 +9510,7 @@
           <a:noFill/>
         </p:spPr>
         <p:txBody>
-          <a:bodyPr wrap="square" tIns="27432" lIns="36576" rIns="36576" bIns="27432">
+          <a:bodyPr wrap="square" lIns="36576" tIns="27432" rIns="36576" bIns="27432">
             <a:spAutoFit/>
           </a:bodyPr>
           <a:lstStyle/>
@@ -9218,7 +9524,7 @@
               </a:defRPr>
             </a:pPr>
             <a:r>
-              <a:rPr sz="900" b="1">
+              <a:rPr sz="1000" b="1" dirty="0">
                 <a:solidFill>
                   <a:srgbClr val="973835"/>
                 </a:solidFill>
@@ -9234,7 +9540,7 @@
               </a:spcBef>
             </a:pPr>
             <a:r>
-              <a:rPr sz="800" b="0">
+              <a:rPr sz="1000" b="0" dirty="0">
                 <a:solidFill>
                   <a:srgbClr val="1F2937"/>
                 </a:solidFill>
@@ -9307,7 +9613,7 @@
         <p:spPr>
           <a:xfrm>
             <a:off x="9006840" y="2980944"/>
-            <a:ext cx="2651760" cy="731520"/>
+            <a:ext cx="2651760" cy="696601"/>
           </a:xfrm>
           <a:prstGeom prst="rect">
             <a:avLst/>
@@ -9315,7 +9621,7 @@
           <a:noFill/>
         </p:spPr>
         <p:txBody>
-          <a:bodyPr wrap="square" tIns="27432" lIns="36576" rIns="36576" bIns="27432">
+          <a:bodyPr wrap="square" lIns="36576" tIns="27432" rIns="36576" bIns="27432">
             <a:spAutoFit/>
           </a:bodyPr>
           <a:lstStyle/>
@@ -9329,13 +9635,31 @@
               </a:defRPr>
             </a:pPr>
             <a:r>
-              <a:rPr sz="900" b="1">
+              <a:rPr sz="1000" b="1" dirty="0">
                 <a:solidFill>
                   <a:srgbClr val="973835"/>
                 </a:solidFill>
                 <a:latin typeface="Arial"/>
               </a:rPr>
-              <a:t>Immediate Deployability:</a:t>
+              <a:t>Immediate </a:t>
+            </a:r>
+            <a:r>
+              <a:rPr sz="1000" b="1" dirty="0" err="1">
+                <a:solidFill>
+                  <a:srgbClr val="973835"/>
+                </a:solidFill>
+                <a:latin typeface="Arial"/>
+              </a:rPr>
+              <a:t>Deployability</a:t>
+            </a:r>
+            <a:r>
+              <a:rPr sz="1000" b="1" dirty="0">
+                <a:solidFill>
+                  <a:srgbClr val="973835"/>
+                </a:solidFill>
+                <a:latin typeface="Arial"/>
+              </a:rPr>
+              <a:t>:</a:t>
             </a:r>
           </a:p>
           <a:p>
@@ -9345,7 +9669,7 @@
               </a:spcBef>
             </a:pPr>
             <a:r>
-              <a:rPr sz="800" b="0">
+              <a:rPr sz="1000" b="0" dirty="0">
                 <a:solidFill>
                   <a:srgbClr val="1F2937"/>
                 </a:solidFill>
@@ -9418,7 +9742,7 @@
         <p:spPr>
           <a:xfrm>
             <a:off x="9006840" y="3758184"/>
-            <a:ext cx="2651760" cy="731520"/>
+            <a:ext cx="2651760" cy="696601"/>
           </a:xfrm>
           <a:prstGeom prst="rect">
             <a:avLst/>
@@ -9426,7 +9750,7 @@
           <a:noFill/>
         </p:spPr>
         <p:txBody>
-          <a:bodyPr wrap="square" tIns="27432" lIns="36576" rIns="36576" bIns="27432">
+          <a:bodyPr wrap="square" lIns="36576" tIns="27432" rIns="36576" bIns="27432">
             <a:spAutoFit/>
           </a:bodyPr>
           <a:lstStyle/>
@@ -9440,7 +9764,7 @@
               </a:defRPr>
             </a:pPr>
             <a:r>
-              <a:rPr sz="900" b="1">
+              <a:rPr sz="1000" b="1" dirty="0">
                 <a:solidFill>
                   <a:srgbClr val="973835"/>
                 </a:solidFill>
@@ -9456,7 +9780,7 @@
               </a:spcBef>
             </a:pPr>
             <a:r>
-              <a:rPr sz="800" b="0">
+              <a:rPr sz="1000" b="0" dirty="0">
                 <a:solidFill>
                   <a:srgbClr val="1F2937"/>
                 </a:solidFill>
@@ -9529,7 +9853,7 @@
         <p:spPr>
           <a:xfrm>
             <a:off x="9006840" y="4535424"/>
-            <a:ext cx="2651760" cy="731520"/>
+            <a:ext cx="2651760" cy="696601"/>
           </a:xfrm>
           <a:prstGeom prst="rect">
             <a:avLst/>
@@ -9537,7 +9861,7 @@
           <a:noFill/>
         </p:spPr>
         <p:txBody>
-          <a:bodyPr wrap="square" tIns="27432" lIns="36576" rIns="36576" bIns="27432">
+          <a:bodyPr wrap="square" lIns="36576" tIns="27432" rIns="36576" bIns="27432">
             <a:spAutoFit/>
           </a:bodyPr>
           <a:lstStyle/>
@@ -9551,7 +9875,7 @@
               </a:defRPr>
             </a:pPr>
             <a:r>
-              <a:rPr sz="900" b="1">
+              <a:rPr sz="1000" b="1" dirty="0">
                 <a:solidFill>
                   <a:srgbClr val="973835"/>
                 </a:solidFill>
@@ -9567,7 +9891,7 @@
               </a:spcBef>
             </a:pPr>
             <a:r>
-              <a:rPr sz="800" b="0">
+              <a:rPr sz="1000" b="0" dirty="0">
                 <a:solidFill>
                   <a:srgbClr val="1F2937"/>
                 </a:solidFill>
@@ -9639,8 +9963,8 @@
         </p:nvSpPr>
         <p:spPr>
           <a:xfrm>
-            <a:off x="9006840" y="5312664"/>
-            <a:ext cx="2651760" cy="731520"/>
+            <a:off x="8961120" y="5303520"/>
+            <a:ext cx="2651760" cy="696601"/>
           </a:xfrm>
           <a:prstGeom prst="rect">
             <a:avLst/>
@@ -9648,7 +9972,7 @@
           <a:noFill/>
         </p:spPr>
         <p:txBody>
-          <a:bodyPr wrap="square" tIns="27432" lIns="36576" rIns="36576" bIns="27432">
+          <a:bodyPr wrap="square" lIns="36576" tIns="27432" rIns="36576" bIns="27432">
             <a:spAutoFit/>
           </a:bodyPr>
           <a:lstStyle/>
@@ -9662,7 +9986,7 @@
               </a:defRPr>
             </a:pPr>
             <a:r>
-              <a:rPr sz="900" b="1">
+              <a:rPr sz="1000" b="1" dirty="0">
                 <a:solidFill>
                   <a:srgbClr val="973835"/>
                 </a:solidFill>
@@ -9678,7 +10002,7 @@
               </a:spcBef>
             </a:pPr>
             <a:r>
-              <a:rPr sz="800" b="0">
+              <a:rPr sz="1000" b="0" dirty="0">
                 <a:solidFill>
                   <a:srgbClr val="1F2937"/>
                 </a:solidFill>
@@ -10000,7 +10324,7 @@
           </a:fontRef>
         </p:style>
         <p:txBody>
-          <a:bodyPr wrap="square" tIns="27432" rtlCol="0" anchor="ctr" lIns="36576" rIns="36576" bIns="27432"/>
+          <a:bodyPr wrap="square" lIns="36576" tIns="27432" rIns="36576" bIns="27432" rtlCol="0" anchor="ctr"/>
           <a:lstStyle/>
           <a:p>
             <a:pPr algn="ctr">
@@ -10012,7 +10336,7 @@
               </a:defRPr>
             </a:pPr>
             <a:r>
-              <a:rPr sz="950" b="1">
+              <a:rPr sz="1000" b="1" dirty="0">
                 <a:solidFill>
                   <a:srgbClr val="973835"/>
                 </a:solidFill>
@@ -10028,7 +10352,7 @@
               </a:spcBef>
             </a:pPr>
             <a:r>
-              <a:rPr sz="819" b="0">
+              <a:rPr sz="1000" b="0" dirty="0">
                 <a:solidFill>
                   <a:srgbClr val="1F2937"/>
                 </a:solidFill>
@@ -10077,7 +10401,7 @@
           </a:fontRef>
         </p:style>
         <p:txBody>
-          <a:bodyPr wrap="square" tIns="27432" rtlCol="0" anchor="ctr" lIns="36576" rIns="36576" bIns="27432"/>
+          <a:bodyPr wrap="square" lIns="36576" tIns="27432" rIns="36576" bIns="27432" rtlCol="0" anchor="ctr"/>
           <a:lstStyle/>
           <a:p>
             <a:pPr algn="ctr">
@@ -10089,7 +10413,7 @@
               </a:defRPr>
             </a:pPr>
             <a:r>
-              <a:rPr sz="950" b="1">
+              <a:rPr sz="1000" b="1" dirty="0">
                 <a:solidFill>
                   <a:srgbClr val="973835"/>
                 </a:solidFill>
@@ -10105,13 +10429,22 @@
               </a:spcBef>
             </a:pPr>
             <a:r>
-              <a:rPr sz="819" b="0">
+              <a:rPr sz="1000" b="0" dirty="0">
                 <a:solidFill>
                   <a:srgbClr val="1F2937"/>
                 </a:solidFill>
                 <a:latin typeface="Arial"/>
               </a:rPr>
-              <a:t>DEM slope &amp; runoff convergence algorithm scores optimal check-dam coordinates (0–100%).</a:t>
+              <a:t>DEM slope &amp; runoff convergence algorithm scores optimal check-dam coordinates (0–100%</a:t>
+            </a:r>
+            <a:r>
+              <a:rPr sz="819" b="0" dirty="0">
+                <a:solidFill>
+                  <a:srgbClr val="1F2937"/>
+                </a:solidFill>
+                <a:latin typeface="Arial"/>
+              </a:rPr>
+              <a:t>).</a:t>
             </a:r>
           </a:p>
         </p:txBody>
@@ -10124,7 +10457,7 @@
         </p:nvSpPr>
         <p:spPr>
           <a:xfrm>
-            <a:off x="365760" y="3310128"/>
+            <a:off x="411480" y="3282696"/>
             <a:ext cx="2926080" cy="877824"/>
           </a:xfrm>
           <a:prstGeom prst="roundRect">
@@ -10154,7 +10487,7 @@
           </a:fontRef>
         </p:style>
         <p:txBody>
-          <a:bodyPr wrap="square" tIns="27432" rtlCol="0" anchor="ctr" lIns="36576" rIns="36576" bIns="27432"/>
+          <a:bodyPr wrap="square" lIns="36576" tIns="27432" rIns="36576" bIns="27432" rtlCol="0" anchor="ctr"/>
           <a:lstStyle/>
           <a:p>
             <a:pPr algn="ctr">
@@ -10166,7 +10499,7 @@
               </a:defRPr>
             </a:pPr>
             <a:r>
-              <a:rPr sz="950" b="1">
+              <a:rPr sz="1000" b="1" dirty="0">
                 <a:solidFill>
                   <a:srgbClr val="973835"/>
                 </a:solidFill>
@@ -10182,7 +10515,7 @@
               </a:spcBef>
             </a:pPr>
             <a:r>
-              <a:rPr sz="819" b="0">
+              <a:rPr sz="1000" b="0" dirty="0">
                 <a:solidFill>
                   <a:srgbClr val="1F2937"/>
                 </a:solidFill>
@@ -10231,7 +10564,7 @@
           </a:fontRef>
         </p:style>
         <p:txBody>
-          <a:bodyPr wrap="square" tIns="27432" rtlCol="0" anchor="ctr" lIns="36576" rIns="36576" bIns="27432"/>
+          <a:bodyPr wrap="square" lIns="36576" tIns="27432" rIns="36576" bIns="27432" rtlCol="0" anchor="ctr"/>
           <a:lstStyle/>
           <a:p>
             <a:pPr algn="ctr">
@@ -10243,7 +10576,7 @@
               </a:defRPr>
             </a:pPr>
             <a:r>
-              <a:rPr sz="950" b="1">
+              <a:rPr sz="1000" b="1" dirty="0">
                 <a:solidFill>
                   <a:srgbClr val="973835"/>
                 </a:solidFill>
@@ -10259,7 +10592,7 @@
               </a:spcBef>
             </a:pPr>
             <a:r>
-              <a:rPr sz="819" b="0">
+              <a:rPr sz="1000" b="0" dirty="0">
                 <a:solidFill>
                   <a:srgbClr val="1F2937"/>
                 </a:solidFill>
@@ -10308,7 +10641,7 @@
           </a:fontRef>
         </p:style>
         <p:txBody>
-          <a:bodyPr wrap="square" tIns="27432" rtlCol="0" anchor="ctr" lIns="36576" rIns="36576" bIns="27432"/>
+          <a:bodyPr wrap="square" lIns="36576" tIns="27432" rIns="36576" bIns="27432" rtlCol="0" anchor="ctr"/>
           <a:lstStyle/>
           <a:p>
             <a:pPr algn="ctr">
@@ -10320,7 +10653,7 @@
               </a:defRPr>
             </a:pPr>
             <a:r>
-              <a:rPr sz="950" b="1">
+              <a:rPr sz="1000" b="1" dirty="0">
                 <a:solidFill>
                   <a:srgbClr val="973835"/>
                 </a:solidFill>
@@ -10336,13 +10669,22 @@
               </a:spcBef>
             </a:pPr>
             <a:r>
-              <a:rPr sz="819" b="0">
+              <a:rPr sz="1000" b="0" dirty="0" err="1">
                 <a:solidFill>
                   <a:srgbClr val="1F2937"/>
                 </a:solidFill>
                 <a:latin typeface="Arial"/>
               </a:rPr>
-              <a:t>LoRaWAN sensors &amp; Sentinel-2 satellite track groundwater recharge &amp; +144% farmer income.</a:t>
+              <a:t>LoRaWAN</a:t>
+            </a:r>
+            <a:r>
+              <a:rPr sz="1000" b="0" dirty="0">
+                <a:solidFill>
+                  <a:srgbClr val="1F2937"/>
+                </a:solidFill>
+                <a:latin typeface="Arial"/>
+              </a:rPr>
+              <a:t> sensors &amp; Sentinel-2 satellite track groundwater recharge &amp; +144% farmer income.</a:t>
             </a:r>
           </a:p>
         </p:txBody>
@@ -10465,7 +10807,7 @@
           </a:fontRef>
         </p:style>
         <p:txBody>
-          <a:bodyPr wrap="square" tIns="27432" rtlCol="0" anchor="ctr" lIns="36576" rIns="36576" bIns="27432"/>
+          <a:bodyPr wrap="square" lIns="36576" tIns="27432" rIns="36576" bIns="27432" rtlCol="0" anchor="ctr"/>
           <a:lstStyle/>
           <a:p>
             <a:pPr algn="ctr">
@@ -10497,7 +10839,7 @@
         <p:spPr>
           <a:xfrm>
             <a:off x="5394960" y="1408176"/>
-            <a:ext cx="3474720" cy="822960"/>
+            <a:ext cx="3474720" cy="753540"/>
           </a:xfrm>
           <a:prstGeom prst="rect">
             <a:avLst/>
@@ -10505,7 +10847,7 @@
           <a:noFill/>
         </p:spPr>
         <p:txBody>
-          <a:bodyPr wrap="square" tIns="36576" lIns="36576" rIns="36576" bIns="36576">
+          <a:bodyPr wrap="square" lIns="36576" tIns="36576" rIns="36576" bIns="36576">
             <a:spAutoFit/>
           </a:bodyPr>
           <a:lstStyle/>
@@ -10522,7 +10864,7 @@
               </a:defRPr>
             </a:pPr>
             <a:r>
-              <a:rPr sz="900" b="0">
+              <a:rPr sz="1000" b="0" dirty="0">
                 <a:solidFill>
                   <a:srgbClr val="1F2937"/>
                 </a:solidFill>
@@ -10538,7 +10880,7 @@
               </a:spcAft>
             </a:pPr>
             <a:r>
-              <a:rPr sz="900" b="0">
+              <a:rPr sz="1000" b="0" dirty="0">
                 <a:solidFill>
                   <a:srgbClr val="1F2937"/>
                 </a:solidFill>
@@ -10631,7 +10973,7 @@
           </a:fontRef>
         </p:style>
         <p:txBody>
-          <a:bodyPr wrap="square" tIns="27432" rtlCol="0" anchor="ctr" lIns="36576" rIns="36576" bIns="27432"/>
+          <a:bodyPr wrap="square" lIns="36576" tIns="27432" rIns="36576" bIns="27432" rtlCol="0" anchor="ctr"/>
           <a:lstStyle/>
           <a:p>
             <a:pPr algn="ctr">
@@ -10663,7 +11005,7 @@
         <p:spPr>
           <a:xfrm>
             <a:off x="5394960" y="2368296"/>
-            <a:ext cx="3474720" cy="822960"/>
+            <a:ext cx="3474720" cy="753540"/>
           </a:xfrm>
           <a:prstGeom prst="rect">
             <a:avLst/>
@@ -10671,7 +11013,7 @@
           <a:noFill/>
         </p:spPr>
         <p:txBody>
-          <a:bodyPr wrap="square" tIns="36576" lIns="36576" rIns="36576" bIns="36576">
+          <a:bodyPr wrap="square" lIns="36576" tIns="36576" rIns="36576" bIns="36576">
             <a:spAutoFit/>
           </a:bodyPr>
           <a:lstStyle/>
@@ -10688,7 +11030,7 @@
               </a:defRPr>
             </a:pPr>
             <a:r>
-              <a:rPr sz="900" b="0">
+              <a:rPr sz="1000" b="0" dirty="0">
                 <a:solidFill>
                   <a:srgbClr val="1F2937"/>
                 </a:solidFill>
@@ -10704,7 +11046,7 @@
               </a:spcAft>
             </a:pPr>
             <a:r>
-              <a:rPr sz="900" b="0">
+              <a:rPr sz="1000" b="0" dirty="0">
                 <a:solidFill>
                   <a:srgbClr val="1F2937"/>
                 </a:solidFill>
@@ -10797,7 +11139,7 @@
           </a:fontRef>
         </p:style>
         <p:txBody>
-          <a:bodyPr wrap="square" tIns="27432" rtlCol="0" anchor="ctr" lIns="36576" rIns="36576" bIns="27432"/>
+          <a:bodyPr wrap="square" lIns="36576" tIns="27432" rIns="36576" bIns="27432" rtlCol="0" anchor="ctr"/>
           <a:lstStyle/>
           <a:p>
             <a:pPr algn="ctr">
@@ -10829,7 +11171,7 @@
         <p:spPr>
           <a:xfrm>
             <a:off x="5394960" y="3328416"/>
-            <a:ext cx="3474720" cy="822960"/>
+            <a:ext cx="3474720" cy="753540"/>
           </a:xfrm>
           <a:prstGeom prst="rect">
             <a:avLst/>
@@ -10837,7 +11179,7 @@
           <a:noFill/>
         </p:spPr>
         <p:txBody>
-          <a:bodyPr wrap="square" tIns="36576" lIns="36576" rIns="36576" bIns="36576">
+          <a:bodyPr wrap="square" lIns="36576" tIns="36576" rIns="36576" bIns="36576">
             <a:spAutoFit/>
           </a:bodyPr>
           <a:lstStyle/>
@@ -10854,7 +11196,7 @@
               </a:defRPr>
             </a:pPr>
             <a:r>
-              <a:rPr sz="900" b="0">
+              <a:rPr sz="1000" b="0" dirty="0">
                 <a:solidFill>
                   <a:srgbClr val="1F2937"/>
                 </a:solidFill>
@@ -10870,7 +11212,7 @@
               </a:spcAft>
             </a:pPr>
             <a:r>
-              <a:rPr sz="900" b="0">
+              <a:rPr sz="1000" b="0" dirty="0">
                 <a:solidFill>
                   <a:srgbClr val="1F2937"/>
                 </a:solidFill>
@@ -10963,7 +11305,7 @@
           </a:fontRef>
         </p:style>
         <p:txBody>
-          <a:bodyPr wrap="square" tIns="27432" rtlCol="0" anchor="ctr" lIns="36576" rIns="36576" bIns="27432"/>
+          <a:bodyPr wrap="square" lIns="36576" tIns="27432" rIns="36576" bIns="27432" rtlCol="0" anchor="ctr"/>
           <a:lstStyle/>
           <a:p>
             <a:pPr algn="ctr">
@@ -10995,7 +11337,7 @@
         <p:spPr>
           <a:xfrm>
             <a:off x="5394960" y="4288536"/>
-            <a:ext cx="3474720" cy="822960"/>
+            <a:ext cx="3474720" cy="753540"/>
           </a:xfrm>
           <a:prstGeom prst="rect">
             <a:avLst/>
@@ -11003,7 +11345,7 @@
           <a:noFill/>
         </p:spPr>
         <p:txBody>
-          <a:bodyPr wrap="square" tIns="36576" lIns="36576" rIns="36576" bIns="36576">
+          <a:bodyPr wrap="square" lIns="36576" tIns="36576" rIns="36576" bIns="36576">
             <a:spAutoFit/>
           </a:bodyPr>
           <a:lstStyle/>
@@ -11020,7 +11362,7 @@
               </a:defRPr>
             </a:pPr>
             <a:r>
-              <a:rPr sz="900" b="0">
+              <a:rPr sz="1000" b="0" dirty="0">
                 <a:solidFill>
                   <a:srgbClr val="1F2937"/>
                 </a:solidFill>
@@ -11036,7 +11378,7 @@
               </a:spcAft>
             </a:pPr>
             <a:r>
-              <a:rPr sz="900" b="0">
+              <a:rPr sz="1000" b="0" dirty="0">
                 <a:solidFill>
                   <a:srgbClr val="1F2937"/>
                 </a:solidFill>
@@ -11129,7 +11471,7 @@
           </a:fontRef>
         </p:style>
         <p:txBody>
-          <a:bodyPr wrap="square" tIns="27432" rtlCol="0" anchor="ctr" lIns="36576" rIns="36576" bIns="27432"/>
+          <a:bodyPr wrap="square" lIns="36576" tIns="27432" rIns="36576" bIns="27432" rtlCol="0" anchor="ctr"/>
           <a:lstStyle/>
           <a:p>
             <a:pPr algn="ctr">
@@ -11161,7 +11503,7 @@
         <p:spPr>
           <a:xfrm>
             <a:off x="5394960" y="5248656"/>
-            <a:ext cx="3474720" cy="822960"/>
+            <a:ext cx="3474720" cy="753540"/>
           </a:xfrm>
           <a:prstGeom prst="rect">
             <a:avLst/>
@@ -11169,7 +11511,7 @@
           <a:noFill/>
         </p:spPr>
         <p:txBody>
-          <a:bodyPr wrap="square" tIns="36576" lIns="36576" rIns="36576" bIns="36576">
+          <a:bodyPr wrap="square" lIns="36576" tIns="36576" rIns="36576" bIns="36576">
             <a:spAutoFit/>
           </a:bodyPr>
           <a:lstStyle/>
@@ -11186,7 +11528,7 @@
               </a:defRPr>
             </a:pPr>
             <a:r>
-              <a:rPr sz="900" b="0">
+              <a:rPr sz="1000" b="0" dirty="0">
                 <a:solidFill>
                   <a:srgbClr val="1F2937"/>
                 </a:solidFill>
@@ -11202,7 +11544,7 @@
               </a:spcAft>
             </a:pPr>
             <a:r>
-              <a:rPr sz="900" b="0">
+              <a:rPr sz="1000" b="0" dirty="0">
                 <a:solidFill>
                   <a:srgbClr val="1F2937"/>
                 </a:solidFill>
@@ -11263,7 +11605,7 @@
               </a:defRPr>
             </a:pPr>
             <a:r>
-              <a:rPr sz="1200" b="1">
+              <a:rPr sz="1200" b="1" dirty="0">
                 <a:solidFill>
                   <a:srgbClr val="973835"/>
                 </a:solidFill>
@@ -11282,7 +11624,7 @@
               </a:spcAft>
             </a:pPr>
             <a:r>
-              <a:rPr sz="950" i="1">
+              <a:rPr sz="1200" i="1" dirty="0">
                 <a:solidFill>
                   <a:srgbClr val="1E3A8A"/>
                 </a:solidFill>
@@ -11298,7 +11640,7 @@
               </a:spcBef>
             </a:pPr>
             <a:r>
-              <a:rPr sz="980" b="1">
+              <a:rPr sz="1200" b="1" dirty="0">
                 <a:solidFill>
                   <a:srgbClr val="14532D"/>
                 </a:solidFill>
@@ -11307,7 +11649,7 @@
               <a:t>✓ +340% Water Retention  </a:t>
             </a:r>
             <a:r>
-              <a:rPr sz="819">
+              <a:rPr sz="1200" dirty="0">
                 <a:solidFill>
                   <a:srgbClr val="4B5563"/>
                 </a:solidFill>
@@ -11323,7 +11665,7 @@
               </a:spcBef>
             </a:pPr>
             <a:r>
-              <a:rPr sz="980" b="1">
+              <a:rPr sz="1200" b="1" dirty="0">
                 <a:solidFill>
                   <a:srgbClr val="14532D"/>
                 </a:solidFill>
@@ -11332,7 +11674,7 @@
               <a:t>✓ +3.5m Aquifer Rise  </a:t>
             </a:r>
             <a:r>
-              <a:rPr sz="819">
+              <a:rPr sz="1200" dirty="0">
                 <a:solidFill>
                   <a:srgbClr val="4B5563"/>
                 </a:solidFill>
@@ -11348,7 +11690,7 @@
               </a:spcBef>
             </a:pPr>
             <a:r>
-              <a:rPr sz="980" b="1">
+              <a:rPr sz="1200" b="1" dirty="0">
                 <a:solidFill>
                   <a:srgbClr val="14532D"/>
                 </a:solidFill>
@@ -11357,7 +11699,7 @@
               <a:t>✓ +144% Farmer Income  </a:t>
             </a:r>
             <a:r>
-              <a:rPr sz="819">
+              <a:rPr sz="1200" dirty="0">
                 <a:solidFill>
                   <a:srgbClr val="4B5563"/>
                 </a:solidFill>
@@ -11373,7 +11715,7 @@
               </a:spcBef>
             </a:pPr>
             <a:r>
-              <a:rPr sz="980" b="1">
+              <a:rPr sz="1200" b="1" dirty="0">
                 <a:solidFill>
                   <a:srgbClr val="14532D"/>
                 </a:solidFill>
@@ -11382,7 +11724,7 @@
               <a:t>✓ 82% Audit Cost Reduction  </a:t>
             </a:r>
             <a:r>
-              <a:rPr sz="819">
+              <a:rPr sz="1200" dirty="0">
                 <a:solidFill>
                   <a:srgbClr val="4B5563"/>
                 </a:solidFill>
@@ -11398,7 +11740,7 @@
               </a:spcBef>
             </a:pPr>
             <a:r>
-              <a:rPr sz="980" b="1">
+              <a:rPr sz="1200" b="1" dirty="0">
                 <a:solidFill>
                   <a:srgbClr val="14532D"/>
                 </a:solidFill>
@@ -11407,7 +11749,7 @@
               <a:t>✓ 100% Fraud Elimination  </a:t>
             </a:r>
             <a:r>
-              <a:rPr sz="819">
+              <a:rPr sz="1200" dirty="0">
                 <a:solidFill>
                   <a:srgbClr val="4B5563"/>
                 </a:solidFill>
@@ -11664,7 +12006,7 @@
         <p:spPr>
           <a:xfrm>
             <a:off x="365760" y="1051560"/>
-            <a:ext cx="11430000" cy="5120640"/>
+            <a:ext cx="11430000" cy="4916731"/>
           </a:xfrm>
           <a:prstGeom prst="rect">
             <a:avLst/>
@@ -11692,7 +12034,7 @@
               </a:defRPr>
             </a:pPr>
             <a:r>
-              <a:rPr sz="1200" b="1">
+              <a:rPr sz="1400" b="1" dirty="0">
                 <a:solidFill>
                   <a:srgbClr val="973835"/>
                 </a:solidFill>
@@ -11708,7 +12050,7 @@
               </a:spcAft>
             </a:pPr>
             <a:r>
-              <a:rPr sz="980" b="1">
+              <a:rPr sz="1400" b="1" dirty="0">
                 <a:solidFill>
                   <a:srgbClr val="000000"/>
                 </a:solidFill>
@@ -11717,7 +12059,7 @@
               <a:t>•  Central Ground Water Board (CGWB), Ministry of Jal Shakti: </a:t>
             </a:r>
             <a:r>
-              <a:rPr sz="950" b="0">
+              <a:rPr sz="1400" b="0" dirty="0">
                 <a:solidFill>
                   <a:srgbClr val="1F2937"/>
                 </a:solidFill>
@@ -11733,16 +12075,34 @@
               </a:spcAft>
             </a:pPr>
             <a:r>
-              <a:rPr sz="980" b="1">
+              <a:rPr sz="1400" b="1" dirty="0">
                 <a:solidFill>
                   <a:srgbClr val="000000"/>
                 </a:solidFill>
                 <a:latin typeface="Arial"/>
               </a:rPr>
-              <a:t>•  Pradhan Mantri Krishi Sinchayee Yojana (PMKSY - WDC): </a:t>
-            </a:r>
-            <a:r>
-              <a:rPr sz="950" b="0">
+              <a:t>•  Pradhan Mantri Krishi </a:t>
+            </a:r>
+            <a:r>
+              <a:rPr sz="1400" b="1" dirty="0" err="1">
+                <a:solidFill>
+                  <a:srgbClr val="000000"/>
+                </a:solidFill>
+                <a:latin typeface="Arial"/>
+              </a:rPr>
+              <a:t>Sinchayee</a:t>
+            </a:r>
+            <a:r>
+              <a:rPr sz="1400" b="1" dirty="0">
+                <a:solidFill>
+                  <a:srgbClr val="000000"/>
+                </a:solidFill>
+                <a:latin typeface="Arial"/>
+              </a:rPr>
+              <a:t> Yojana (PMKSY - WDC): </a:t>
+            </a:r>
+            <a:r>
+              <a:rPr sz="1400" b="0" dirty="0">
                 <a:solidFill>
                   <a:srgbClr val="1F2937"/>
                 </a:solidFill>
@@ -11758,7 +12118,7 @@
               </a:spcAft>
             </a:pPr>
             <a:r>
-              <a:rPr sz="980" b="1">
+              <a:rPr sz="1400" b="1" dirty="0">
                 <a:solidFill>
                   <a:srgbClr val="000000"/>
                 </a:solidFill>
@@ -11767,7 +12127,7 @@
               <a:t>•  Mission Amrit Sarovar &amp; Jal Jeevan Mission: </a:t>
             </a:r>
             <a:r>
-              <a:rPr sz="950" b="0">
+              <a:rPr sz="1400" b="0" dirty="0">
                 <a:solidFill>
                   <a:srgbClr val="1F2937"/>
                 </a:solidFill>
@@ -11783,7 +12143,7 @@
               </a:spcAft>
             </a:pPr>
             <a:r>
-              <a:rPr sz="980" b="1">
+              <a:rPr sz="1400" b="1" dirty="0">
                 <a:solidFill>
                   <a:srgbClr val="000000"/>
                 </a:solidFill>
@@ -11792,7 +12152,7 @@
               <a:t>•  Food and Agriculture Organization (FAO): </a:t>
             </a:r>
             <a:r>
-              <a:rPr sz="950" b="0">
+              <a:rPr sz="1400" b="0" dirty="0">
                 <a:solidFill>
                   <a:srgbClr val="1F2937"/>
                 </a:solidFill>
@@ -11811,7 +12171,7 @@
               </a:spcAft>
             </a:pPr>
             <a:r>
-              <a:rPr sz="1200" b="1">
+              <a:rPr sz="1400" b="1" dirty="0">
                 <a:solidFill>
                   <a:srgbClr val="973835"/>
                 </a:solidFill>
@@ -11827,7 +12187,7 @@
               </a:spcAft>
             </a:pPr>
             <a:r>
-              <a:rPr sz="980" b="1">
+              <a:rPr sz="1400" b="1" dirty="0">
                 <a:solidFill>
                   <a:srgbClr val="000000"/>
                 </a:solidFill>
@@ -11836,7 +12196,7 @@
               <a:t>•  USDA-NRCS: </a:t>
             </a:r>
             <a:r>
-              <a:rPr sz="950" b="0">
+              <a:rPr sz="1400" b="0" dirty="0">
                 <a:solidFill>
                   <a:srgbClr val="1F2937"/>
                 </a:solidFill>
@@ -11852,7 +12212,7 @@
               </a:spcAft>
             </a:pPr>
             <a:r>
-              <a:rPr sz="980" b="1">
+              <a:rPr sz="1400" b="1" dirty="0">
                 <a:solidFill>
                   <a:srgbClr val="000000"/>
                 </a:solidFill>
@@ -11861,7 +12221,7 @@
               <a:t>•  Strahler, A. N. (1957): </a:t>
             </a:r>
             <a:r>
-              <a:rPr sz="950" b="0">
+              <a:rPr sz="1400" b="0" dirty="0">
                 <a:solidFill>
                   <a:srgbClr val="1F2937"/>
                 </a:solidFill>
@@ -11877,7 +12237,7 @@
               </a:spcAft>
             </a:pPr>
             <a:r>
-              <a:rPr sz="980" b="1">
+              <a:rPr sz="1400" b="1" dirty="0">
                 <a:solidFill>
                   <a:srgbClr val="000000"/>
                 </a:solidFill>
@@ -11886,7 +12246,7 @@
               <a:t>•  European Space Agency (ESA Copernicus): </a:t>
             </a:r>
             <a:r>
-              <a:rPr sz="950" b="0">
+              <a:rPr sz="1400" b="0" dirty="0">
                 <a:solidFill>
                   <a:srgbClr val="1F2937"/>
                 </a:solidFill>
@@ -11902,7 +12262,7 @@
               </a:spcAft>
             </a:pPr>
             <a:r>
-              <a:rPr sz="980" b="1">
+              <a:rPr sz="1400" b="1" dirty="0">
                 <a:solidFill>
                   <a:srgbClr val="000000"/>
                 </a:solidFill>
@@ -11911,7 +12271,7 @@
               <a:t>•  ISRO &amp; NRSC: </a:t>
             </a:r>
             <a:r>
-              <a:rPr sz="950" b="0">
+              <a:rPr sz="1400" b="0" dirty="0">
                 <a:solidFill>
                   <a:srgbClr val="1F2937"/>
                 </a:solidFill>
@@ -11927,22 +12287,58 @@
               </a:spcAft>
             </a:pPr>
             <a:r>
-              <a:rPr sz="980" b="1">
+              <a:rPr sz="1400" b="1" dirty="0">
                 <a:solidFill>
                   <a:srgbClr val="000000"/>
                 </a:solidFill>
                 <a:latin typeface="Arial"/>
               </a:rPr>
-              <a:t>•  OpenFreeMap Project: </a:t>
-            </a:r>
-            <a:r>
-              <a:rPr sz="950" b="0">
+              <a:t>•  </a:t>
+            </a:r>
+            <a:r>
+              <a:rPr sz="1400" b="1" dirty="0" err="1">
+                <a:solidFill>
+                  <a:srgbClr val="000000"/>
+                </a:solidFill>
+                <a:latin typeface="Arial"/>
+              </a:rPr>
+              <a:t>OpenFreeMap</a:t>
+            </a:r>
+            <a:r>
+              <a:rPr sz="1400" b="1" dirty="0">
+                <a:solidFill>
+                  <a:srgbClr val="000000"/>
+                </a:solidFill>
+                <a:latin typeface="Arial"/>
+              </a:rPr>
+              <a:t> Project: </a:t>
+            </a:r>
+            <a:r>
+              <a:rPr sz="1400" b="0" dirty="0">
                 <a:solidFill>
                   <a:srgbClr val="1F2937"/>
                 </a:solidFill>
                 <a:latin typeface="Arial"/>
               </a:rPr>
-              <a:t>Open-source Vector Tile Topographical Schemas and MapLibre GL Cartography Engine.</a:t>
+              <a:t>Open-source Vector Tile Topographical Schemas and </a:t>
+            </a:r>
+            <a:r>
+              <a:rPr sz="1400" b="0" dirty="0" err="1">
+                <a:solidFill>
+                  <a:srgbClr val="1F2937"/>
+                </a:solidFill>
+                <a:latin typeface="Arial"/>
+              </a:rPr>
+              <a:t>MapLibre</a:t>
+            </a:r>
+            <a:r>
+              <a:rPr sz="1400" b="0" dirty="0">
+                <a:solidFill>
+                  <a:srgbClr val="1F2937"/>
+                </a:solidFill>
+                <a:latin typeface="Arial"/>
+              </a:rPr>
+              <a:t> GL Cartography Engine.</a:t>
             </a:r>
           </a:p>
           <a:p>
@@ -11955,7 +12351,7 @@
               </a:spcAft>
             </a:pPr>
             <a:r>
-              <a:rPr sz="1200" b="1">
+              <a:rPr sz="1400" b="1" dirty="0">
                 <a:solidFill>
                   <a:srgbClr val="973835"/>
                 </a:solidFill>
@@ -11971,7 +12367,7 @@
               </a:spcAft>
             </a:pPr>
             <a:r>
-              <a:rPr sz="980" b="1">
+              <a:rPr sz="1400" b="1" dirty="0">
                 <a:solidFill>
                   <a:srgbClr val="000000"/>
                 </a:solidFill>
@@ -11980,7 +12376,7 @@
               <a:t>•  Lukas et al. (IEEE TIFS): </a:t>
             </a:r>
             <a:r>
-              <a:rPr sz="950" b="0">
+              <a:rPr sz="1400" b="0" dirty="0">
                 <a:solidFill>
                   <a:srgbClr val="1F2937"/>
                 </a:solidFill>
@@ -11996,7 +12392,7 @@
               </a:spcAft>
             </a:pPr>
             <a:r>
-              <a:rPr sz="980" b="1">
+              <a:rPr sz="1400" b="1" dirty="0">
                 <a:solidFill>
                   <a:srgbClr val="000000"/>
                 </a:solidFill>
@@ -12005,7 +12401,7 @@
               <a:t>•  Corvi et al. (IEEE CVPR): </a:t>
             </a:r>
             <a:r>
-              <a:rPr sz="950" b="0">
+              <a:rPr sz="1400" b="0" dirty="0">
                 <a:solidFill>
                   <a:srgbClr val="1F2937"/>
                 </a:solidFill>
@@ -12021,7 +12417,7 @@
               </a:spcAft>
             </a:pPr>
             <a:r>
-              <a:rPr sz="980" b="1">
+              <a:rPr sz="1400" b="1" dirty="0">
                 <a:solidFill>
                   <a:srgbClr val="000000"/>
                 </a:solidFill>
@@ -12030,7 +12426,7 @@
               <a:t>•  NIST FIPS 180-4: </a:t>
             </a:r>
             <a:r>
-              <a:rPr sz="950" b="0">
+              <a:rPr sz="1400" b="0" dirty="0">
                 <a:solidFill>
                   <a:srgbClr val="1F2937"/>
                 </a:solidFill>
@@ -12046,7 +12442,7 @@
               </a:spcAft>
             </a:pPr>
             <a:r>
-              <a:rPr sz="980" b="1">
+              <a:rPr sz="1400" b="1" dirty="0">
                 <a:solidFill>
                   <a:srgbClr val="000000"/>
                 </a:solidFill>
@@ -12055,13 +12451,22 @@
               <a:t>•  LoRa Alliance: </a:t>
             </a:r>
             <a:r>
-              <a:rPr sz="950" b="0">
+              <a:rPr sz="1400" b="0" dirty="0" err="1">
                 <a:solidFill>
                   <a:srgbClr val="1F2937"/>
                 </a:solidFill>
                 <a:latin typeface="Arial"/>
               </a:rPr>
-              <a:t>LoRaWAN Link Layer Specification v1.0.4 for Long-Range Rural Micro-RTU Sensor Mesh Networks.</a:t>
+              <a:t>LoRaWAN</a:t>
+            </a:r>
+            <a:r>
+              <a:rPr sz="1400" b="0" dirty="0">
+                <a:solidFill>
+                  <a:srgbClr val="1F2937"/>
+                </a:solidFill>
+                <a:latin typeface="Arial"/>
+              </a:rPr>
+              <a:t> Link Layer Specification v1.0.4 for Long-Range Rural Micro-RTU Sensor Mesh Networks.</a:t>
             </a:r>
           </a:p>
         </p:txBody>

</xml_diff>